<commit_message>
Revise the expert deck: open with achievements, then background before positioning.
Slide 1 is now a one-page research-and-record intro. Slide 2 walks from the high-reliability data problem to the four constraints, and only then states the research position.

Co-authored-by: Ancha Xu <xuancha2011@aliyun.com>
</commit_message>
<xml_diff>
--- a/files/slides/research-intro-experts.pptx
+++ b/files/slides/research-intro-experts.pptx
@@ -506,7 +506,7 @@
           <a:lstStyle/>
           <a:p>
             <a:r>
-              <a:t>开场 30 秒。先报身份，再读中间那句研究定位，不要报奖项和论文篇数。四块只点名：退化建模、在线贝叶斯、客观贝叶斯、试验与现场。若专家是可靠性同行，可补一句：我们关心的不是再造一个过程，而是让过程可推断、可在线更新。</a:t>
+              <a:t>开场 1 分钟。先报姓名、单位、职称，再报四个研究方向。业绩只点三句：六十余篇一作通讯、一本专著、国自然青年加三项面上。奖项和服务各报一项即可：省自然科学奖、可靠性分会副理事长。不要把格子念完。下一页再讲为什么做这件事。</a:t>
             </a:r>
           </a:p>
         </p:txBody>
@@ -576,7 +576,7 @@
           <a:lstStyle/>
           <a:p>
             <a:r>
-              <a:t>这页只讲问题，不报论文。先说高可靠导致寿命试验失效太少，再强调退化轨迹是连续信息。四个约束各举半句现场例子即可：永磁制动器是小样本，重型机床是多指标，激光器常有个体差异，航空发动机是流式监测。右边四层从上往下讲一遍，收在：我们后面三页分别对应过程、推断、决策。</a:t>
+              <a:t>这页按三步讲，不要倒过来先报定位。第一步研究背景：高可靠导致寿命试验失效太少，退化轨迹成为主要信息。第二步四个困难各举半句现场例子：永磁制动器是小样本，重型机床是多指标，激光器常有个体差异，航空发动机是流式监测。第三步才读出定位那两句，并点名四条主线。后面三页分别展开过程、推断、评估。</a:t>
             </a:r>
           </a:p>
         </p:txBody>
@@ -786,7 +786,7 @@
           <a:lstStyle/>
           <a:p>
             <a:r>
-              <a:t>这页留给讨论。前两列各举一例：客观贝叶斯用屏蔽数据或加速试验；应用用永磁制动器或华为。开放问题按听者背景选一两个：理论专家谈偏态厚尾可识别性，应用专家谈现场外推的校准。底部数字只报一句，不要念完。最后停在“欢迎批评”。</a:t>
+              <a:t>这页留给讨论。前两列各举一例：客观贝叶斯用屏蔽数据或加速试验；应用用永磁制动器或华为。开放问题按听者背景选一两个：理论专家谈偏态厚尾可识别性，应用专家谈现场外推的校准。业绩已在第 1 页说过，这里不要再报数字。最后停在欢迎批评。</a:t>
             </a:r>
           </a:p>
         </p:txBody>
@@ -3801,7 +3801,7 @@
         <p:spPr>
           <a:xfrm>
             <a:off x="0" y="0"/>
-            <a:ext cx="164592" cy="6858000"/>
+            <a:ext cx="3246120" cy="6858000"/>
           </a:xfrm>
           <a:prstGeom prst="rect">
             <a:avLst/>
@@ -3836,50 +3836,30 @@
           </a:p>
         </p:txBody>
       </p:sp>
-      <p:sp>
-        <p:nvSpPr>
-          <p:cNvPr id="3" name="Rectangle 2"/>
-          <p:cNvSpPr/>
-          <p:nvPr/>
-        </p:nvSpPr>
-        <p:spPr>
-          <a:xfrm>
-            <a:off x="0" y="0"/>
-            <a:ext cx="12191695" cy="73152"/>
-          </a:xfrm>
-          <a:prstGeom prst="rect">
-            <a:avLst/>
-          </a:prstGeom>
-          <a:solidFill>
-            <a:srgbClr val="1B365D"/>
-          </a:solidFill>
-          <a:ln>
-            <a:noFill/>
-          </a:ln>
-          <a:effectLst/>
-        </p:spPr>
-        <p:style>
-          <a:lnRef idx="1">
-            <a:schemeClr val="accent1"/>
-          </a:lnRef>
-          <a:fillRef idx="3">
-            <a:schemeClr val="accent1"/>
-          </a:fillRef>
-          <a:effectRef idx="2">
-            <a:schemeClr val="accent1"/>
-          </a:effectRef>
-          <a:fontRef idx="minor">
-            <a:schemeClr val="lt1"/>
-          </a:fontRef>
-        </p:style>
-        <p:txBody>
-          <a:bodyPr rtlCol="0" anchor="ctr"/>
-          <a:lstStyle/>
-          <a:p>
-            <a:pPr algn="ctr"/>
-          </a:p>
-        </p:txBody>
-      </p:sp>
+      <p:pic>
+        <p:nvPicPr>
+          <p:cNvPr id="3" name="Picture 2" descr="research-intro-portrait.jpg"/>
+          <p:cNvPicPr>
+            <a:picLocks noChangeAspect="1"/>
+          </p:cNvPicPr>
+          <p:nvPr/>
+        </p:nvPicPr>
+        <p:blipFill>
+          <a:blip r:embed="rId2"/>
+          <a:stretch>
+            <a:fillRect/>
+          </a:stretch>
+        </p:blipFill>
+        <p:spPr>
+          <a:xfrm>
+            <a:off x="411480" y="365760"/>
+            <a:ext cx="2423160" cy="3063240"/>
+          </a:xfrm>
+          <a:prstGeom prst="rect">
+            <a:avLst/>
+          </a:prstGeom>
+        </p:spPr>
+      </p:pic>
       <p:sp>
         <p:nvSpPr>
           <p:cNvPr id="4" name="TextBox 3"/>
@@ -3888,8 +3868,8 @@
         </p:nvSpPr>
         <p:spPr>
           <a:xfrm>
-            <a:off x="640080" y="411480"/>
-            <a:ext cx="10972800" cy="292608"/>
+            <a:off x="320040" y="3566160"/>
+            <a:ext cx="2606040" cy="457200"/>
           </a:xfrm>
           <a:prstGeom prst="rect">
             <a:avLst/>
@@ -3900,7 +3880,7 @@
           <a:bodyPr wrap="square" lIns="54864" rIns="54864" tIns="18288" bIns="18288" anchor="t"/>
           <a:lstStyle/>
           <a:p>
-            <a:pPr algn="l">
+            <a:pPr algn="ctr">
               <a:lnSpc>
                 <a:spcPct val="115000"/>
               </a:lnSpc>
@@ -3909,14 +3889,14 @@
               </a:spcAft>
             </a:pPr>
             <a:r>
-              <a:rPr sz="1400" b="1">
-                <a:solidFill>
-                  <a:srgbClr val="A8452B"/>
-                </a:solidFill>
-                <a:latin typeface="微软雅黑"/>
-                <a:ea typeface="微软雅黑"/>
-              </a:rPr>
-              <a:t>研究工作简介  ·  同行专家交流</a:t>
+              <a:rPr sz="2600" b="1">
+                <a:solidFill>
+                  <a:srgbClr val="FFFFFF"/>
+                </a:solidFill>
+                <a:latin typeface="微软雅黑"/>
+                <a:ea typeface="微软雅黑"/>
+              </a:rPr>
+              <a:t>徐安察</a:t>
             </a:r>
           </a:p>
         </p:txBody>
@@ -3929,8 +3909,8 @@
         </p:nvSpPr>
         <p:spPr>
           <a:xfrm>
-            <a:off x="640080" y="914400"/>
-            <a:ext cx="10972800" cy="1371600"/>
+            <a:off x="256032" y="4041648"/>
+            <a:ext cx="2743200" cy="1234440"/>
           </a:xfrm>
           <a:prstGeom prst="rect">
             <a:avLst/>
@@ -3941,57 +3921,199 @@
           <a:bodyPr wrap="square" lIns="54864" rIns="54864" tIns="18288" bIns="18288" anchor="t"/>
           <a:lstStyle/>
           <a:p>
+            <a:pPr algn="ctr">
+              <a:lnSpc>
+                <a:spcPct val="115000"/>
+              </a:lnSpc>
+              <a:spcAft>
+                <a:spcPts val="600"/>
+              </a:spcAft>
+            </a:pPr>
+            <a:r>
+              <a:rPr sz="1400" b="1">
+                <a:solidFill>
+                  <a:srgbClr val="F0C4B0"/>
+                </a:solidFill>
+                <a:latin typeface="微软雅黑"/>
+                <a:ea typeface="微软雅黑"/>
+              </a:rPr>
+              <a:t>教授、博士生导师</a:t>
+            </a:r>
+          </a:p>
+          <a:p>
+            <a:pPr algn="ctr">
+              <a:lnSpc>
+                <a:spcPct val="115000"/>
+              </a:lnSpc>
+              <a:spcAft>
+                <a:spcPts val="200"/>
+              </a:spcAft>
+            </a:pPr>
+            <a:r>
+              <a:rPr sz="1300" b="0">
+                <a:solidFill>
+                  <a:srgbClr val="D7DEE7"/>
+                </a:solidFill>
+                <a:latin typeface="微软雅黑"/>
+                <a:ea typeface="微软雅黑"/>
+              </a:rPr>
+              <a:t>浙江工商大学</a:t>
+            </a:r>
+          </a:p>
+          <a:p>
+            <a:pPr algn="ctr">
+              <a:lnSpc>
+                <a:spcPct val="115000"/>
+              </a:lnSpc>
+              <a:spcAft>
+                <a:spcPts val="1000"/>
+              </a:spcAft>
+            </a:pPr>
+            <a:r>
+              <a:rPr sz="1300" b="0">
+                <a:solidFill>
+                  <a:srgbClr val="D7DEE7"/>
+                </a:solidFill>
+                <a:latin typeface="微软雅黑"/>
+                <a:ea typeface="微软雅黑"/>
+              </a:rPr>
+              <a:t>统计与数据科学学院</a:t>
+            </a:r>
+          </a:p>
+          <a:p>
+            <a:pPr algn="ctr">
+              <a:lnSpc>
+                <a:spcPct val="115000"/>
+              </a:lnSpc>
+              <a:spcAft>
+                <a:spcPts val="200"/>
+              </a:spcAft>
+            </a:pPr>
+            <a:r>
+              <a:rPr sz="1100" b="0">
+                <a:solidFill>
+                  <a:srgbClr val="B8C3D0"/>
+                </a:solidFill>
+                <a:latin typeface="微软雅黑"/>
+                <a:ea typeface="微软雅黑"/>
+              </a:rPr>
+              <a:t>xuancha@mail.zjgsu.edu.cn</a:t>
+            </a:r>
+          </a:p>
+          <a:p>
+            <a:pPr algn="ctr">
+              <a:lnSpc>
+                <a:spcPct val="115000"/>
+              </a:lnSpc>
+              <a:spcAft>
+                <a:spcPts val="0"/>
+              </a:spcAft>
+            </a:pPr>
+            <a:r>
+              <a:rPr sz="1100" b="0">
+                <a:solidFill>
+                  <a:srgbClr val="B8C3D0"/>
+                </a:solidFill>
+                <a:latin typeface="微软雅黑"/>
+                <a:ea typeface="微软雅黑"/>
+              </a:rPr>
+              <a:t>www.xu-ancha.com</a:t>
+            </a:r>
+          </a:p>
+        </p:txBody>
+      </p:sp>
+      <p:sp>
+        <p:nvSpPr>
+          <p:cNvPr id="6" name="TextBox 5"/>
+          <p:cNvSpPr txBox="1"/>
+          <p:nvPr/>
+        </p:nvSpPr>
+        <p:spPr>
+          <a:xfrm>
+            <a:off x="3520440" y="256032"/>
+            <a:ext cx="8229600" cy="237744"/>
+          </a:xfrm>
+          <a:prstGeom prst="rect">
+            <a:avLst/>
+          </a:prstGeom>
+          <a:noFill/>
+        </p:spPr>
+        <p:txBody>
+          <a:bodyPr wrap="square" lIns="54864" rIns="54864" tIns="18288" bIns="18288" anchor="t"/>
+          <a:lstStyle/>
+          <a:p>
             <a:pPr algn="l">
               <a:lnSpc>
                 <a:spcPct val="115000"/>
               </a:lnSpc>
               <a:spcAft>
-                <a:spcPts val="400"/>
-              </a:spcAft>
-            </a:pPr>
-            <a:r>
-              <a:rPr sz="3600" b="1">
+                <a:spcPts val="0"/>
+              </a:spcAft>
+            </a:pPr>
+            <a:r>
+              <a:rPr sz="1200" b="1">
+                <a:solidFill>
+                  <a:srgbClr val="A8452B"/>
+                </a:solidFill>
+                <a:latin typeface="微软雅黑"/>
+                <a:ea typeface="微软雅黑"/>
+              </a:rPr>
+              <a:t>研究工作简介  ·  同行专家交流</a:t>
+            </a:r>
+          </a:p>
+        </p:txBody>
+      </p:sp>
+      <p:sp>
+        <p:nvSpPr>
+          <p:cNvPr id="7" name="TextBox 6"/>
+          <p:cNvSpPr txBox="1"/>
+          <p:nvPr/>
+        </p:nvSpPr>
+        <p:spPr>
+          <a:xfrm>
+            <a:off x="3520440" y="493776"/>
+            <a:ext cx="8229600" cy="438912"/>
+          </a:xfrm>
+          <a:prstGeom prst="rect">
+            <a:avLst/>
+          </a:prstGeom>
+          <a:noFill/>
+        </p:spPr>
+        <p:txBody>
+          <a:bodyPr wrap="square" lIns="54864" rIns="54864" tIns="18288" bIns="18288" anchor="t"/>
+          <a:lstStyle/>
+          <a:p>
+            <a:pPr algn="l">
+              <a:lnSpc>
+                <a:spcPct val="115000"/>
+              </a:lnSpc>
+              <a:spcAft>
+                <a:spcPts val="0"/>
+              </a:spcAft>
+            </a:pPr>
+            <a:r>
+              <a:rPr sz="2800" b="1">
                 <a:solidFill>
                   <a:srgbClr val="1B365D"/>
                 </a:solidFill>
                 <a:latin typeface="微软雅黑"/>
                 <a:ea typeface="微软雅黑"/>
               </a:rPr>
-              <a:t>随机退化过程与</a:t>
-            </a:r>
-          </a:p>
-          <a:p>
-            <a:pPr algn="l">
-              <a:lnSpc>
-                <a:spcPct val="115000"/>
-              </a:lnSpc>
-              <a:spcAft>
-                <a:spcPts val="0"/>
-              </a:spcAft>
-            </a:pPr>
-            <a:r>
-              <a:rPr sz="3600" b="1">
-                <a:solidFill>
-                  <a:srgbClr val="1B365D"/>
-                </a:solidFill>
-                <a:latin typeface="微软雅黑"/>
-                <a:ea typeface="微软雅黑"/>
-              </a:rPr>
-              <a:t>贝叶斯可靠性推断</a:t>
-            </a:r>
-          </a:p>
-        </p:txBody>
-      </p:sp>
-      <p:sp>
-        <p:nvSpPr>
-          <p:cNvPr id="6" name="Rectangle 5"/>
+              <a:t>个人研究与业绩</a:t>
+            </a:r>
+          </a:p>
+        </p:txBody>
+      </p:sp>
+      <p:sp>
+        <p:nvSpPr>
+          <p:cNvPr id="8" name="Rectangle 7"/>
           <p:cNvSpPr/>
           <p:nvPr/>
         </p:nvSpPr>
         <p:spPr>
           <a:xfrm>
-            <a:off x="640080" y="2468880"/>
-            <a:ext cx="1280160" cy="45720"/>
+            <a:off x="3520440" y="969264"/>
+            <a:ext cx="1051560" cy="36576"/>
           </a:xfrm>
           <a:prstGeom prst="rect">
             <a:avLst/>
@@ -4028,14 +4150,14 @@
       </p:sp>
       <p:sp>
         <p:nvSpPr>
-          <p:cNvPr id="7" name="TextBox 6"/>
+          <p:cNvPr id="9" name="TextBox 8"/>
           <p:cNvSpPr txBox="1"/>
           <p:nvPr/>
         </p:nvSpPr>
         <p:spPr>
           <a:xfrm>
-            <a:off x="640080" y="2697480"/>
-            <a:ext cx="10789920" cy="822960"/>
+            <a:off x="3520440" y="1115568"/>
+            <a:ext cx="8229600" cy="219456"/>
           </a:xfrm>
           <a:prstGeom prst="rect">
             <a:avLst/>
@@ -4051,18 +4173,59 @@
                 <a:spcPct val="115000"/>
               </a:lnSpc>
               <a:spcAft>
-                <a:spcPts val="400"/>
-              </a:spcAft>
-            </a:pPr>
-            <a:r>
-              <a:rPr sz="1800" b="0">
+                <a:spcPts val="0"/>
+              </a:spcAft>
+            </a:pPr>
+            <a:r>
+              <a:rPr sz="1200" b="1">
+                <a:solidFill>
+                  <a:srgbClr val="A8452B"/>
+                </a:solidFill>
+                <a:latin typeface="微软雅黑"/>
+                <a:ea typeface="微软雅黑"/>
+              </a:rPr>
+              <a:t>研究方向</a:t>
+            </a:r>
+          </a:p>
+        </p:txBody>
+      </p:sp>
+      <p:sp>
+        <p:nvSpPr>
+          <p:cNvPr id="10" name="TextBox 9"/>
+          <p:cNvSpPr txBox="1"/>
+          <p:nvPr/>
+        </p:nvSpPr>
+        <p:spPr>
+          <a:xfrm>
+            <a:off x="3520440" y="1335024"/>
+            <a:ext cx="8229600" cy="640080"/>
+          </a:xfrm>
+          <a:prstGeom prst="rect">
+            <a:avLst/>
+          </a:prstGeom>
+          <a:noFill/>
+        </p:spPr>
+        <p:txBody>
+          <a:bodyPr wrap="square" lIns="54864" rIns="54864" tIns="18288" bIns="18288" anchor="t"/>
+          <a:lstStyle/>
+          <a:p>
+            <a:pPr algn="l">
+              <a:lnSpc>
+                <a:spcPct val="115000"/>
+              </a:lnSpc>
+              <a:spcAft>
+                <a:spcPts val="200"/>
+              </a:spcAft>
+            </a:pPr>
+            <a:r>
+              <a:rPr sz="1600" b="0">
                 <a:solidFill>
                   <a:srgbClr val="1C1C1C"/>
                 </a:solidFill>
                 <a:latin typeface="微软雅黑"/>
                 <a:ea typeface="微软雅黑"/>
               </a:rPr>
-              <a:t>用随机过程与贝叶斯方法，从退化监测数据和寿命数据中</a:t>
+              <a:t>退化数据分析与建模  ·  贝叶斯在线学习</a:t>
             </a:r>
           </a:p>
           <a:p>
@@ -4075,28 +4238,28 @@
               </a:spcAft>
             </a:pPr>
             <a:r>
-              <a:rPr sz="1800" b="0">
+              <a:rPr sz="1600" b="0">
                 <a:solidFill>
                   <a:srgbClr val="1C1C1C"/>
                 </a:solidFill>
                 <a:latin typeface="微软雅黑"/>
                 <a:ea typeface="微软雅黑"/>
               </a:rPr>
-              <a:t>评估高可靠产品的可靠性，并给出可递归更新的剩余寿命预测。</a:t>
-            </a:r>
-          </a:p>
-        </p:txBody>
-      </p:sp>
-      <p:sp>
-        <p:nvSpPr>
-          <p:cNvPr id="8" name="Rectangle 7"/>
+              <a:t>客观贝叶斯方法  ·  寿命数据分析</a:t>
+            </a:r>
+          </a:p>
+        </p:txBody>
+      </p:sp>
+      <p:sp>
+        <p:nvSpPr>
+          <p:cNvPr id="11" name="Rectangle 10"/>
           <p:cNvSpPr/>
           <p:nvPr/>
         </p:nvSpPr>
         <p:spPr>
           <a:xfrm>
-            <a:off x="640080" y="3794760"/>
-            <a:ext cx="2606040" cy="1691640"/>
+            <a:off x="3520440" y="2084831"/>
+            <a:ext cx="1975104" cy="960120"/>
           </a:xfrm>
           <a:prstGeom prst="rect">
             <a:avLst/>
@@ -4135,14 +4298,14 @@
       </p:sp>
       <p:sp>
         <p:nvSpPr>
-          <p:cNvPr id="9" name="TextBox 8"/>
+          <p:cNvPr id="12" name="TextBox 11"/>
           <p:cNvSpPr txBox="1"/>
           <p:nvPr/>
         </p:nvSpPr>
         <p:spPr>
           <a:xfrm>
-            <a:off x="786384" y="3904488"/>
-            <a:ext cx="2350008" cy="256032"/>
+            <a:off x="3520440" y="2139696"/>
+            <a:ext cx="1975104" cy="438912"/>
           </a:xfrm>
           <a:prstGeom prst="rect">
             <a:avLst/>
@@ -4153,7 +4316,7 @@
           <a:bodyPr wrap="square" lIns="54864" rIns="54864" tIns="18288" bIns="18288" anchor="t"/>
           <a:lstStyle/>
           <a:p>
-            <a:pPr algn="l">
+            <a:pPr algn="ctr">
               <a:lnSpc>
                 <a:spcPct val="115000"/>
               </a:lnSpc>
@@ -4162,28 +4325,28 @@
               </a:spcAft>
             </a:pPr>
             <a:r>
-              <a:rPr sz="1200" b="1">
-                <a:solidFill>
-                  <a:srgbClr val="A8452B"/>
-                </a:solidFill>
-                <a:latin typeface="微软雅黑"/>
-                <a:ea typeface="微软雅黑"/>
-              </a:rPr>
-              <a:t>01</a:t>
-            </a:r>
-          </a:p>
-        </p:txBody>
-      </p:sp>
-      <p:sp>
-        <p:nvSpPr>
-          <p:cNvPr id="10" name="TextBox 9"/>
+              <a:rPr sz="2200" b="1">
+                <a:solidFill>
+                  <a:srgbClr val="1B365D"/>
+                </a:solidFill>
+                <a:latin typeface="微软雅黑"/>
+                <a:ea typeface="微软雅黑"/>
+              </a:rPr>
+              <a:t>60+</a:t>
+            </a:r>
+          </a:p>
+        </p:txBody>
+      </p:sp>
+      <p:sp>
+        <p:nvSpPr>
+          <p:cNvPr id="13" name="TextBox 12"/>
           <p:cNvSpPr txBox="1"/>
           <p:nvPr/>
         </p:nvSpPr>
         <p:spPr>
           <a:xfrm>
-            <a:off x="786384" y="4160520"/>
-            <a:ext cx="2350008" cy="329184"/>
+            <a:off x="3520440" y="2578608"/>
+            <a:ext cx="1975104" cy="365760"/>
           </a:xfrm>
           <a:prstGeom prst="rect">
             <a:avLst/>
@@ -4194,7 +4357,7 @@
           <a:bodyPr wrap="square" lIns="54864" rIns="54864" tIns="18288" bIns="18288" anchor="t"/>
           <a:lstStyle/>
           <a:p>
-            <a:pPr algn="l">
+            <a:pPr algn="ctr">
               <a:lnSpc>
                 <a:spcPct val="115000"/>
               </a:lnSpc>
@@ -4203,70 +4366,28 @@
               </a:spcAft>
             </a:pPr>
             <a:r>
-              <a:rPr sz="1600" b="1">
-                <a:solidFill>
-                  <a:srgbClr val="1B365D"/>
-                </a:solidFill>
-                <a:latin typeface="微软雅黑"/>
-                <a:ea typeface="微软雅黑"/>
-              </a:rPr>
-              <a:t>退化建模</a:t>
-            </a:r>
-          </a:p>
-        </p:txBody>
-      </p:sp>
-      <p:sp>
-        <p:nvSpPr>
-          <p:cNvPr id="11" name="TextBox 10"/>
-          <p:cNvSpPr txBox="1"/>
-          <p:nvPr/>
-        </p:nvSpPr>
-        <p:spPr>
-          <a:xfrm>
-            <a:off x="786384" y="4544568"/>
-            <a:ext cx="2350008" cy="777240"/>
-          </a:xfrm>
-          <a:prstGeom prst="rect">
-            <a:avLst/>
-          </a:prstGeom>
-          <a:noFill/>
-        </p:spPr>
-        <p:txBody>
-          <a:bodyPr wrap="square" lIns="54864" rIns="54864" tIns="18288" bIns="18288" anchor="t"/>
-          <a:lstStyle/>
-          <a:p>
-            <a:pPr algn="l">
-              <a:lnSpc>
-                <a:spcPct val="115000"/>
-              </a:lnSpc>
-              <a:spcAft>
-                <a:spcPts val="0"/>
-              </a:spcAft>
-            </a:pPr>
-            <a:r>
-              <a:rPr sz="1300" b="0">
+              <a:rPr sz="1100" b="0">
                 <a:solidFill>
                   <a:srgbClr val="5A646E"/>
                 </a:solidFill>
                 <a:latin typeface="微软雅黑"/>
                 <a:ea typeface="微软雅黑"/>
               </a:rPr>
-              <a:t>Wiener / IG / Gamma
-多元 · 两阶段 · 厚尾</a:t>
-            </a:r>
-          </a:p>
-        </p:txBody>
-      </p:sp>
-      <p:sp>
-        <p:nvSpPr>
-          <p:cNvPr id="12" name="Rectangle 11"/>
+              <a:t>一作 / 通讯 SCI</a:t>
+            </a:r>
+          </a:p>
+        </p:txBody>
+      </p:sp>
+      <p:sp>
+        <p:nvSpPr>
+          <p:cNvPr id="14" name="Rectangle 13"/>
           <p:cNvSpPr/>
           <p:nvPr/>
         </p:nvSpPr>
         <p:spPr>
           <a:xfrm>
-            <a:off x="3410712" y="3794760"/>
-            <a:ext cx="2606040" cy="1691640"/>
+            <a:off x="5605271" y="2084831"/>
+            <a:ext cx="1975104" cy="960120"/>
           </a:xfrm>
           <a:prstGeom prst="rect">
             <a:avLst/>
@@ -4305,96 +4426,14 @@
       </p:sp>
       <p:sp>
         <p:nvSpPr>
-          <p:cNvPr id="13" name="TextBox 12"/>
-          <p:cNvSpPr txBox="1"/>
-          <p:nvPr/>
-        </p:nvSpPr>
-        <p:spPr>
-          <a:xfrm>
-            <a:off x="3557016" y="3904488"/>
-            <a:ext cx="2350008" cy="256032"/>
-          </a:xfrm>
-          <a:prstGeom prst="rect">
-            <a:avLst/>
-          </a:prstGeom>
-          <a:noFill/>
-        </p:spPr>
-        <p:txBody>
-          <a:bodyPr wrap="square" lIns="54864" rIns="54864" tIns="18288" bIns="18288" anchor="t"/>
-          <a:lstStyle/>
-          <a:p>
-            <a:pPr algn="l">
-              <a:lnSpc>
-                <a:spcPct val="115000"/>
-              </a:lnSpc>
-              <a:spcAft>
-                <a:spcPts val="0"/>
-              </a:spcAft>
-            </a:pPr>
-            <a:r>
-              <a:rPr sz="1200" b="1">
-                <a:solidFill>
-                  <a:srgbClr val="A8452B"/>
-                </a:solidFill>
-                <a:latin typeface="微软雅黑"/>
-                <a:ea typeface="微软雅黑"/>
-              </a:rPr>
-              <a:t>02</a:t>
-            </a:r>
-          </a:p>
-        </p:txBody>
-      </p:sp>
-      <p:sp>
-        <p:nvSpPr>
-          <p:cNvPr id="14" name="TextBox 13"/>
-          <p:cNvSpPr txBox="1"/>
-          <p:nvPr/>
-        </p:nvSpPr>
-        <p:spPr>
-          <a:xfrm>
-            <a:off x="3557016" y="4160520"/>
-            <a:ext cx="2350008" cy="329184"/>
-          </a:xfrm>
-          <a:prstGeom prst="rect">
-            <a:avLst/>
-          </a:prstGeom>
-          <a:noFill/>
-        </p:spPr>
-        <p:txBody>
-          <a:bodyPr wrap="square" lIns="54864" rIns="54864" tIns="18288" bIns="18288" anchor="t"/>
-          <a:lstStyle/>
-          <a:p>
-            <a:pPr algn="l">
-              <a:lnSpc>
-                <a:spcPct val="115000"/>
-              </a:lnSpc>
-              <a:spcAft>
-                <a:spcPts val="0"/>
-              </a:spcAft>
-            </a:pPr>
-            <a:r>
-              <a:rPr sz="1600" b="1">
-                <a:solidFill>
-                  <a:srgbClr val="1B365D"/>
-                </a:solidFill>
-                <a:latin typeface="微软雅黑"/>
-                <a:ea typeface="微软雅黑"/>
-              </a:rPr>
-              <a:t>在线贝叶斯</a:t>
-            </a:r>
-          </a:p>
-        </p:txBody>
-      </p:sp>
-      <p:sp>
-        <p:nvSpPr>
           <p:cNvPr id="15" name="TextBox 14"/>
           <p:cNvSpPr txBox="1"/>
           <p:nvPr/>
         </p:nvSpPr>
         <p:spPr>
           <a:xfrm>
-            <a:off x="3557016" y="4544568"/>
-            <a:ext cx="2350008" cy="777240"/>
+            <a:off x="5605271" y="2139696"/>
+            <a:ext cx="1975104" cy="438912"/>
           </a:xfrm>
           <a:prstGeom prst="rect">
             <a:avLst/>
@@ -4405,7 +4444,7 @@
           <a:bodyPr wrap="square" lIns="54864" rIns="54864" tIns="18288" bIns="18288" anchor="t"/>
           <a:lstStyle/>
           <a:p>
-            <a:pPr algn="l">
+            <a:pPr algn="ctr">
               <a:lnSpc>
                 <a:spcPct val="115000"/>
               </a:lnSpc>
@@ -4414,29 +4453,69 @@
               </a:spcAft>
             </a:pPr>
             <a:r>
-              <a:rPr sz="1300" b="0">
+              <a:rPr sz="2200" b="1">
+                <a:solidFill>
+                  <a:srgbClr val="1B365D"/>
+                </a:solidFill>
+                <a:latin typeface="微软雅黑"/>
+                <a:ea typeface="微软雅黑"/>
+              </a:rPr>
+              <a:t>2,478</a:t>
+            </a:r>
+          </a:p>
+        </p:txBody>
+      </p:sp>
+      <p:sp>
+        <p:nvSpPr>
+          <p:cNvPr id="16" name="TextBox 15"/>
+          <p:cNvSpPr txBox="1"/>
+          <p:nvPr/>
+        </p:nvSpPr>
+        <p:spPr>
+          <a:xfrm>
+            <a:off x="5605271" y="2578608"/>
+            <a:ext cx="1975104" cy="365760"/>
+          </a:xfrm>
+          <a:prstGeom prst="rect">
+            <a:avLst/>
+          </a:prstGeom>
+          <a:noFill/>
+        </p:spPr>
+        <p:txBody>
+          <a:bodyPr wrap="square" lIns="54864" rIns="54864" tIns="18288" bIns="18288" anchor="t"/>
+          <a:lstStyle/>
+          <a:p>
+            <a:pPr algn="ctr">
+              <a:lnSpc>
+                <a:spcPct val="115000"/>
+              </a:lnSpc>
+              <a:spcAft>
+                <a:spcPts val="0"/>
+              </a:spcAft>
+            </a:pPr>
+            <a:r>
+              <a:rPr sz="1100" b="0">
                 <a:solidFill>
                   <a:srgbClr val="5A646E"/>
                 </a:solidFill>
                 <a:latin typeface="微软雅黑"/>
                 <a:ea typeface="微软雅黑"/>
               </a:rPr>
-              <a:t>共轭结构与递归更新
-RUL 与隐状态识别</a:t>
-            </a:r>
-          </a:p>
-        </p:txBody>
-      </p:sp>
-      <p:sp>
-        <p:nvSpPr>
-          <p:cNvPr id="16" name="Rectangle 15"/>
+              <a:t>Google Scholar 引用</a:t>
+            </a:r>
+          </a:p>
+        </p:txBody>
+      </p:sp>
+      <p:sp>
+        <p:nvSpPr>
+          <p:cNvPr id="17" name="Rectangle 16"/>
           <p:cNvSpPr/>
           <p:nvPr/>
         </p:nvSpPr>
         <p:spPr>
           <a:xfrm>
-            <a:off x="6181344" y="3794760"/>
-            <a:ext cx="2606040" cy="1691640"/>
+            <a:off x="7690102" y="2084831"/>
+            <a:ext cx="1975104" cy="960120"/>
           </a:xfrm>
           <a:prstGeom prst="rect">
             <a:avLst/>
@@ -4475,55 +4554,14 @@
       </p:sp>
       <p:sp>
         <p:nvSpPr>
-          <p:cNvPr id="17" name="TextBox 16"/>
-          <p:cNvSpPr txBox="1"/>
-          <p:nvPr/>
-        </p:nvSpPr>
-        <p:spPr>
-          <a:xfrm>
-            <a:off x="6327648" y="3904488"/>
-            <a:ext cx="2350008" cy="256032"/>
-          </a:xfrm>
-          <a:prstGeom prst="rect">
-            <a:avLst/>
-          </a:prstGeom>
-          <a:noFill/>
-        </p:spPr>
-        <p:txBody>
-          <a:bodyPr wrap="square" lIns="54864" rIns="54864" tIns="18288" bIns="18288" anchor="t"/>
-          <a:lstStyle/>
-          <a:p>
-            <a:pPr algn="l">
-              <a:lnSpc>
-                <a:spcPct val="115000"/>
-              </a:lnSpc>
-              <a:spcAft>
-                <a:spcPts val="0"/>
-              </a:spcAft>
-            </a:pPr>
-            <a:r>
-              <a:rPr sz="1200" b="1">
-                <a:solidFill>
-                  <a:srgbClr val="A8452B"/>
-                </a:solidFill>
-                <a:latin typeface="微软雅黑"/>
-                <a:ea typeface="微软雅黑"/>
-              </a:rPr>
-              <a:t>03</a:t>
-            </a:r>
-          </a:p>
-        </p:txBody>
-      </p:sp>
-      <p:sp>
-        <p:nvSpPr>
           <p:cNvPr id="18" name="TextBox 17"/>
           <p:cNvSpPr txBox="1"/>
           <p:nvPr/>
         </p:nvSpPr>
         <p:spPr>
           <a:xfrm>
-            <a:off x="6327648" y="4160520"/>
-            <a:ext cx="2350008" cy="329184"/>
+            <a:off x="7690102" y="2139696"/>
+            <a:ext cx="1975104" cy="438912"/>
           </a:xfrm>
           <a:prstGeom prst="rect">
             <a:avLst/>
@@ -4534,7 +4572,7 @@
           <a:bodyPr wrap="square" lIns="54864" rIns="54864" tIns="18288" bIns="18288" anchor="t"/>
           <a:lstStyle/>
           <a:p>
-            <a:pPr algn="l">
+            <a:pPr algn="ctr">
               <a:lnSpc>
                 <a:spcPct val="115000"/>
               </a:lnSpc>
@@ -4543,14 +4581,14 @@
               </a:spcAft>
             </a:pPr>
             <a:r>
-              <a:rPr sz="1600" b="1">
+              <a:rPr sz="2200" b="1">
                 <a:solidFill>
                   <a:srgbClr val="1B365D"/>
                 </a:solidFill>
                 <a:latin typeface="微软雅黑"/>
                 <a:ea typeface="微软雅黑"/>
               </a:rPr>
-              <a:t>客观贝叶斯</a:t>
+              <a:t>29</a:t>
             </a:r>
           </a:p>
         </p:txBody>
@@ -4563,8 +4601,8 @@
         </p:nvSpPr>
         <p:spPr>
           <a:xfrm>
-            <a:off x="6327648" y="4544568"/>
-            <a:ext cx="2350008" cy="777240"/>
+            <a:off x="7690102" y="2578608"/>
+            <a:ext cx="1975104" cy="365760"/>
           </a:xfrm>
           <a:prstGeom prst="rect">
             <a:avLst/>
@@ -4575,7 +4613,7 @@
           <a:bodyPr wrap="square" lIns="54864" rIns="54864" tIns="18288" bIns="18288" anchor="t"/>
           <a:lstStyle/>
           <a:p>
-            <a:pPr algn="l">
+            <a:pPr algn="ctr">
               <a:lnSpc>
                 <a:spcPct val="115000"/>
               </a:lnSpc>
@@ -4584,15 +4622,14 @@
               </a:spcAft>
             </a:pPr>
             <a:r>
-              <a:rPr sz="1300" b="0">
+              <a:rPr sz="1100" b="0">
                 <a:solidFill>
                   <a:srgbClr val="5A646E"/>
                 </a:solidFill>
                 <a:latin typeface="微软雅黑"/>
                 <a:ea typeface="微软雅黑"/>
               </a:rPr>
-              <a:t>参考先验与后验正常性
-小样本寿命评估</a:t>
+              <a:t>h 指数</a:t>
             </a:r>
           </a:p>
         </p:txBody>
@@ -4605,8 +4642,8 @@
         </p:nvSpPr>
         <p:spPr>
           <a:xfrm>
-            <a:off x="8951976" y="3794760"/>
-            <a:ext cx="2606040" cy="1691640"/>
+            <a:off x="9774933" y="2084831"/>
+            <a:ext cx="1975104" cy="960120"/>
           </a:xfrm>
           <a:prstGeom prst="rect">
             <a:avLst/>
@@ -4651,8 +4688,8 @@
         </p:nvSpPr>
         <p:spPr>
           <a:xfrm>
-            <a:off x="9098280" y="3904488"/>
-            <a:ext cx="2350008" cy="256032"/>
+            <a:off x="9774933" y="2139696"/>
+            <a:ext cx="1975104" cy="438912"/>
           </a:xfrm>
           <a:prstGeom prst="rect">
             <a:avLst/>
@@ -4663,7 +4700,7 @@
           <a:bodyPr wrap="square" lIns="54864" rIns="54864" tIns="18288" bIns="18288" anchor="t"/>
           <a:lstStyle/>
           <a:p>
-            <a:pPr algn="l">
+            <a:pPr algn="ctr">
               <a:lnSpc>
                 <a:spcPct val="115000"/>
               </a:lnSpc>
@@ -4672,14 +4709,14 @@
               </a:spcAft>
             </a:pPr>
             <a:r>
-              <a:rPr sz="1200" b="1">
-                <a:solidFill>
-                  <a:srgbClr val="A8452B"/>
-                </a:solidFill>
-                <a:latin typeface="微软雅黑"/>
-                <a:ea typeface="微软雅黑"/>
-              </a:rPr>
-              <a:t>04</a:t>
+              <a:rPr sz="2200" b="1">
+                <a:solidFill>
+                  <a:srgbClr val="1B365D"/>
+                </a:solidFill>
+                <a:latin typeface="微软雅黑"/>
+                <a:ea typeface="微软雅黑"/>
+              </a:rPr>
+              <a:t>6</a:t>
             </a:r>
           </a:p>
         </p:txBody>
@@ -4692,8 +4729,8 @@
         </p:nvSpPr>
         <p:spPr>
           <a:xfrm>
-            <a:off x="9098280" y="4160520"/>
-            <a:ext cx="2350008" cy="329184"/>
+            <a:off x="9774933" y="2578608"/>
+            <a:ext cx="1975104" cy="365760"/>
           </a:xfrm>
           <a:prstGeom prst="rect">
             <a:avLst/>
@@ -4704,7 +4741,7 @@
           <a:bodyPr wrap="square" lIns="54864" rIns="54864" tIns="18288" bIns="18288" anchor="t"/>
           <a:lstStyle/>
           <a:p>
-            <a:pPr algn="l">
+            <a:pPr algn="ctr">
               <a:lnSpc>
                 <a:spcPct val="115000"/>
               </a:lnSpc>
@@ -4713,57 +4750,61 @@
               </a:spcAft>
             </a:pPr>
             <a:r>
-              <a:rPr sz="1600" b="1">
-                <a:solidFill>
-                  <a:srgbClr val="1B365D"/>
-                </a:solidFill>
-                <a:latin typeface="微软雅黑"/>
-                <a:ea typeface="微软雅黑"/>
-              </a:rPr>
-              <a:t>试验与现场</a:t>
-            </a:r>
-          </a:p>
-        </p:txBody>
-      </p:sp>
-      <p:sp>
-        <p:nvSpPr>
-          <p:cNvPr id="23" name="TextBox 22"/>
-          <p:cNvSpPr txBox="1"/>
-          <p:nvPr/>
-        </p:nvSpPr>
-        <p:spPr>
-          <a:xfrm>
-            <a:off x="9098280" y="4544568"/>
-            <a:ext cx="2350008" cy="777240"/>
-          </a:xfrm>
-          <a:prstGeom prst="rect">
-            <a:avLst/>
-          </a:prstGeom>
-          <a:noFill/>
-        </p:spPr>
-        <p:txBody>
-          <a:bodyPr wrap="square" lIns="54864" rIns="54864" tIns="18288" bIns="18288" anchor="t"/>
-          <a:lstStyle/>
-          <a:p>
-            <a:pPr algn="l">
-              <a:lnSpc>
-                <a:spcPct val="115000"/>
-              </a:lnSpc>
-              <a:spcAft>
-                <a:spcPts val="0"/>
-              </a:spcAft>
-            </a:pPr>
-            <a:r>
-              <a:rPr sz="1300" b="0">
+              <a:rPr sz="1100" b="0">
                 <a:solidFill>
                   <a:srgbClr val="5A646E"/>
                 </a:solidFill>
                 <a:latin typeface="微软雅黑"/>
                 <a:ea typeface="微软雅黑"/>
               </a:rPr>
-              <a:t>加速试验最优设计
-竞争失效与数据融合</a:t>
-            </a:r>
+              <a:t>ESI 高被引论文</a:t>
+            </a:r>
+          </a:p>
+        </p:txBody>
+      </p:sp>
+      <p:sp>
+        <p:nvSpPr>
+          <p:cNvPr id="23" name="Rectangle 22"/>
+          <p:cNvSpPr/>
+          <p:nvPr/>
+        </p:nvSpPr>
+        <p:spPr>
+          <a:xfrm>
+            <a:off x="3520440" y="3200400"/>
+            <a:ext cx="4023360" cy="3200400"/>
+          </a:xfrm>
+          <a:prstGeom prst="rect">
+            <a:avLst/>
+          </a:prstGeom>
+          <a:solidFill>
+            <a:srgbClr val="F2F4F7"/>
+          </a:solidFill>
+          <a:ln w="6350">
+            <a:solidFill>
+              <a:srgbClr val="D0D5DC"/>
+            </a:solidFill>
+          </a:ln>
+          <a:effectLst/>
+        </p:spPr>
+        <p:style>
+          <a:lnRef idx="1">
+            <a:schemeClr val="accent1"/>
+          </a:lnRef>
+          <a:fillRef idx="3">
+            <a:schemeClr val="accent1"/>
+          </a:fillRef>
+          <a:effectRef idx="2">
+            <a:schemeClr val="accent1"/>
+          </a:effectRef>
+          <a:fontRef idx="minor">
+            <a:schemeClr val="lt1"/>
+          </a:fontRef>
+        </p:style>
+        <p:txBody>
+          <a:bodyPr rtlCol="0" anchor="ctr"/>
+          <a:lstStyle/>
+          <a:p>
+            <a:pPr algn="ctr"/>
           </a:p>
         </p:txBody>
       </p:sp>
@@ -4775,8 +4816,8 @@
         </p:nvSpPr>
         <p:spPr>
           <a:xfrm>
-            <a:off x="640080" y="5669280"/>
-            <a:ext cx="10972800" cy="640080"/>
+            <a:off x="3703320" y="3310128"/>
+            <a:ext cx="3703320" cy="256032"/>
           </a:xfrm>
           <a:prstGeom prst="rect">
             <a:avLst/>
@@ -4792,18 +4833,59 @@
                 <a:spcPct val="115000"/>
               </a:lnSpc>
               <a:spcAft>
+                <a:spcPts val="0"/>
+              </a:spcAft>
+            </a:pPr>
+            <a:r>
+              <a:rPr sz="1400" b="1">
+                <a:solidFill>
+                  <a:srgbClr val="A8452B"/>
+                </a:solidFill>
+                <a:latin typeface="微软雅黑"/>
+                <a:ea typeface="微软雅黑"/>
+              </a:rPr>
+              <a:t>代表性成果</a:t>
+            </a:r>
+          </a:p>
+        </p:txBody>
+      </p:sp>
+      <p:sp>
+        <p:nvSpPr>
+          <p:cNvPr id="25" name="TextBox 24"/>
+          <p:cNvSpPr txBox="1"/>
+          <p:nvPr/>
+        </p:nvSpPr>
+        <p:spPr>
+          <a:xfrm>
+            <a:off x="3703320" y="3621024"/>
+            <a:ext cx="3703320" cy="2651760"/>
+          </a:xfrm>
+          <a:prstGeom prst="rect">
+            <a:avLst/>
+          </a:prstGeom>
+          <a:noFill/>
+        </p:spPr>
+        <p:txBody>
+          <a:bodyPr wrap="square" lIns="54864" rIns="54864" tIns="18288" bIns="18288" anchor="t"/>
+          <a:lstStyle/>
+          <a:p>
+            <a:pPr algn="l">
+              <a:lnSpc>
+                <a:spcPct val="115000"/>
+              </a:lnSpc>
+              <a:spcAft>
                 <a:spcPts val="200"/>
               </a:spcAft>
             </a:pPr>
             <a:r>
-              <a:rPr sz="1600" b="1">
+              <a:rPr sz="1300" b="1">
                 <a:solidFill>
                   <a:srgbClr val="1B365D"/>
                 </a:solidFill>
                 <a:latin typeface="微软雅黑"/>
                 <a:ea typeface="微软雅黑"/>
               </a:rPr>
-              <a:t>徐安察  ·  教授、博士生导师</a:t>
+              <a:t>专著《随机退化过程与统计建模》</a:t>
             </a:r>
           </a:p>
           <a:p>
@@ -4812,18 +4894,366 @@
                 <a:spcPct val="115000"/>
               </a:lnSpc>
               <a:spcAft>
+                <a:spcPts val="800"/>
+              </a:spcAft>
+            </a:pPr>
+            <a:r>
+              <a:rPr sz="1200" b="0">
+                <a:solidFill>
+                  <a:srgbClr val="5A646E"/>
+                </a:solidFill>
+                <a:latin typeface="微软雅黑"/>
+                <a:ea typeface="微软雅黑"/>
+              </a:rPr>
+              <a:t>科学出版社，2025；入选统计与数据科学丛书</a:t>
+            </a:r>
+          </a:p>
+          <a:p>
+            <a:pPr algn="l">
+              <a:lnSpc>
+                <a:spcPct val="115000"/>
+              </a:lnSpc>
+              <a:spcAft>
+                <a:spcPts val="200"/>
+              </a:spcAft>
+            </a:pPr>
+            <a:r>
+              <a:rPr sz="1300" b="0">
+                <a:solidFill>
+                  <a:srgbClr val="1C1C1C"/>
+                </a:solidFill>
+                <a:latin typeface="微软雅黑"/>
+                <a:ea typeface="微软雅黑"/>
+              </a:rPr>
+              <a:t>论文见于 NRL、SJS、JQT、EJOR、</a:t>
+            </a:r>
+          </a:p>
+          <a:p>
+            <a:pPr algn="l">
+              <a:lnSpc>
+                <a:spcPct val="115000"/>
+              </a:lnSpc>
+              <a:spcAft>
+                <a:spcPts val="800"/>
+              </a:spcAft>
+            </a:pPr>
+            <a:r>
+              <a:rPr sz="1300" b="0">
+                <a:solidFill>
+                  <a:srgbClr val="1C1C1C"/>
+                </a:solidFill>
+                <a:latin typeface="微软雅黑"/>
+                <a:ea typeface="微软雅黑"/>
+              </a:rPr>
+              <a:t>IEEE TR、IISE Transactions 等</a:t>
+            </a:r>
+          </a:p>
+          <a:p>
+            <a:pPr algn="l">
+              <a:lnSpc>
+                <a:spcPct val="115000"/>
+              </a:lnSpc>
+              <a:spcAft>
+                <a:spcPts val="200"/>
+              </a:spcAft>
+            </a:pPr>
+            <a:r>
+              <a:rPr sz="1300" b="0">
+                <a:solidFill>
+                  <a:srgbClr val="1C1C1C"/>
+                </a:solidFill>
+                <a:latin typeface="微软雅黑"/>
+                <a:ea typeface="微软雅黑"/>
+              </a:rPr>
+              <a:t>主持国自然青年 1 项、面上 3 项</a:t>
+            </a:r>
+          </a:p>
+          <a:p>
+            <a:pPr algn="l">
+              <a:lnSpc>
+                <a:spcPct val="115000"/>
+              </a:lnSpc>
+              <a:spcAft>
+                <a:spcPts val="800"/>
+              </a:spcAft>
+            </a:pPr>
+            <a:r>
+              <a:rPr sz="1200" b="0">
+                <a:solidFill>
+                  <a:srgbClr val="5A646E"/>
+                </a:solidFill>
+                <a:latin typeface="微软雅黑"/>
+                <a:ea typeface="微软雅黑"/>
+              </a:rPr>
+              <a:t>在研面上项目 72571246</a:t>
+            </a:r>
+          </a:p>
+          <a:p>
+            <a:pPr algn="l">
+              <a:lnSpc>
+                <a:spcPct val="115000"/>
+              </a:lnSpc>
+              <a:spcAft>
                 <a:spcPts val="0"/>
               </a:spcAft>
             </a:pPr>
             <a:r>
               <a:rPr sz="1300" b="0">
                 <a:solidFill>
+                  <a:srgbClr val="1C1C1C"/>
+                </a:solidFill>
+                <a:latin typeface="微软雅黑"/>
+                <a:ea typeface="微软雅黑"/>
+              </a:rPr>
+              <a:t>浙江省自然科学基金重点项目等十余项</a:t>
+            </a:r>
+          </a:p>
+        </p:txBody>
+      </p:sp>
+      <p:sp>
+        <p:nvSpPr>
+          <p:cNvPr id="26" name="Rectangle 25"/>
+          <p:cNvSpPr/>
+          <p:nvPr/>
+        </p:nvSpPr>
+        <p:spPr>
+          <a:xfrm>
+            <a:off x="7726679" y="3200400"/>
+            <a:ext cx="4023360" cy="3200400"/>
+          </a:xfrm>
+          <a:prstGeom prst="rect">
+            <a:avLst/>
+          </a:prstGeom>
+          <a:solidFill>
+            <a:srgbClr val="F2F4F7"/>
+          </a:solidFill>
+          <a:ln w="6350">
+            <a:solidFill>
+              <a:srgbClr val="D0D5DC"/>
+            </a:solidFill>
+          </a:ln>
+          <a:effectLst/>
+        </p:spPr>
+        <p:style>
+          <a:lnRef idx="1">
+            <a:schemeClr val="accent1"/>
+          </a:lnRef>
+          <a:fillRef idx="3">
+            <a:schemeClr val="accent1"/>
+          </a:fillRef>
+          <a:effectRef idx="2">
+            <a:schemeClr val="accent1"/>
+          </a:effectRef>
+          <a:fontRef idx="minor">
+            <a:schemeClr val="lt1"/>
+          </a:fontRef>
+        </p:style>
+        <p:txBody>
+          <a:bodyPr rtlCol="0" anchor="ctr"/>
+          <a:lstStyle/>
+          <a:p>
+            <a:pPr algn="ctr"/>
+          </a:p>
+        </p:txBody>
+      </p:sp>
+      <p:sp>
+        <p:nvSpPr>
+          <p:cNvPr id="27" name="TextBox 26"/>
+          <p:cNvSpPr txBox="1"/>
+          <p:nvPr/>
+        </p:nvSpPr>
+        <p:spPr>
+          <a:xfrm>
+            <a:off x="7909560" y="3310128"/>
+            <a:ext cx="3703320" cy="256032"/>
+          </a:xfrm>
+          <a:prstGeom prst="rect">
+            <a:avLst/>
+          </a:prstGeom>
+          <a:noFill/>
+        </p:spPr>
+        <p:txBody>
+          <a:bodyPr wrap="square" lIns="54864" rIns="54864" tIns="18288" bIns="18288" anchor="t"/>
+          <a:lstStyle/>
+          <a:p>
+            <a:pPr algn="l">
+              <a:lnSpc>
+                <a:spcPct val="115000"/>
+              </a:lnSpc>
+              <a:spcAft>
+                <a:spcPts val="0"/>
+              </a:spcAft>
+            </a:pPr>
+            <a:r>
+              <a:rPr sz="1400" b="1">
+                <a:solidFill>
+                  <a:srgbClr val="A8452B"/>
+                </a:solidFill>
+                <a:latin typeface="微软雅黑"/>
+                <a:ea typeface="微软雅黑"/>
+              </a:rPr>
+              <a:t>奖励与学术服务</a:t>
+            </a:r>
+          </a:p>
+        </p:txBody>
+      </p:sp>
+      <p:sp>
+        <p:nvSpPr>
+          <p:cNvPr id="28" name="TextBox 27"/>
+          <p:cNvSpPr txBox="1"/>
+          <p:nvPr/>
+        </p:nvSpPr>
+        <p:spPr>
+          <a:xfrm>
+            <a:off x="7909560" y="3621024"/>
+            <a:ext cx="3703320" cy="2651760"/>
+          </a:xfrm>
+          <a:prstGeom prst="rect">
+            <a:avLst/>
+          </a:prstGeom>
+          <a:noFill/>
+        </p:spPr>
+        <p:txBody>
+          <a:bodyPr wrap="square" lIns="54864" rIns="54864" tIns="18288" bIns="18288" anchor="t"/>
+          <a:lstStyle/>
+          <a:p>
+            <a:pPr algn="l">
+              <a:lnSpc>
+                <a:spcPct val="115000"/>
+              </a:lnSpc>
+              <a:spcAft>
+                <a:spcPts val="200"/>
+              </a:spcAft>
+            </a:pPr>
+            <a:r>
+              <a:rPr sz="1300" b="1">
+                <a:solidFill>
+                  <a:srgbClr val="1B365D"/>
+                </a:solidFill>
+                <a:latin typeface="微软雅黑"/>
+                <a:ea typeface="微软雅黑"/>
+              </a:rPr>
+              <a:t>浙江省自然科学奖</a:t>
+            </a:r>
+          </a:p>
+          <a:p>
+            <a:pPr algn="l">
+              <a:lnSpc>
+                <a:spcPct val="115000"/>
+              </a:lnSpc>
+              <a:spcAft>
+                <a:spcPts val="800"/>
+              </a:spcAft>
+            </a:pPr>
+            <a:r>
+              <a:rPr sz="1200" b="0">
+                <a:solidFill>
                   <a:srgbClr val="5A646E"/>
                 </a:solidFill>
                 <a:latin typeface="微软雅黑"/>
                 <a:ea typeface="微软雅黑"/>
               </a:rPr>
-              <a:t>浙江工商大学 统计与数据科学学院    xuancha@mail.zjgsu.edu.cn    www.xu-ancha.com</a:t>
+              <a:t>福建省自然科学奖、全国统计科技进步奖</a:t>
+            </a:r>
+          </a:p>
+          <a:p>
+            <a:pPr algn="l">
+              <a:lnSpc>
+                <a:spcPct val="115000"/>
+              </a:lnSpc>
+              <a:spcAft>
+                <a:spcPts val="200"/>
+              </a:spcAft>
+            </a:pPr>
+            <a:r>
+              <a:rPr sz="1300" b="0">
+                <a:solidFill>
+                  <a:srgbClr val="1C1C1C"/>
+                </a:solidFill>
+                <a:latin typeface="微软雅黑"/>
+                <a:ea typeface="微软雅黑"/>
+              </a:rPr>
+              <a:t>省高校院士专家结对培养青年英才</a:t>
+            </a:r>
+          </a:p>
+          <a:p>
+            <a:pPr algn="l">
+              <a:lnSpc>
+                <a:spcPct val="115000"/>
+              </a:lnSpc>
+              <a:spcAft>
+                <a:spcPts val="800"/>
+              </a:spcAft>
+            </a:pPr>
+            <a:r>
+              <a:rPr sz="1200" b="0">
+                <a:solidFill>
+                  <a:srgbClr val="5A646E"/>
+                </a:solidFill>
+                <a:latin typeface="微软雅黑"/>
+                <a:ea typeface="微软雅黑"/>
+              </a:rPr>
+              <a:t>省特支计划教育青年人才</a:t>
+            </a:r>
+          </a:p>
+          <a:p>
+            <a:pPr algn="l">
+              <a:lnSpc>
+                <a:spcPct val="115000"/>
+              </a:lnSpc>
+              <a:spcAft>
+                <a:spcPts val="800"/>
+              </a:spcAft>
+            </a:pPr>
+            <a:r>
+              <a:rPr sz="1300" b="0">
+                <a:solidFill>
+                  <a:srgbClr val="1C1C1C"/>
+                </a:solidFill>
+                <a:latin typeface="微软雅黑"/>
+                <a:ea typeface="微软雅黑"/>
+              </a:rPr>
+              <a:t>中国运筹学会可靠性分会副理事长</a:t>
+            </a:r>
+          </a:p>
+          <a:p>
+            <a:pPr algn="l">
+              <a:lnSpc>
+                <a:spcPct val="115000"/>
+              </a:lnSpc>
+              <a:spcAft>
+                <a:spcPts val="200"/>
+              </a:spcAft>
+            </a:pPr>
+            <a:r>
+              <a:rPr sz="1300" b="0">
+                <a:solidFill>
+                  <a:srgbClr val="1C1C1C"/>
+                </a:solidFill>
+                <a:latin typeface="微软雅黑"/>
+                <a:ea typeface="微软雅黑"/>
+              </a:rPr>
+              <a:t>Statistical Theory and Related Fields</a:t>
+            </a:r>
+          </a:p>
+          <a:p>
+            <a:pPr algn="l">
+              <a:lnSpc>
+                <a:spcPct val="115000"/>
+              </a:lnSpc>
+              <a:spcAft>
+                <a:spcPts val="0"/>
+              </a:spcAft>
+            </a:pPr>
+            <a:r>
+              <a:rPr sz="1200" b="0">
+                <a:solidFill>
+                  <a:srgbClr val="5A646E"/>
+                </a:solidFill>
+                <a:latin typeface="微软雅黑"/>
+                <a:ea typeface="微软雅黑"/>
+              </a:rPr>
+              <a:t>Associate Editor</a:t>
             </a:r>
           </a:p>
         </p:txBody>
@@ -4926,7 +5356,7 @@
                 <a:latin typeface="微软雅黑"/>
                 <a:ea typeface="微软雅黑"/>
               </a:rPr>
-              <a:t>01  /  问题</a:t>
+              <a:t>01  /  背景与定位</a:t>
             </a:r>
           </a:p>
         </p:txBody>
@@ -4967,7 +5397,7 @@
                 <a:latin typeface="微软雅黑"/>
                 <a:ea typeface="微软雅黑"/>
               </a:rPr>
-              <a:t>为什么做退化，而不是只看失效时间</a:t>
+              <a:t>先看研究背景，再落到我们的定位</a:t>
             </a:r>
           </a:p>
         </p:txBody>
@@ -5144,14 +5574,55 @@
       </p:sp>
       <p:sp>
         <p:nvSpPr>
-          <p:cNvPr id="9" name="Rectangle 8"/>
+          <p:cNvPr id="9" name="TextBox 8"/>
+          <p:cNvSpPr txBox="1"/>
+          <p:nvPr/>
+        </p:nvSpPr>
+        <p:spPr>
+          <a:xfrm>
+            <a:off x="457200" y="1078992"/>
+            <a:ext cx="11247120" cy="237744"/>
+          </a:xfrm>
+          <a:prstGeom prst="rect">
+            <a:avLst/>
+          </a:prstGeom>
+          <a:noFill/>
+        </p:spPr>
+        <p:txBody>
+          <a:bodyPr wrap="square" lIns="54864" rIns="54864" tIns="18288" bIns="18288" anchor="t"/>
+          <a:lstStyle/>
+          <a:p>
+            <a:pPr algn="l">
+              <a:lnSpc>
+                <a:spcPct val="115000"/>
+              </a:lnSpc>
+              <a:spcAft>
+                <a:spcPts val="0"/>
+              </a:spcAft>
+            </a:pPr>
+            <a:r>
+              <a:rPr sz="1300" b="1">
+                <a:solidFill>
+                  <a:srgbClr val="A8452B"/>
+                </a:solidFill>
+                <a:latin typeface="微软雅黑"/>
+                <a:ea typeface="微软雅黑"/>
+              </a:rPr>
+              <a:t>研究背景</a:t>
+            </a:r>
+          </a:p>
+        </p:txBody>
+      </p:sp>
+      <p:sp>
+        <p:nvSpPr>
+          <p:cNvPr id="10" name="Rectangle 9"/>
           <p:cNvSpPr/>
           <p:nvPr/>
         </p:nvSpPr>
         <p:spPr>
           <a:xfrm>
-            <a:off x="457200" y="1143000"/>
-            <a:ext cx="5532120" cy="5257800"/>
+            <a:off x="457200" y="1353312"/>
+            <a:ext cx="11247120" cy="1417320"/>
           </a:xfrm>
           <a:prstGeom prst="rect">
             <a:avLst/>
@@ -5190,55 +5661,14 @@
       </p:sp>
       <p:sp>
         <p:nvSpPr>
-          <p:cNvPr id="10" name="TextBox 9"/>
-          <p:cNvSpPr txBox="1"/>
-          <p:nvPr/>
-        </p:nvSpPr>
-        <p:spPr>
-          <a:xfrm>
-            <a:off x="658368" y="1280160"/>
-            <a:ext cx="5120640" cy="292608"/>
-          </a:xfrm>
-          <a:prstGeom prst="rect">
-            <a:avLst/>
-          </a:prstGeom>
-          <a:noFill/>
-        </p:spPr>
-        <p:txBody>
-          <a:bodyPr wrap="square" lIns="54864" rIns="54864" tIns="18288" bIns="18288" anchor="t"/>
-          <a:lstStyle/>
-          <a:p>
-            <a:pPr algn="l">
-              <a:lnSpc>
-                <a:spcPct val="115000"/>
-              </a:lnSpc>
-              <a:spcAft>
-                <a:spcPts val="0"/>
-              </a:spcAft>
-            </a:pPr>
-            <a:r>
-              <a:rPr sz="1300" b="1">
-                <a:solidFill>
-                  <a:srgbClr val="A8452B"/>
-                </a:solidFill>
-                <a:latin typeface="微软雅黑"/>
-                <a:ea typeface="微软雅黑"/>
-              </a:rPr>
-              <a:t>工程事实</a:t>
-            </a:r>
-          </a:p>
-        </p:txBody>
-      </p:sp>
-      <p:sp>
-        <p:nvSpPr>
           <p:cNvPr id="11" name="TextBox 10"/>
           <p:cNvSpPr txBox="1"/>
           <p:nvPr/>
         </p:nvSpPr>
         <p:spPr>
           <a:xfrm>
-            <a:off x="658368" y="1591056"/>
-            <a:ext cx="5120640" cy="1417320"/>
+            <a:off x="640080" y="1463040"/>
+            <a:ext cx="10927080" cy="1207008"/>
           </a:xfrm>
           <a:prstGeom prst="rect">
             <a:avLst/>
@@ -5254,18 +5684,18 @@
                 <a:spcPct val="115000"/>
               </a:lnSpc>
               <a:spcAft>
-                <a:spcPts val="400"/>
-              </a:spcAft>
-            </a:pPr>
-            <a:r>
-              <a:rPr sz="1400" b="0">
+                <a:spcPts val="600"/>
+              </a:spcAft>
+            </a:pPr>
+            <a:r>
+              <a:rPr sz="1500" b="0">
                 <a:solidFill>
                   <a:srgbClr val="1C1C1C"/>
                 </a:solidFill>
                 <a:latin typeface="微软雅黑"/>
                 <a:ea typeface="微软雅黑"/>
               </a:rPr>
-              <a:t>高可靠产品在试验期内很少失效。寿命试验给出的多为删失，</a:t>
+              <a:t>电子器件、机电系统和航空装备的可靠度持续提高。传统寿命试验在有限工期内往往只能拿到大量删失，很难观测到足够失效。</a:t>
             </a:r>
           </a:p>
           <a:p>
@@ -5274,18 +5704,18 @@
                 <a:spcPct val="115000"/>
               </a:lnSpc>
               <a:spcAft>
-                <a:spcPts val="400"/>
-              </a:spcAft>
-            </a:pPr>
-            <a:r>
-              <a:rPr sz="1400" b="0">
+                <a:spcPts val="600"/>
+              </a:spcAft>
+            </a:pPr>
+            <a:r>
+              <a:rPr sz="1500" b="0">
                 <a:solidFill>
                   <a:srgbClr val="1C1C1C"/>
                 </a:solidFill>
                 <a:latin typeface="微软雅黑"/>
                 <a:ea typeface="微软雅黑"/>
               </a:rPr>
-              <a:t>信息量不足。电流漂移、裂纹扩展、光强衰减、制动转矩等</a:t>
+              <a:t>与此同时，产品在试验或服役中会留下连续的性能轨迹：电流漂移、裂纹扩展、光强衰减、制动转矩下降。</a:t>
             </a:r>
           </a:p>
           <a:p>
@@ -5298,14 +5728,14 @@
               </a:spcAft>
             </a:pPr>
             <a:r>
-              <a:rPr sz="1400" b="0">
+              <a:rPr sz="1500" b="0">
                 <a:solidFill>
                   <a:srgbClr val="1C1C1C"/>
                 </a:solidFill>
                 <a:latin typeface="微软雅黑"/>
                 <a:ea typeface="微软雅黑"/>
               </a:rPr>
-              <a:t>退化轨迹是连续观测，比失效时间携带更多过程信息。</a:t>
+              <a:t>退化轨迹比失效时间携带更多过程信息，正在成为高可靠产品评估与预测的主要数据来源。</a:t>
             </a:r>
           </a:p>
         </p:txBody>
@@ -5318,8 +5748,8 @@
         </p:nvSpPr>
         <p:spPr>
           <a:xfrm>
-            <a:off x="658368" y="3108960"/>
-            <a:ext cx="5120640" cy="274320"/>
+            <a:off x="457200" y="2889504"/>
+            <a:ext cx="11247120" cy="237744"/>
           </a:xfrm>
           <a:prstGeom prst="rect">
             <a:avLst/>
@@ -5346,7 +5776,7 @@
                 <a:latin typeface="微软雅黑"/>
                 <a:ea typeface="微软雅黑"/>
               </a:rPr>
-              <a:t>统计上要同时处理的四个约束</a:t>
+              <a:t>由此形成的统计困难</a:t>
             </a:r>
           </a:p>
         </p:txBody>
@@ -5359,8 +5789,8 @@
         </p:nvSpPr>
         <p:spPr>
           <a:xfrm>
-            <a:off x="658368" y="3456432"/>
-            <a:ext cx="5120640" cy="585216"/>
+            <a:off x="457200" y="3163824"/>
+            <a:ext cx="2788920" cy="1170432"/>
           </a:xfrm>
           <a:prstGeom prst="rect">
             <a:avLst/>
@@ -5405,8 +5835,8 @@
         </p:nvSpPr>
         <p:spPr>
           <a:xfrm>
-            <a:off x="658368" y="3456432"/>
-            <a:ext cx="73152" cy="585216"/>
+            <a:off x="457200" y="3163824"/>
+            <a:ext cx="73152" cy="1170432"/>
           </a:xfrm>
           <a:prstGeom prst="rect">
             <a:avLst/>
@@ -5449,8 +5879,8 @@
         </p:nvSpPr>
         <p:spPr>
           <a:xfrm>
-            <a:off x="877824" y="3493008"/>
-            <a:ext cx="4754880" cy="237744"/>
+            <a:off x="640080" y="3255264"/>
+            <a:ext cx="2487168" cy="274320"/>
           </a:xfrm>
           <a:prstGeom prst="rect">
             <a:avLst/>
@@ -5470,7 +5900,7 @@
               </a:spcAft>
             </a:pPr>
             <a:r>
-              <a:rPr sz="1400" b="1">
+              <a:rPr sz="1500" b="1">
                 <a:solidFill>
                   <a:srgbClr val="1B365D"/>
                 </a:solidFill>
@@ -5490,8 +5920,8 @@
         </p:nvSpPr>
         <p:spPr>
           <a:xfrm>
-            <a:off x="877824" y="3730752"/>
-            <a:ext cx="4754880" cy="256032"/>
+            <a:off x="640080" y="3547872"/>
+            <a:ext cx="2487168" cy="658368"/>
           </a:xfrm>
           <a:prstGeom prst="rect">
             <a:avLst/>
@@ -5531,8 +5961,8 @@
         </p:nvSpPr>
         <p:spPr>
           <a:xfrm>
-            <a:off x="658368" y="4114800"/>
-            <a:ext cx="5120640" cy="585216"/>
+            <a:off x="3383280" y="3163824"/>
+            <a:ext cx="2788920" cy="1170432"/>
           </a:xfrm>
           <a:prstGeom prst="rect">
             <a:avLst/>
@@ -5577,8 +6007,8 @@
         </p:nvSpPr>
         <p:spPr>
           <a:xfrm>
-            <a:off x="658368" y="4114800"/>
-            <a:ext cx="73152" cy="585216"/>
+            <a:off x="3383280" y="3163824"/>
+            <a:ext cx="73152" cy="1170432"/>
           </a:xfrm>
           <a:prstGeom prst="rect">
             <a:avLst/>
@@ -5621,8 +6051,8 @@
         </p:nvSpPr>
         <p:spPr>
           <a:xfrm>
-            <a:off x="877824" y="4151376"/>
-            <a:ext cx="4754880" cy="237744"/>
+            <a:off x="3566160" y="3255264"/>
+            <a:ext cx="2487168" cy="274320"/>
           </a:xfrm>
           <a:prstGeom prst="rect">
             <a:avLst/>
@@ -5642,7 +6072,7 @@
               </a:spcAft>
             </a:pPr>
             <a:r>
-              <a:rPr sz="1400" b="1">
+              <a:rPr sz="1500" b="1">
                 <a:solidFill>
                   <a:srgbClr val="1B365D"/>
                 </a:solidFill>
@@ -5662,8 +6092,8 @@
         </p:nvSpPr>
         <p:spPr>
           <a:xfrm>
-            <a:off x="877824" y="4389120"/>
-            <a:ext cx="4754880" cy="256032"/>
+            <a:off x="3566160" y="3547872"/>
+            <a:ext cx="2487168" cy="658368"/>
           </a:xfrm>
           <a:prstGeom prst="rect">
             <a:avLst/>
@@ -5703,8 +6133,8 @@
         </p:nvSpPr>
         <p:spPr>
           <a:xfrm>
-            <a:off x="658368" y="4773168"/>
-            <a:ext cx="5120640" cy="585216"/>
+            <a:off x="6309360" y="3163824"/>
+            <a:ext cx="2788920" cy="1170432"/>
           </a:xfrm>
           <a:prstGeom prst="rect">
             <a:avLst/>
@@ -5749,8 +6179,8 @@
         </p:nvSpPr>
         <p:spPr>
           <a:xfrm>
-            <a:off x="658368" y="4773168"/>
-            <a:ext cx="73152" cy="585216"/>
+            <a:off x="6309360" y="3163824"/>
+            <a:ext cx="73152" cy="1170432"/>
           </a:xfrm>
           <a:prstGeom prst="rect">
             <a:avLst/>
@@ -5793,8 +6223,8 @@
         </p:nvSpPr>
         <p:spPr>
           <a:xfrm>
-            <a:off x="877824" y="4809744"/>
-            <a:ext cx="4754880" cy="237744"/>
+            <a:off x="6492240" y="3255264"/>
+            <a:ext cx="2487168" cy="274320"/>
           </a:xfrm>
           <a:prstGeom prst="rect">
             <a:avLst/>
@@ -5814,7 +6244,7 @@
               </a:spcAft>
             </a:pPr>
             <a:r>
-              <a:rPr sz="1400" b="1">
+              <a:rPr sz="1500" b="1">
                 <a:solidFill>
                   <a:srgbClr val="1B365D"/>
                 </a:solidFill>
@@ -5834,8 +6264,8 @@
         </p:nvSpPr>
         <p:spPr>
           <a:xfrm>
-            <a:off x="877824" y="5047488"/>
-            <a:ext cx="4754880" cy="256032"/>
+            <a:off x="6492240" y="3547872"/>
+            <a:ext cx="2487168" cy="658368"/>
           </a:xfrm>
           <a:prstGeom prst="rect">
             <a:avLst/>
@@ -5862,7 +6292,7 @@
                 <a:latin typeface="微软雅黑"/>
                 <a:ea typeface="微软雅黑"/>
               </a:rPr>
-              <a:t>随机效应、亚总体、两阶段 / 双尺度</a:t>
+              <a:t>随机效应、亚总体、两阶段与双尺度</a:t>
             </a:r>
           </a:p>
         </p:txBody>
@@ -5875,8 +6305,8 @@
         </p:nvSpPr>
         <p:spPr>
           <a:xfrm>
-            <a:off x="658368" y="5431536"/>
-            <a:ext cx="5120640" cy="585216"/>
+            <a:off x="9235440" y="3163824"/>
+            <a:ext cx="2788920" cy="1170432"/>
           </a:xfrm>
           <a:prstGeom prst="rect">
             <a:avLst/>
@@ -5921,8 +6351,8 @@
         </p:nvSpPr>
         <p:spPr>
           <a:xfrm>
-            <a:off x="658368" y="5431536"/>
-            <a:ext cx="73152" cy="585216"/>
+            <a:off x="9235440" y="3163824"/>
+            <a:ext cx="73152" cy="1170432"/>
           </a:xfrm>
           <a:prstGeom prst="rect">
             <a:avLst/>
@@ -5965,8 +6395,8 @@
         </p:nvSpPr>
         <p:spPr>
           <a:xfrm>
-            <a:off x="877824" y="5468112"/>
-            <a:ext cx="4754880" cy="237744"/>
+            <a:off x="9418320" y="3255264"/>
+            <a:ext cx="2487168" cy="274320"/>
           </a:xfrm>
           <a:prstGeom prst="rect">
             <a:avLst/>
@@ -5986,7 +6416,7 @@
               </a:spcAft>
             </a:pPr>
             <a:r>
-              <a:rPr sz="1400" b="1">
+              <a:rPr sz="1500" b="1">
                 <a:solidFill>
                   <a:srgbClr val="1B365D"/>
                 </a:solidFill>
@@ -6006,8 +6436,8 @@
         </p:nvSpPr>
         <p:spPr>
           <a:xfrm>
-            <a:off x="877824" y="5705856"/>
-            <a:ext cx="4754880" cy="256032"/>
+            <a:off x="9418320" y="3547872"/>
+            <a:ext cx="2487168" cy="658368"/>
           </a:xfrm>
           <a:prstGeom prst="rect">
             <a:avLst/>
@@ -6047,8 +6477,8 @@
         </p:nvSpPr>
         <p:spPr>
           <a:xfrm>
-            <a:off x="6263640" y="1143000"/>
-            <a:ext cx="5394960" cy="292608"/>
+            <a:off x="457200" y="4462272"/>
+            <a:ext cx="11247120" cy="237744"/>
           </a:xfrm>
           <a:prstGeom prst="rect">
             <a:avLst/>
@@ -6075,7 +6505,7 @@
                 <a:latin typeface="微软雅黑"/>
                 <a:ea typeface="微软雅黑"/>
               </a:rPr>
-              <a:t>研究框架：一层对应一个约束</a:t>
+              <a:t>因此，研究定位</a:t>
             </a:r>
           </a:p>
         </p:txBody>
@@ -6088,8 +6518,8 @@
         </p:nvSpPr>
         <p:spPr>
           <a:xfrm>
-            <a:off x="6263640" y="1536192"/>
-            <a:ext cx="5440680" cy="932688"/>
+            <a:off x="457200" y="4718304"/>
+            <a:ext cx="11247120" cy="1719072"/>
           </a:xfrm>
           <a:prstGeom prst="rect">
             <a:avLst/>
@@ -6132,8 +6562,8 @@
         </p:nvSpPr>
         <p:spPr>
           <a:xfrm>
-            <a:off x="6473952" y="1664208"/>
-            <a:ext cx="5029200" cy="274320"/>
+            <a:off x="658368" y="4828032"/>
+            <a:ext cx="10881360" cy="640080"/>
           </a:xfrm>
           <a:prstGeom prst="rect">
             <a:avLst/>
@@ -6149,18 +6579,38 @@
                 <a:spcPct val="115000"/>
               </a:lnSpc>
               <a:spcAft>
+                <a:spcPts val="300"/>
+              </a:spcAft>
+            </a:pPr>
+            <a:r>
+              <a:rPr sz="1600" b="0">
+                <a:solidFill>
+                  <a:srgbClr val="FFFFFF"/>
+                </a:solidFill>
+                <a:latin typeface="微软雅黑"/>
+                <a:ea typeface="微软雅黑"/>
+              </a:rPr>
+              <a:t>用随机过程与贝叶斯方法，从退化监测数据和寿命数据中</a:t>
+            </a:r>
+          </a:p>
+          <a:p>
+            <a:pPr algn="l">
+              <a:lnSpc>
+                <a:spcPct val="115000"/>
+              </a:lnSpc>
+              <a:spcAft>
                 <a:spcPts val="0"/>
               </a:spcAft>
             </a:pPr>
             <a:r>
-              <a:rPr sz="1600" b="1">
+              <a:rPr sz="1600" b="0">
                 <a:solidFill>
                   <a:srgbClr val="FFFFFF"/>
                 </a:solidFill>
                 <a:latin typeface="微软雅黑"/>
                 <a:ea typeface="微软雅黑"/>
               </a:rPr>
-              <a:t>数据</a:t>
+              <a:t>评估高可靠产品的可靠性，并给出可递归更新的剩余寿命预测。</a:t>
             </a:r>
           </a:p>
         </p:txBody>
@@ -6173,8 +6623,8 @@
         </p:nvSpPr>
         <p:spPr>
           <a:xfrm>
-            <a:off x="6473952" y="1975104"/>
-            <a:ext cx="5029200" cy="365760"/>
+            <a:off x="658368" y="5559552"/>
+            <a:ext cx="2651760" cy="256032"/>
           </a:xfrm>
           <a:prstGeom prst="rect">
             <a:avLst/>
@@ -6194,59 +6644,56 @@
               </a:spcAft>
             </a:pPr>
             <a:r>
-              <a:rPr sz="1300" b="0">
+              <a:rPr sz="1300" b="1">
+                <a:solidFill>
+                  <a:srgbClr val="F0C4B0"/>
+                </a:solidFill>
+                <a:latin typeface="微软雅黑"/>
+                <a:ea typeface="微软雅黑"/>
+              </a:rPr>
+              <a:t>退化建模</a:t>
+            </a:r>
+          </a:p>
+        </p:txBody>
+      </p:sp>
+      <p:sp>
+        <p:nvSpPr>
+          <p:cNvPr id="33" name="TextBox 32"/>
+          <p:cNvSpPr txBox="1"/>
+          <p:nvPr/>
+        </p:nvSpPr>
+        <p:spPr>
+          <a:xfrm>
+            <a:off x="658368" y="5815584"/>
+            <a:ext cx="2651760" cy="256032"/>
+          </a:xfrm>
+          <a:prstGeom prst="rect">
+            <a:avLst/>
+          </a:prstGeom>
+          <a:noFill/>
+        </p:spPr>
+        <p:txBody>
+          <a:bodyPr wrap="square" lIns="54864" rIns="54864" tIns="18288" bIns="18288" anchor="t"/>
+          <a:lstStyle/>
+          <a:p>
+            <a:pPr algn="l">
+              <a:lnSpc>
+                <a:spcPct val="115000"/>
+              </a:lnSpc>
+              <a:spcAft>
+                <a:spcPts val="0"/>
+              </a:spcAft>
+            </a:pPr>
+            <a:r>
+              <a:rPr sz="1200" b="0">
                 <a:solidFill>
                   <a:srgbClr val="D7DEE7"/>
                 </a:solidFill>
                 <a:latin typeface="微软雅黑"/>
                 <a:ea typeface="微软雅黑"/>
               </a:rPr>
-              <a:t>退化轨迹  ·  寿命 / 删失  ·  加速试验  ·  现场服役</a:t>
-            </a:r>
-          </a:p>
-        </p:txBody>
-      </p:sp>
-      <p:sp>
-        <p:nvSpPr>
-          <p:cNvPr id="33" name="Rectangle 32"/>
-          <p:cNvSpPr/>
-          <p:nvPr/>
-        </p:nvSpPr>
-        <p:spPr>
-          <a:xfrm>
-            <a:off x="6263640" y="2615184"/>
-            <a:ext cx="5440680" cy="932688"/>
-          </a:xfrm>
-          <a:prstGeom prst="rect">
-            <a:avLst/>
-          </a:prstGeom>
-          <a:solidFill>
-            <a:srgbClr val="2F4F73"/>
-          </a:solidFill>
-          <a:ln>
-            <a:noFill/>
-          </a:ln>
-          <a:effectLst/>
-        </p:spPr>
-        <p:style>
-          <a:lnRef idx="1">
-            <a:schemeClr val="accent1"/>
-          </a:lnRef>
-          <a:fillRef idx="3">
-            <a:schemeClr val="accent1"/>
-          </a:fillRef>
-          <a:effectRef idx="2">
-            <a:schemeClr val="accent1"/>
-          </a:effectRef>
-          <a:fontRef idx="minor">
-            <a:schemeClr val="lt1"/>
-          </a:fontRef>
-        </p:style>
-        <p:txBody>
-          <a:bodyPr rtlCol="0" anchor="ctr"/>
-          <a:lstStyle/>
-          <a:p>
-            <a:pPr algn="ctr"/>
+              <a:t>Wiener / IG / Gamma</a:t>
+            </a:r>
           </a:p>
         </p:txBody>
       </p:sp>
@@ -6258,8 +6705,8 @@
         </p:nvSpPr>
         <p:spPr>
           <a:xfrm>
-            <a:off x="6473952" y="2743200"/>
-            <a:ext cx="5029200" cy="274320"/>
+            <a:off x="3447288" y="5559552"/>
+            <a:ext cx="2651760" cy="256032"/>
           </a:xfrm>
           <a:prstGeom prst="rect">
             <a:avLst/>
@@ -6279,14 +6726,14 @@
               </a:spcAft>
             </a:pPr>
             <a:r>
-              <a:rPr sz="1600" b="1">
-                <a:solidFill>
-                  <a:srgbClr val="FFFFFF"/>
-                </a:solidFill>
-                <a:latin typeface="微软雅黑"/>
-                <a:ea typeface="微软雅黑"/>
-              </a:rPr>
-              <a:t>过程</a:t>
+              <a:rPr sz="1300" b="1">
+                <a:solidFill>
+                  <a:srgbClr val="F0C4B0"/>
+                </a:solidFill>
+                <a:latin typeface="微软雅黑"/>
+                <a:ea typeface="微软雅黑"/>
+              </a:rPr>
+              <a:t>在线贝叶斯</a:t>
             </a:r>
           </a:p>
         </p:txBody>
@@ -6299,8 +6746,8 @@
         </p:nvSpPr>
         <p:spPr>
           <a:xfrm>
-            <a:off x="6473952" y="3054096"/>
-            <a:ext cx="5029200" cy="365760"/>
+            <a:off x="3447288" y="5815584"/>
+            <a:ext cx="2651760" cy="256032"/>
           </a:xfrm>
           <a:prstGeom prst="rect">
             <a:avLst/>
@@ -6320,59 +6767,56 @@
               </a:spcAft>
             </a:pPr>
             <a:r>
-              <a:rPr sz="1300" b="0">
+              <a:rPr sz="1200" b="0">
                 <a:solidFill>
                   <a:srgbClr val="D7DEE7"/>
                 </a:solidFill>
                 <a:latin typeface="微软雅黑"/>
                 <a:ea typeface="微软雅黑"/>
               </a:rPr>
-              <a:t>Wiener / 逆高斯 / Gamma，及其多元、变点、厚尾扩展</a:t>
-            </a:r>
-          </a:p>
-        </p:txBody>
-      </p:sp>
-      <p:sp>
-        <p:nvSpPr>
-          <p:cNvPr id="36" name="Rectangle 35"/>
-          <p:cNvSpPr/>
-          <p:nvPr/>
-        </p:nvSpPr>
-        <p:spPr>
-          <a:xfrm>
-            <a:off x="6263640" y="3694176"/>
-            <a:ext cx="5440680" cy="932688"/>
-          </a:xfrm>
-          <a:prstGeom prst="rect">
-            <a:avLst/>
-          </a:prstGeom>
-          <a:solidFill>
-            <a:srgbClr val="1B365D"/>
-          </a:solidFill>
-          <a:ln>
-            <a:noFill/>
-          </a:ln>
-          <a:effectLst/>
-        </p:spPr>
-        <p:style>
-          <a:lnRef idx="1">
-            <a:schemeClr val="accent1"/>
-          </a:lnRef>
-          <a:fillRef idx="3">
-            <a:schemeClr val="accent1"/>
-          </a:fillRef>
-          <a:effectRef idx="2">
-            <a:schemeClr val="accent1"/>
-          </a:effectRef>
-          <a:fontRef idx="minor">
-            <a:schemeClr val="lt1"/>
-          </a:fontRef>
-        </p:style>
-        <p:txBody>
-          <a:bodyPr rtlCol="0" anchor="ctr"/>
-          <a:lstStyle/>
-          <a:p>
-            <a:pPr algn="ctr"/>
+              <a:t>共轭与递归更新</a:t>
+            </a:r>
+          </a:p>
+        </p:txBody>
+      </p:sp>
+      <p:sp>
+        <p:nvSpPr>
+          <p:cNvPr id="36" name="TextBox 35"/>
+          <p:cNvSpPr txBox="1"/>
+          <p:nvPr/>
+        </p:nvSpPr>
+        <p:spPr>
+          <a:xfrm>
+            <a:off x="6236208" y="5559552"/>
+            <a:ext cx="2651760" cy="256032"/>
+          </a:xfrm>
+          <a:prstGeom prst="rect">
+            <a:avLst/>
+          </a:prstGeom>
+          <a:noFill/>
+        </p:spPr>
+        <p:txBody>
+          <a:bodyPr wrap="square" lIns="54864" rIns="54864" tIns="18288" bIns="18288" anchor="t"/>
+          <a:lstStyle/>
+          <a:p>
+            <a:pPr algn="l">
+              <a:lnSpc>
+                <a:spcPct val="115000"/>
+              </a:lnSpc>
+              <a:spcAft>
+                <a:spcPts val="0"/>
+              </a:spcAft>
+            </a:pPr>
+            <a:r>
+              <a:rPr sz="1300" b="1">
+                <a:solidFill>
+                  <a:srgbClr val="F0C4B0"/>
+                </a:solidFill>
+                <a:latin typeface="微软雅黑"/>
+                <a:ea typeface="微软雅黑"/>
+              </a:rPr>
+              <a:t>客观贝叶斯</a:t>
+            </a:r>
           </a:p>
         </p:txBody>
       </p:sp>
@@ -6384,8 +6828,8 @@
         </p:nvSpPr>
         <p:spPr>
           <a:xfrm>
-            <a:off x="6473952" y="3822192"/>
-            <a:ext cx="5029200" cy="274320"/>
+            <a:off x="6236208" y="5815584"/>
+            <a:ext cx="2651760" cy="256032"/>
           </a:xfrm>
           <a:prstGeom prst="rect">
             <a:avLst/>
@@ -6405,14 +6849,14 @@
               </a:spcAft>
             </a:pPr>
             <a:r>
-              <a:rPr sz="1600" b="1">
-                <a:solidFill>
-                  <a:srgbClr val="FFFFFF"/>
-                </a:solidFill>
-                <a:latin typeface="微软雅黑"/>
-                <a:ea typeface="微软雅黑"/>
-              </a:rPr>
-              <a:t>推断</a:t>
+              <a:rPr sz="1200" b="0">
+                <a:solidFill>
+                  <a:srgbClr val="D7DEE7"/>
+                </a:solidFill>
+                <a:latin typeface="微软雅黑"/>
+                <a:ea typeface="微软雅黑"/>
+              </a:rPr>
+              <a:t>小样本寿命评估</a:t>
             </a:r>
           </a:p>
         </p:txBody>
@@ -6425,8 +6869,8 @@
         </p:nvSpPr>
         <p:spPr>
           <a:xfrm>
-            <a:off x="6473952" y="4133088"/>
-            <a:ext cx="5029200" cy="365760"/>
+            <a:off x="9025128" y="5559552"/>
+            <a:ext cx="2651760" cy="256032"/>
           </a:xfrm>
           <a:prstGeom prst="rect">
             <a:avLst/>
@@ -6446,140 +6890,55 @@
               </a:spcAft>
             </a:pPr>
             <a:r>
-              <a:rPr sz="1300" b="0">
+              <a:rPr sz="1300" b="1">
+                <a:solidFill>
+                  <a:srgbClr val="F0C4B0"/>
+                </a:solidFill>
+                <a:latin typeface="微软雅黑"/>
+                <a:ea typeface="微软雅黑"/>
+              </a:rPr>
+              <a:t>试验与现场</a:t>
+            </a:r>
+          </a:p>
+        </p:txBody>
+      </p:sp>
+      <p:sp>
+        <p:nvSpPr>
+          <p:cNvPr id="39" name="TextBox 38"/>
+          <p:cNvSpPr txBox="1"/>
+          <p:nvPr/>
+        </p:nvSpPr>
+        <p:spPr>
+          <a:xfrm>
+            <a:off x="9025128" y="5815584"/>
+            <a:ext cx="2651760" cy="256032"/>
+          </a:xfrm>
+          <a:prstGeom prst="rect">
+            <a:avLst/>
+          </a:prstGeom>
+          <a:noFill/>
+        </p:spPr>
+        <p:txBody>
+          <a:bodyPr wrap="square" lIns="54864" rIns="54864" tIns="18288" bIns="18288" anchor="t"/>
+          <a:lstStyle/>
+          <a:p>
+            <a:pPr algn="l">
+              <a:lnSpc>
+                <a:spcPct val="115000"/>
+              </a:lnSpc>
+              <a:spcAft>
+                <a:spcPts val="0"/>
+              </a:spcAft>
+            </a:pPr>
+            <a:r>
+              <a:rPr sz="1200" b="0">
                 <a:solidFill>
                   <a:srgbClr val="D7DEE7"/>
                 </a:solidFill>
                 <a:latin typeface="微软雅黑"/>
                 <a:ea typeface="微软雅黑"/>
               </a:rPr>
-              <a:t>客观先验、共轭与递归更新、近似贝叶斯</a:t>
-            </a:r>
-          </a:p>
-        </p:txBody>
-      </p:sp>
-      <p:sp>
-        <p:nvSpPr>
-          <p:cNvPr id="39" name="Rectangle 38"/>
-          <p:cNvSpPr/>
-          <p:nvPr/>
-        </p:nvSpPr>
-        <p:spPr>
-          <a:xfrm>
-            <a:off x="6263640" y="4773168"/>
-            <a:ext cx="5440680" cy="932688"/>
-          </a:xfrm>
-          <a:prstGeom prst="rect">
-            <a:avLst/>
-          </a:prstGeom>
-          <a:solidFill>
-            <a:srgbClr val="2F4F73"/>
-          </a:solidFill>
-          <a:ln>
-            <a:noFill/>
-          </a:ln>
-          <a:effectLst/>
-        </p:spPr>
-        <p:style>
-          <a:lnRef idx="1">
-            <a:schemeClr val="accent1"/>
-          </a:lnRef>
-          <a:fillRef idx="3">
-            <a:schemeClr val="accent1"/>
-          </a:fillRef>
-          <a:effectRef idx="2">
-            <a:schemeClr val="accent1"/>
-          </a:effectRef>
-          <a:fontRef idx="minor">
-            <a:schemeClr val="lt1"/>
-          </a:fontRef>
-        </p:style>
-        <p:txBody>
-          <a:bodyPr rtlCol="0" anchor="ctr"/>
-          <a:lstStyle/>
-          <a:p>
-            <a:pPr algn="ctr"/>
-          </a:p>
-        </p:txBody>
-      </p:sp>
-      <p:sp>
-        <p:nvSpPr>
-          <p:cNvPr id="40" name="TextBox 39"/>
-          <p:cNvSpPr txBox="1"/>
-          <p:nvPr/>
-        </p:nvSpPr>
-        <p:spPr>
-          <a:xfrm>
-            <a:off x="6473952" y="4901184"/>
-            <a:ext cx="5029200" cy="274320"/>
-          </a:xfrm>
-          <a:prstGeom prst="rect">
-            <a:avLst/>
-          </a:prstGeom>
-          <a:noFill/>
-        </p:spPr>
-        <p:txBody>
-          <a:bodyPr wrap="square" lIns="54864" rIns="54864" tIns="18288" bIns="18288" anchor="t"/>
-          <a:lstStyle/>
-          <a:p>
-            <a:pPr algn="l">
-              <a:lnSpc>
-                <a:spcPct val="115000"/>
-              </a:lnSpc>
-              <a:spcAft>
-                <a:spcPts val="0"/>
-              </a:spcAft>
-            </a:pPr>
-            <a:r>
-              <a:rPr sz="1600" b="1">
-                <a:solidFill>
-                  <a:srgbClr val="FFFFFF"/>
-                </a:solidFill>
-                <a:latin typeface="微软雅黑"/>
-                <a:ea typeface="微软雅黑"/>
-              </a:rPr>
-              <a:t>决策</a:t>
-            </a:r>
-          </a:p>
-        </p:txBody>
-      </p:sp>
-      <p:sp>
-        <p:nvSpPr>
-          <p:cNvPr id="41" name="TextBox 40"/>
-          <p:cNvSpPr txBox="1"/>
-          <p:nvPr/>
-        </p:nvSpPr>
-        <p:spPr>
-          <a:xfrm>
-            <a:off x="6473952" y="5212080"/>
-            <a:ext cx="5029200" cy="365760"/>
-          </a:xfrm>
-          <a:prstGeom prst="rect">
-            <a:avLst/>
-          </a:prstGeom>
-          <a:noFill/>
-        </p:spPr>
-        <p:txBody>
-          <a:bodyPr wrap="square" lIns="54864" rIns="54864" tIns="18288" bIns="18288" anchor="t"/>
-          <a:lstStyle/>
-          <a:p>
-            <a:pPr algn="l">
-              <a:lnSpc>
-                <a:spcPct val="115000"/>
-              </a:lnSpc>
-              <a:spcAft>
-                <a:spcPts val="0"/>
-              </a:spcAft>
-            </a:pPr>
-            <a:r>
-              <a:rPr sz="1300" b="0">
-                <a:solidFill>
-                  <a:srgbClr val="D7DEE7"/>
-                </a:solidFill>
-                <a:latin typeface="微软雅黑"/>
-                <a:ea typeface="微软雅黑"/>
-              </a:rPr>
-              <a:t>可靠性评估  ·  RUL  ·  预测性维修  ·  试验设计</a:t>
+              <a:t>加速试验与数据融合</a:t>
             </a:r>
           </a:p>
         </p:txBody>
@@ -10719,34 +11078,34 @@
               </a:spcAft>
             </a:pPr>
             <a:r>
+              <a:rPr sz="1500" b="0">
+                <a:solidFill>
+                  <a:srgbClr val="FFFFFF"/>
+                </a:solidFill>
+                <a:latin typeface="微软雅黑"/>
+                <a:ea typeface="微软雅黑"/>
+              </a:rPr>
+              <a:t>后面的工作会沿着偏态厚尾建模、在线校准和试验—现场融合继续做。</a:t>
+            </a:r>
+          </a:p>
+          <a:p>
+            <a:pPr algn="l">
+              <a:lnSpc>
+                <a:spcPct val="115000"/>
+              </a:lnSpc>
+              <a:spcAft>
+                <a:spcPts val="0"/>
+              </a:spcAft>
+            </a:pPr>
+            <a:r>
               <a:rPr sz="1400" b="0">
                 <a:solidFill>
-                  <a:srgbClr val="FFFFFF"/>
-                </a:solidFill>
-                <a:latin typeface="微软雅黑"/>
-                <a:ea typeface="微软雅黑"/>
-              </a:rPr>
-              <a:t>一作 / 通讯 SCI 60 余篇，ESI 高被引 6 篇。主持国自然青年 1 项、面上 3 项，以及浙江省自然科学基金重点项目。</a:t>
-            </a:r>
-          </a:p>
-          <a:p>
-            <a:pPr algn="l">
-              <a:lnSpc>
-                <a:spcPct val="115000"/>
-              </a:lnSpc>
-              <a:spcAft>
-                <a:spcPts val="0"/>
-              </a:spcAft>
-            </a:pPr>
-            <a:r>
-              <a:rPr sz="1300" b="0">
-                <a:solidFill>
                   <a:srgbClr val="D7DEE7"/>
                 </a:solidFill>
                 <a:latin typeface="微软雅黑"/>
                 <a:ea typeface="微软雅黑"/>
               </a:rPr>
-              <a:t>中国运筹学会可靠性分会副理事长  ·  Statistical Theory and Related Fields 副主编</a:t>
+              <a:t>欢迎批评，也欢迎在具体数据或问题上合作。</a:t>
             </a:r>
           </a:p>
         </p:txBody>

</xml_diff>

<commit_message>
Restructure the briefing into four formal slides.
The opening page now covers teaching, research, and service. The background is framed by national quality and manufacturing strategies. Research is one page mapped to those problems, and the last page looks ahead to data streams, multi-center data, federated learning, and AI reliability.

Co-authored-by: Ancha Xu <xuancha2011@aliyun.com>
</commit_message>
<xml_diff>
--- a/files/slides/research-intro-experts.pptx
+++ b/files/slides/research-intro-experts.pptx
@@ -9,7 +9,6 @@
     <p:sldId id="257" r:id="rId9"/>
     <p:sldId id="258" r:id="rId10"/>
     <p:sldId id="259" r:id="rId11"/>
-    <p:sldId id="260" r:id="rId12"/>
   </p:sldIdLst>
   <p:sldSz cx="12191695" cy="6858000" type="screen4x3"/>
   <p:notesSz cx="6858000" cy="9144000"/>
@@ -506,7 +505,7 @@
           <a:lstStyle/>
           <a:p>
             <a:r>
-              <a:t>先报姓名和单位。教学点课程和学生去向，提一句好导师和挑战杯即可。科研报论文、书、基金和分会兼职。不要念完每一行。</a:t>
+              <a:t>按三块讲。教学点课程和学生去向。科研点论文、专著和基金。社会服务点学会职务和企业合作。</a:t>
             </a:r>
           </a:p>
         </p:txBody>
@@ -576,7 +575,7 @@
           <a:lstStyle/>
           <a:p>
             <a:r>
-              <a:t>先把背景讲完：失效少，所以看退化轨迹。再提四个具体麻烦。最后两句说我们做什么，不要念成口号。</a:t>
+              <a:t>先讲质量强国、制造强国，再落到高可靠、少失效和退化轨迹。四个问题与下一页一一对应。</a:t>
             </a:r>
           </a:p>
         </p:txBody>
@@ -646,7 +645,7 @@
           <a:lstStyle/>
           <a:p>
             <a:r>
-              <a:t>点两篇就够：Student-t 和两阶段逆高斯。书一句话带过。</a:t>
+              <a:t>按四个问题对讲。每块点一项代表工作即可，不必报齐刊物。</a:t>
             </a:r>
           </a:p>
         </p:txBody>
@@ -716,77 +715,7 @@
           <a:lstStyle/>
           <a:p>
             <a:r>
-              <a:t>统计同行多讲 SJS 和 NRL。工业上可以提航空发动机。不要说“不是更快的 MCMC”这种对比句。</a:t>
-            </a:r>
-          </a:p>
-        </p:txBody>
-      </p:sp>
-      <p:sp>
-        <p:nvSpPr>
-          <p:cNvPr id="4" name="Slide Number Placeholder 3"/>
-          <p:cNvSpPr>
-            <a:spLocks noGrp="1"/>
-          </p:cNvSpPr>
-          <p:nvPr>
-            <p:ph type="sldNum" idx="5" sz="quarter"/>
-          </p:nvPr>
-        </p:nvSpPr>
-        <p:spPr/>
-      </p:sp>
-    </p:spTree>
-  </p:cSld>
-  <p:clrMapOvr>
-    <a:masterClrMapping/>
-  </p:clrMapOvr>
-</p:notes>
-</file>
-
-<file path=ppt/notesSlides/notesSlide5.xml><?xml version="1.0" encoding="utf-8"?>
-<p:notes xmlns:a="http://schemas.openxmlformats.org/drawingml/2006/main" xmlns:p="http://schemas.openxmlformats.org/presentationml/2006/main" xmlns:r="http://schemas.openxmlformats.org/officeDocument/2006/relationships">
-  <p:cSld>
-    <p:spTree>
-      <p:nvGrpSpPr>
-        <p:cNvPr id="1" name=""/>
-        <p:cNvGrpSpPr/>
-        <p:nvPr/>
-      </p:nvGrpSpPr>
-      <p:grpSpPr>
-        <a:xfrm>
-          <a:off x="0" y="0"/>
-          <a:ext cx="0" cy="0"/>
-          <a:chOff x="0" y="0"/>
-          <a:chExt cx="0" cy="0"/>
-        </a:xfrm>
-      </p:grpSpPr>
-      <p:sp>
-        <p:nvSpPr>
-          <p:cNvPr id="2" name="Slide Image Placeholder 1"/>
-          <p:cNvSpPr>
-            <a:spLocks noGrp="1"/>
-          </p:cNvSpPr>
-          <p:nvPr>
-            <p:ph type="sldImg" idx="2"/>
-          </p:nvPr>
-        </p:nvSpPr>
-        <p:spPr/>
-      </p:sp>
-      <p:sp>
-        <p:nvSpPr>
-          <p:cNvPr id="3" name="Notes Placeholder 2"/>
-          <p:cNvSpPr>
-            <a:spLocks noGrp="1"/>
-          </p:cNvSpPr>
-          <p:nvPr>
-            <p:ph type="body" idx="3" sz="quarter"/>
-          </p:nvPr>
-        </p:nvSpPr>
-        <p:spPr/>
-        <p:txBody>
-          <a:bodyPr/>
-          <a:lstStyle/>
-          <a:p>
-            <a:r>
-              <a:t>小样本举屏蔽数据或加速试验，应用举永磁制动器或华为。后面的问题挑一两个问在座的人。不要再报论文篇数。</a:t>
+              <a:t>四块各举一句。联邦学习可提已有航空发动机工作。最后停在请批评指正。</a:t>
             </a:r>
           </a:p>
         </p:txBody>
@@ -3809,7 +3738,7 @@
         <p:spPr>
           <a:xfrm>
             <a:off x="0" y="0"/>
-            <a:ext cx="3703320" cy="6858000"/>
+            <a:ext cx="12191695" cy="1755648"/>
           </a:xfrm>
           <a:prstGeom prst="rect">
             <a:avLst/>
@@ -3827,7 +3756,7 @@
                 <a:srgbClr val="123A63"/>
               </a:gs>
             </a:gsLst>
-            <a:lin ang="12000000" scaled="0"/>
+            <a:lin ang="0" scaled="0"/>
           </a:gradFill>
         </p:spPr>
         <p:style>
@@ -3860,54 +3789,8 @@
         </p:nvSpPr>
         <p:spPr>
           <a:xfrm>
-            <a:off x="-1005840" y="-914400"/>
-            <a:ext cx="2926080" cy="2926080"/>
-          </a:xfrm>
-          <a:prstGeom prst="ellipse">
-            <a:avLst/>
-          </a:prstGeom>
-          <a:solidFill>
-            <a:srgbClr val="3A7CA5">
-              <a:alpha val="18000"/>
-            </a:srgbClr>
-          </a:solidFill>
-          <a:ln>
-            <a:noFill/>
-          </a:ln>
-          <a:effectLst/>
-        </p:spPr>
-        <p:style>
-          <a:lnRef idx="1">
-            <a:schemeClr val="accent1"/>
-          </a:lnRef>
-          <a:fillRef idx="3">
-            <a:schemeClr val="accent1"/>
-          </a:fillRef>
-          <a:effectRef idx="2">
-            <a:schemeClr val="accent1"/>
-          </a:effectRef>
-          <a:fontRef idx="minor">
-            <a:schemeClr val="lt1"/>
-          </a:fontRef>
-        </p:style>
-        <p:txBody>
-          <a:bodyPr rtlCol="0" anchor="ctr"/>
-          <a:lstStyle/>
-          <a:p>
-            <a:pPr algn="ctr"/>
-          </a:p>
-        </p:txBody>
-      </p:sp>
-      <p:sp>
-        <p:nvSpPr>
-          <p:cNvPr id="4" name="Oval 3"/>
-          <p:cNvSpPr/>
-          <p:nvPr/>
-        </p:nvSpPr>
-        <p:spPr>
-          <a:xfrm>
-            <a:off x="2103120" y="5120640"/>
-            <a:ext cx="2377440" cy="2377440"/>
+            <a:off x="10607040" y="-640080"/>
+            <a:ext cx="2194560" cy="2194560"/>
           </a:xfrm>
           <a:prstGeom prst="ellipse">
             <a:avLst/>
@@ -3946,7 +3829,7 @@
       </p:sp>
       <p:pic>
         <p:nvPicPr>
-          <p:cNvPr id="5" name="Picture 4" descr="research-intro-portrait.png"/>
+          <p:cNvPr id="4" name="Picture 3" descr="research-intro-portrait.png"/>
           <p:cNvPicPr>
             <a:picLocks noChangeAspect="1"/>
           </p:cNvPicPr>
@@ -3960,8 +3843,8 @@
         </p:blipFill>
         <p:spPr>
           <a:xfrm>
-            <a:off x="713232" y="502920"/>
-            <a:ext cx="2267712" cy="2267712"/>
+            <a:off x="384048" y="201168"/>
+            <a:ext cx="1353312" cy="1353312"/>
           </a:xfrm>
           <a:prstGeom prst="rect">
             <a:avLst/>
@@ -3970,241 +3853,14 @@
       </p:pic>
       <p:sp>
         <p:nvSpPr>
-          <p:cNvPr id="6" name="TextBox 5"/>
+          <p:cNvPr id="5" name="TextBox 4"/>
           <p:cNvSpPr txBox="1"/>
           <p:nvPr/>
         </p:nvSpPr>
         <p:spPr>
           <a:xfrm>
-            <a:off x="228600" y="2944368"/>
-            <a:ext cx="3246120" cy="438912"/>
-          </a:xfrm>
-          <a:prstGeom prst="rect">
-            <a:avLst/>
-          </a:prstGeom>
-          <a:noFill/>
-        </p:spPr>
-        <p:txBody>
-          <a:bodyPr wrap="square" lIns="36576" rIns="36576" tIns="18288" bIns="18288" anchor="t"/>
-          <a:lstStyle/>
-          <a:p>
-            <a:pPr algn="ctr">
-              <a:lnSpc>
-                <a:spcPct val="118000"/>
-              </a:lnSpc>
-              <a:spcAft>
-                <a:spcPts val="0"/>
-              </a:spcAft>
-            </a:pPr>
-            <a:r>
-              <a:rPr sz="2800" b="1">
-                <a:solidFill>
-                  <a:srgbClr val="FFFFFF"/>
-                </a:solidFill>
-                <a:latin typeface="微软雅黑"/>
-                <a:ea typeface="微软雅黑"/>
-              </a:rPr>
-              <a:t>徐安察</a:t>
-            </a:r>
-          </a:p>
-        </p:txBody>
-      </p:sp>
-      <p:sp>
-        <p:nvSpPr>
-          <p:cNvPr id="7" name="TextBox 6"/>
-          <p:cNvSpPr txBox="1"/>
-          <p:nvPr/>
-        </p:nvSpPr>
-        <p:spPr>
-          <a:xfrm>
-            <a:off x="228600" y="3401568"/>
-            <a:ext cx="3246120" cy="292608"/>
-          </a:xfrm>
-          <a:prstGeom prst="rect">
-            <a:avLst/>
-          </a:prstGeom>
-          <a:noFill/>
-        </p:spPr>
-        <p:txBody>
-          <a:bodyPr wrap="square" lIns="36576" rIns="36576" tIns="18288" bIns="18288" anchor="t"/>
-          <a:lstStyle/>
-          <a:p>
-            <a:pPr algn="ctr">
-              <a:lnSpc>
-                <a:spcPct val="118000"/>
-              </a:lnSpc>
-              <a:spcAft>
-                <a:spcPts val="0"/>
-              </a:spcAft>
-            </a:pPr>
-            <a:r>
-              <a:rPr sz="1300" b="1">
-                <a:solidFill>
-                  <a:srgbClr val="3A7CA5"/>
-                </a:solidFill>
-                <a:latin typeface="微软雅黑"/>
-                <a:ea typeface="微软雅黑"/>
-              </a:rPr>
-              <a:t>教授  ·  博士生导师</a:t>
-            </a:r>
-          </a:p>
-        </p:txBody>
-      </p:sp>
-      <p:sp>
-        <p:nvSpPr>
-          <p:cNvPr id="8" name="Rectangle 7"/>
-          <p:cNvSpPr/>
-          <p:nvPr/>
-        </p:nvSpPr>
-        <p:spPr>
-          <a:xfrm>
-            <a:off x="1554480" y="3785615"/>
-            <a:ext cx="585216" cy="27432"/>
-          </a:xfrm>
-          <a:prstGeom prst="rect">
-            <a:avLst/>
-          </a:prstGeom>
-          <a:solidFill>
-            <a:srgbClr val="3A7CA5"/>
-          </a:solidFill>
-          <a:ln>
-            <a:noFill/>
-          </a:ln>
-          <a:effectLst/>
-        </p:spPr>
-        <p:style>
-          <a:lnRef idx="1">
-            <a:schemeClr val="accent1"/>
-          </a:lnRef>
-          <a:fillRef idx="3">
-            <a:schemeClr val="accent1"/>
-          </a:fillRef>
-          <a:effectRef idx="2">
-            <a:schemeClr val="accent1"/>
-          </a:effectRef>
-          <a:fontRef idx="minor">
-            <a:schemeClr val="lt1"/>
-          </a:fontRef>
-        </p:style>
-        <p:txBody>
-          <a:bodyPr rtlCol="0" anchor="ctr"/>
-          <a:lstStyle/>
-          <a:p>
-            <a:pPr algn="ctr"/>
-          </a:p>
-        </p:txBody>
-      </p:sp>
-      <p:sp>
-        <p:nvSpPr>
-          <p:cNvPr id="9" name="TextBox 8"/>
-          <p:cNvSpPr txBox="1"/>
-          <p:nvPr/>
-        </p:nvSpPr>
-        <p:spPr>
-          <a:xfrm>
-            <a:off x="228600" y="3950208"/>
-            <a:ext cx="3246120" cy="1051560"/>
-          </a:xfrm>
-          <a:prstGeom prst="rect">
-            <a:avLst/>
-          </a:prstGeom>
-          <a:noFill/>
-        </p:spPr>
-        <p:txBody>
-          <a:bodyPr wrap="square" lIns="36576" rIns="36576" tIns="18288" bIns="18288" anchor="t"/>
-          <a:lstStyle/>
-          <a:p>
-            <a:pPr algn="ctr">
-              <a:lnSpc>
-                <a:spcPct val="118000"/>
-              </a:lnSpc>
-              <a:spcAft>
-                <a:spcPts val="300"/>
-              </a:spcAft>
-            </a:pPr>
-            <a:r>
-              <a:rPr sz="1300" b="0">
-                <a:solidFill>
-                  <a:srgbClr val="C5D6E6"/>
-                </a:solidFill>
-                <a:latin typeface="微软雅黑"/>
-                <a:ea typeface="微软雅黑"/>
-              </a:rPr>
-              <a:t>浙江工商大学</a:t>
-            </a:r>
-          </a:p>
-          <a:p>
-            <a:pPr algn="ctr">
-              <a:lnSpc>
-                <a:spcPct val="118000"/>
-              </a:lnSpc>
-              <a:spcAft>
-                <a:spcPts val="1000"/>
-              </a:spcAft>
-            </a:pPr>
-            <a:r>
-              <a:rPr sz="1300" b="0">
-                <a:solidFill>
-                  <a:srgbClr val="C5D6E6"/>
-                </a:solidFill>
-                <a:latin typeface="微软雅黑"/>
-                <a:ea typeface="微软雅黑"/>
-              </a:rPr>
-              <a:t>统计与数据科学学院</a:t>
-            </a:r>
-          </a:p>
-          <a:p>
-            <a:pPr algn="ctr">
-              <a:lnSpc>
-                <a:spcPct val="118000"/>
-              </a:lnSpc>
-              <a:spcAft>
-                <a:spcPts val="300"/>
-              </a:spcAft>
-            </a:pPr>
-            <a:r>
-              <a:rPr sz="1100" b="0">
-                <a:solidFill>
-                  <a:srgbClr val="B8CDDE"/>
-                </a:solidFill>
-                <a:latin typeface="微软雅黑"/>
-                <a:ea typeface="微软雅黑"/>
-              </a:rPr>
-              <a:t>xuancha@mail.zjgsu.edu.cn</a:t>
-            </a:r>
-          </a:p>
-          <a:p>
-            <a:pPr algn="ctr">
-              <a:lnSpc>
-                <a:spcPct val="118000"/>
-              </a:lnSpc>
-              <a:spcAft>
-                <a:spcPts val="0"/>
-              </a:spcAft>
-            </a:pPr>
-            <a:r>
-              <a:rPr sz="1100" b="0">
-                <a:solidFill>
-                  <a:srgbClr val="B8CDDE"/>
-                </a:solidFill>
-                <a:latin typeface="微软雅黑"/>
-                <a:ea typeface="微软雅黑"/>
-              </a:rPr>
-              <a:t>www.xu-ancha.com</a:t>
-            </a:r>
-          </a:p>
-        </p:txBody>
-      </p:sp>
-      <p:sp>
-        <p:nvSpPr>
-          <p:cNvPr id="10" name="TextBox 9"/>
-          <p:cNvSpPr txBox="1"/>
-          <p:nvPr/>
-        </p:nvSpPr>
-        <p:spPr>
-          <a:xfrm>
-            <a:off x="4069080" y="329184"/>
-            <a:ext cx="7680960" cy="219456"/>
+            <a:off x="1920240" y="256032"/>
+            <a:ext cx="7772400" cy="402336"/>
           </a:xfrm>
           <a:prstGeom prst="rect">
             <a:avLst/>
@@ -4224,28 +3880,28 @@
               </a:spcAft>
             </a:pPr>
             <a:r>
-              <a:rPr sz="1200" b="0">
+              <a:rPr sz="2600" b="1">
                 <a:solidFill>
-                  <a:srgbClr val="3A7CA5"/>
+                  <a:srgbClr val="FFFFFF"/>
                 </a:solidFill>
                 <a:latin typeface="微软雅黑"/>
                 <a:ea typeface="微软雅黑"/>
               </a:rPr>
-              <a:t>浙江工商大学统计与数据科学学院</a:t>
-            </a:r>
-          </a:p>
-        </p:txBody>
-      </p:sp>
-      <p:sp>
-        <p:nvSpPr>
-          <p:cNvPr id="11" name="TextBox 10"/>
+              <a:t>徐安察</a:t>
+            </a:r>
+          </a:p>
+        </p:txBody>
+      </p:sp>
+      <p:sp>
+        <p:nvSpPr>
+          <p:cNvPr id="6" name="TextBox 5"/>
           <p:cNvSpPr txBox="1"/>
           <p:nvPr/>
         </p:nvSpPr>
         <p:spPr>
           <a:xfrm>
-            <a:off x="4069080" y="566928"/>
-            <a:ext cx="7680960" cy="402336"/>
+            <a:off x="1920240" y="676656"/>
+            <a:ext cx="7772400" cy="256032"/>
           </a:xfrm>
           <a:prstGeom prst="rect">
             <a:avLst/>
@@ -4265,72 +3921,28 @@
               </a:spcAft>
             </a:pPr>
             <a:r>
-              <a:rPr sz="2800" b="1">
+              <a:rPr sz="1400" b="0">
                 <a:solidFill>
-                  <a:srgbClr val="0A1F3D"/>
+                  <a:srgbClr val="3A7CA5"/>
                 </a:solidFill>
                 <a:latin typeface="微软雅黑"/>
                 <a:ea typeface="微软雅黑"/>
               </a:rPr>
-              <a:t>个人简介</a:t>
-            </a:r>
-          </a:p>
-        </p:txBody>
-      </p:sp>
-      <p:sp>
-        <p:nvSpPr>
-          <p:cNvPr id="12" name="Rectangle 11"/>
-          <p:cNvSpPr/>
-          <p:nvPr/>
-        </p:nvSpPr>
-        <p:spPr>
-          <a:xfrm>
-            <a:off x="4069080" y="1024128"/>
-            <a:ext cx="384048" cy="36576"/>
-          </a:xfrm>
-          <a:prstGeom prst="rect">
-            <a:avLst/>
-          </a:prstGeom>
-          <a:solidFill>
-            <a:srgbClr val="3A7CA5"/>
-          </a:solidFill>
-          <a:ln>
-            <a:noFill/>
-          </a:ln>
-          <a:effectLst/>
-        </p:spPr>
-        <p:style>
-          <a:lnRef idx="1">
-            <a:schemeClr val="accent1"/>
-          </a:lnRef>
-          <a:fillRef idx="3">
-            <a:schemeClr val="accent1"/>
-          </a:fillRef>
-          <a:effectRef idx="2">
-            <a:schemeClr val="accent1"/>
-          </a:effectRef>
-          <a:fontRef idx="minor">
-            <a:schemeClr val="lt1"/>
-          </a:fontRef>
-        </p:style>
-        <p:txBody>
-          <a:bodyPr rtlCol="0" anchor="ctr"/>
-          <a:lstStyle/>
-          <a:p>
-            <a:pPr algn="ctr"/>
-          </a:p>
-        </p:txBody>
-      </p:sp>
-      <p:sp>
-        <p:nvSpPr>
-          <p:cNvPr id="13" name="TextBox 12"/>
+              <a:t>教授、博士生导师</a:t>
+            </a:r>
+          </a:p>
+        </p:txBody>
+      </p:sp>
+      <p:sp>
+        <p:nvSpPr>
+          <p:cNvPr id="7" name="TextBox 6"/>
           <p:cNvSpPr txBox="1"/>
           <p:nvPr/>
         </p:nvSpPr>
         <p:spPr>
           <a:xfrm>
-            <a:off x="4069080" y="1170432"/>
-            <a:ext cx="7680960" cy="502920"/>
+            <a:off x="1920240" y="969264"/>
+            <a:ext cx="9601200" cy="585216"/>
           </a:xfrm>
           <a:prstGeom prst="rect">
             <a:avLst/>
@@ -4346,18 +3958,18 @@
                 <a:spcPct val="118000"/>
               </a:lnSpc>
               <a:spcAft>
-                <a:spcPts val="200"/>
+                <a:spcPts val="300"/>
               </a:spcAft>
             </a:pPr>
             <a:r>
-              <a:rPr sz="1500" b="0">
+              <a:rPr sz="1300" b="0">
                 <a:solidFill>
-                  <a:srgbClr val="122033"/>
+                  <a:srgbClr val="C5D6E6"/>
                 </a:solidFill>
                 <a:latin typeface="微软雅黑"/>
                 <a:ea typeface="微软雅黑"/>
               </a:rPr>
-              <a:t>主要做退化数据、寿命数据和贝叶斯方法。</a:t>
+              <a:t>浙江工商大学统计与数据科学学院</a:t>
             </a:r>
           </a:p>
           <a:p>
@@ -4370,28 +3982,154 @@
               </a:spcAft>
             </a:pPr>
             <a:r>
-              <a:rPr sz="1500" b="0">
+              <a:rPr sz="1300" b="0">
                 <a:solidFill>
-                  <a:srgbClr val="122033"/>
+                  <a:srgbClr val="B8CDDE"/>
                 </a:solidFill>
                 <a:latin typeface="微软雅黑"/>
                 <a:ea typeface="微软雅黑"/>
               </a:rPr>
-              <a:t>下面分教学、人才培养和科研说一下。</a:t>
-            </a:r>
-          </a:p>
-        </p:txBody>
-      </p:sp>
-      <p:sp>
-        <p:nvSpPr>
-          <p:cNvPr id="14" name="Rounded Rectangle 13"/>
+              <a:t>主要研究退化数据分析、寿命数据与贝叶斯推断。</a:t>
+            </a:r>
+          </a:p>
+        </p:txBody>
+      </p:sp>
+      <p:sp>
+        <p:nvSpPr>
+          <p:cNvPr id="8" name="Rectangle 7"/>
           <p:cNvSpPr/>
           <p:nvPr/>
         </p:nvSpPr>
         <p:spPr>
           <a:xfrm>
-            <a:off x="4069080" y="1810512"/>
-            <a:ext cx="3840480" cy="4498848"/>
+            <a:off x="0" y="6638544"/>
+            <a:ext cx="12191695" cy="219456"/>
+          </a:xfrm>
+          <a:prstGeom prst="rect">
+            <a:avLst/>
+          </a:prstGeom>
+          <a:solidFill>
+            <a:srgbClr val="0A1F3D"/>
+          </a:solidFill>
+          <a:ln>
+            <a:noFill/>
+          </a:ln>
+          <a:effectLst/>
+        </p:spPr>
+        <p:style>
+          <a:lnRef idx="1">
+            <a:schemeClr val="accent1"/>
+          </a:lnRef>
+          <a:fillRef idx="3">
+            <a:schemeClr val="accent1"/>
+          </a:fillRef>
+          <a:effectRef idx="2">
+            <a:schemeClr val="accent1"/>
+          </a:effectRef>
+          <a:fontRef idx="minor">
+            <a:schemeClr val="lt1"/>
+          </a:fontRef>
+        </p:style>
+        <p:txBody>
+          <a:bodyPr rtlCol="0" anchor="ctr"/>
+          <a:lstStyle/>
+          <a:p>
+            <a:pPr algn="ctr"/>
+          </a:p>
+        </p:txBody>
+      </p:sp>
+      <p:sp>
+        <p:nvSpPr>
+          <p:cNvPr id="9" name="TextBox 8"/>
+          <p:cNvSpPr txBox="1"/>
+          <p:nvPr/>
+        </p:nvSpPr>
+        <p:spPr>
+          <a:xfrm>
+            <a:off x="457200" y="6638544"/>
+            <a:ext cx="9326880" cy="219456"/>
+          </a:xfrm>
+          <a:prstGeom prst="rect">
+            <a:avLst/>
+          </a:prstGeom>
+          <a:noFill/>
+        </p:spPr>
+        <p:txBody>
+          <a:bodyPr wrap="square" lIns="36576" rIns="36576" tIns="18288" bIns="18288" anchor="ctr"/>
+          <a:lstStyle/>
+          <a:p>
+            <a:pPr algn="l">
+              <a:lnSpc>
+                <a:spcPct val="118000"/>
+              </a:lnSpc>
+              <a:spcAft>
+                <a:spcPts val="0"/>
+              </a:spcAft>
+            </a:pPr>
+            <a:r>
+              <a:rPr sz="1000" b="0">
+                <a:solidFill>
+                  <a:srgbClr val="B8CDDE"/>
+                </a:solidFill>
+                <a:latin typeface="微软雅黑"/>
+                <a:ea typeface="微软雅黑"/>
+              </a:rPr>
+              <a:t>徐安察    浙江工商大学统计与数据科学学院</a:t>
+            </a:r>
+          </a:p>
+        </p:txBody>
+      </p:sp>
+      <p:sp>
+        <p:nvSpPr>
+          <p:cNvPr id="10" name="TextBox 9"/>
+          <p:cNvSpPr txBox="1"/>
+          <p:nvPr/>
+        </p:nvSpPr>
+        <p:spPr>
+          <a:xfrm>
+            <a:off x="10515600" y="6638544"/>
+            <a:ext cx="1280160" cy="219456"/>
+          </a:xfrm>
+          <a:prstGeom prst="rect">
+            <a:avLst/>
+          </a:prstGeom>
+          <a:noFill/>
+        </p:spPr>
+        <p:txBody>
+          <a:bodyPr wrap="square" lIns="36576" rIns="36576" tIns="18288" bIns="18288" anchor="ctr"/>
+          <a:lstStyle/>
+          <a:p>
+            <a:pPr algn="r">
+              <a:lnSpc>
+                <a:spcPct val="118000"/>
+              </a:lnSpc>
+              <a:spcAft>
+                <a:spcPts val="0"/>
+              </a:spcAft>
+            </a:pPr>
+            <a:r>
+              <a:rPr sz="1000" b="0">
+                <a:solidFill>
+                  <a:srgbClr val="C5D6E6"/>
+                </a:solidFill>
+                <a:latin typeface="微软雅黑"/>
+                <a:ea typeface="微软雅黑"/>
+              </a:rPr>
+              <a:t>01  /  04</a:t>
+            </a:r>
+          </a:p>
+        </p:txBody>
+      </p:sp>
+      <p:sp>
+        <p:nvSpPr>
+          <p:cNvPr id="11" name="Rounded Rectangle 10"/>
+          <p:cNvSpPr/>
+          <p:nvPr/>
+        </p:nvSpPr>
+        <p:spPr>
+          <a:xfrm>
+            <a:off x="384048" y="1956816"/>
+            <a:ext cx="3767328" cy="4480560"/>
           </a:xfrm>
           <a:prstGeom prst="roundRect">
             <a:avLst>
@@ -4432,14 +4170,14 @@
       </p:sp>
       <p:sp>
         <p:nvSpPr>
-          <p:cNvPr id="15" name="Rectangle 14"/>
+          <p:cNvPr id="12" name="Rectangle 11"/>
           <p:cNvSpPr/>
           <p:nvPr/>
         </p:nvSpPr>
         <p:spPr>
           <a:xfrm>
-            <a:off x="4069080" y="1810512"/>
-            <a:ext cx="64008" cy="4498848"/>
+            <a:off x="384048" y="1956816"/>
+            <a:ext cx="3767328" cy="54864"/>
           </a:xfrm>
           <a:prstGeom prst="rect">
             <a:avLst/>
@@ -4476,14 +4214,14 @@
       </p:sp>
       <p:sp>
         <p:nvSpPr>
-          <p:cNvPr id="16" name="TextBox 15"/>
+          <p:cNvPr id="13" name="TextBox 12"/>
           <p:cNvSpPr txBox="1"/>
           <p:nvPr/>
         </p:nvSpPr>
         <p:spPr>
           <a:xfrm>
-            <a:off x="4315968" y="1938528"/>
-            <a:ext cx="3429000" cy="292608"/>
+            <a:off x="548640" y="2103120"/>
+            <a:ext cx="3438144" cy="365760"/>
           </a:xfrm>
           <a:prstGeom prst="rect">
             <a:avLst/>
@@ -4503,7 +4241,7 @@
               </a:spcAft>
             </a:pPr>
             <a:r>
-              <a:rPr sz="1500" b="1">
+              <a:rPr sz="1600" b="1">
                 <a:solidFill>
                   <a:srgbClr val="0A1F3D"/>
                 </a:solidFill>
@@ -4517,14 +4255,14 @@
       </p:sp>
       <p:sp>
         <p:nvSpPr>
-          <p:cNvPr id="17" name="TextBox 16"/>
+          <p:cNvPr id="14" name="TextBox 13"/>
           <p:cNvSpPr txBox="1"/>
           <p:nvPr/>
         </p:nvSpPr>
         <p:spPr>
           <a:xfrm>
-            <a:off x="4315968" y="2304288"/>
-            <a:ext cx="3429000" cy="3840480"/>
+            <a:off x="548640" y="2542032"/>
+            <a:ext cx="3438144" cy="3749039"/>
           </a:xfrm>
           <a:prstGeom prst="rect">
             <a:avLst/>
@@ -4534,46 +4272,6 @@
         <p:txBody>
           <a:bodyPr wrap="square" lIns="36576" rIns="36576" tIns="18288" bIns="18288" anchor="t"/>
           <a:lstStyle/>
-          <a:p>
-            <a:pPr algn="l">
-              <a:lnSpc>
-                <a:spcPct val="118000"/>
-              </a:lnSpc>
-              <a:spcAft>
-                <a:spcPts val="200"/>
-              </a:spcAft>
-            </a:pPr>
-            <a:r>
-              <a:rPr sz="1300" b="0">
-                <a:solidFill>
-                  <a:srgbClr val="122033"/>
-                </a:solidFill>
-                <a:latin typeface="微软雅黑"/>
-                <a:ea typeface="微软雅黑"/>
-              </a:rPr>
-              <a:t>本科开过统计质量管理、贝叶斯数据</a:t>
-            </a:r>
-          </a:p>
-          <a:p>
-            <a:pPr algn="l">
-              <a:lnSpc>
-                <a:spcPct val="118000"/>
-              </a:lnSpc>
-              <a:spcAft>
-                <a:spcPts val="200"/>
-              </a:spcAft>
-            </a:pPr>
-            <a:r>
-              <a:rPr sz="1300" b="0">
-                <a:solidFill>
-                  <a:srgbClr val="122033"/>
-                </a:solidFill>
-                <a:latin typeface="微软雅黑"/>
-                <a:ea typeface="微软雅黑"/>
-              </a:rPr>
-              <a:t>分析、概率论；研究生开过可靠性、</a:t>
-            </a:r>
-          </a:p>
           <a:p>
             <a:pPr algn="l">
               <a:lnSpc>
@@ -4591,47 +4289,7 @@
                 <a:latin typeface="微软雅黑"/>
                 <a:ea typeface="微软雅黑"/>
               </a:rPr>
-              <a:t>贝叶斯计算。</a:t>
-            </a:r>
-          </a:p>
-          <a:p>
-            <a:pPr algn="l">
-              <a:lnSpc>
-                <a:spcPct val="118000"/>
-              </a:lnSpc>
-              <a:spcAft>
-                <a:spcPts val="200"/>
-              </a:spcAft>
-            </a:pPr>
-            <a:r>
-              <a:rPr sz="1300" b="0">
-                <a:solidFill>
-                  <a:srgbClr val="122033"/>
-                </a:solidFill>
-                <a:latin typeface="微软雅黑"/>
-                <a:ea typeface="微软雅黑"/>
-              </a:rPr>
-              <a:t>带博士和硕士。学生里有人拿到国家</a:t>
-            </a:r>
-          </a:p>
-          <a:p>
-            <a:pPr algn="l">
-              <a:lnSpc>
-                <a:spcPct val="118000"/>
-              </a:lnSpc>
-              <a:spcAft>
-                <a:spcPts val="200"/>
-              </a:spcAft>
-            </a:pPr>
-            <a:r>
-              <a:rPr sz="1300" b="0">
-                <a:solidFill>
-                  <a:srgbClr val="122033"/>
-                </a:solidFill>
-                <a:latin typeface="微软雅黑"/>
-                <a:ea typeface="微软雅黑"/>
-              </a:rPr>
-              <a:t>奖学金，也有人去了南京理工大学、</a:t>
+              <a:t>本科承担统计质量管理、贝叶斯数据分析、概率论等课程；研究生开设可靠性、贝叶斯计算等。</a:t>
             </a:r>
           </a:p>
           <a:p>
@@ -4651,7 +4309,7 @@
                 <a:latin typeface="微软雅黑"/>
                 <a:ea typeface="微软雅黑"/>
               </a:rPr>
-              <a:t>温州大学等高校。</a:t>
+              <a:t>指导博士、硕士研究生。学生获国家奖学金，并有多人进入南京理工大学、温州大学等高校工作。</a:t>
             </a:r>
           </a:p>
           <a:p>
@@ -4671,41 +4329,21 @@
                 <a:latin typeface="微软雅黑"/>
                 <a:ea typeface="微软雅黑"/>
               </a:rPr>
-              <a:t>两次评上「我心目中的好导师」。</a:t>
-            </a:r>
-          </a:p>
-          <a:p>
-            <a:pPr algn="l">
-              <a:lnSpc>
-                <a:spcPct val="118000"/>
-              </a:lnSpc>
-              <a:spcAft>
-                <a:spcPts val="0"/>
-              </a:spcAft>
-            </a:pPr>
-            <a:r>
-              <a:rPr sz="1300" b="0">
-                <a:solidFill>
-                  <a:srgbClr val="122033"/>
-                </a:solidFill>
-                <a:latin typeface="微软雅黑"/>
-                <a:ea typeface="微软雅黑"/>
-              </a:rPr>
-              <a:t>带过挑战杯，作品拿到过全国二等奖。</a:t>
-            </a:r>
-          </a:p>
-        </p:txBody>
-      </p:sp>
-      <p:sp>
-        <p:nvSpPr>
-          <p:cNvPr id="18" name="Rounded Rectangle 17"/>
+              <a:t>两次获评「我心目中的好导师」。指导学生参加挑战杯，作品获全国二等奖。</a:t>
+            </a:r>
+          </a:p>
+        </p:txBody>
+      </p:sp>
+      <p:sp>
+        <p:nvSpPr>
+          <p:cNvPr id="15" name="Rounded Rectangle 14"/>
           <p:cNvSpPr/>
           <p:nvPr/>
         </p:nvSpPr>
         <p:spPr>
           <a:xfrm>
-            <a:off x="8092440" y="1810512"/>
-            <a:ext cx="3657600" cy="4498848"/>
+            <a:off x="4297680" y="1956816"/>
+            <a:ext cx="3767328" cy="4480560"/>
           </a:xfrm>
           <a:prstGeom prst="roundRect">
             <a:avLst>
@@ -4746,14 +4384,14 @@
       </p:sp>
       <p:sp>
         <p:nvSpPr>
-          <p:cNvPr id="19" name="Rectangle 18"/>
+          <p:cNvPr id="16" name="Rectangle 15"/>
           <p:cNvSpPr/>
           <p:nvPr/>
         </p:nvSpPr>
         <p:spPr>
           <a:xfrm>
-            <a:off x="8092440" y="1810512"/>
-            <a:ext cx="64008" cy="4498848"/>
+            <a:off x="4297680" y="1956816"/>
+            <a:ext cx="3767328" cy="54864"/>
           </a:xfrm>
           <a:prstGeom prst="rect">
             <a:avLst/>
@@ -4790,14 +4428,14 @@
       </p:sp>
       <p:sp>
         <p:nvSpPr>
-          <p:cNvPr id="20" name="TextBox 19"/>
+          <p:cNvPr id="17" name="TextBox 16"/>
           <p:cNvSpPr txBox="1"/>
           <p:nvPr/>
         </p:nvSpPr>
         <p:spPr>
           <a:xfrm>
-            <a:off x="8339327" y="1938528"/>
-            <a:ext cx="3246120" cy="292608"/>
+            <a:off x="4462272" y="2103120"/>
+            <a:ext cx="3438144" cy="365760"/>
           </a:xfrm>
           <a:prstGeom prst="rect">
             <a:avLst/>
@@ -4817,7 +4455,7 @@
               </a:spcAft>
             </a:pPr>
             <a:r>
-              <a:rPr sz="1500" b="1">
+              <a:rPr sz="1600" b="1">
                 <a:solidFill>
                   <a:srgbClr val="0A1F3D"/>
                 </a:solidFill>
@@ -4831,14 +4469,14 @@
       </p:sp>
       <p:sp>
         <p:nvSpPr>
-          <p:cNvPr id="21" name="TextBox 20"/>
+          <p:cNvPr id="18" name="TextBox 17"/>
           <p:cNvSpPr txBox="1"/>
           <p:nvPr/>
         </p:nvSpPr>
         <p:spPr>
           <a:xfrm>
-            <a:off x="8339327" y="2304288"/>
-            <a:ext cx="3246120" cy="3840480"/>
+            <a:off x="4462272" y="2542032"/>
+            <a:ext cx="3438144" cy="3749039"/>
           </a:xfrm>
           <a:prstGeom prst="rect">
             <a:avLst/>
@@ -4848,46 +4486,6 @@
         <p:txBody>
           <a:bodyPr wrap="square" lIns="36576" rIns="36576" tIns="18288" bIns="18288" anchor="t"/>
           <a:lstStyle/>
-          <a:p>
-            <a:pPr algn="l">
-              <a:lnSpc>
-                <a:spcPct val="118000"/>
-              </a:lnSpc>
-              <a:spcAft>
-                <a:spcPts val="200"/>
-              </a:spcAft>
-            </a:pPr>
-            <a:r>
-              <a:rPr sz="1300" b="0">
-                <a:solidFill>
-                  <a:srgbClr val="122033"/>
-                </a:solidFill>
-                <a:latin typeface="微软雅黑"/>
-                <a:ea typeface="微软雅黑"/>
-              </a:rPr>
-              <a:t>一作或通讯六十多篇，其中 6 篇是</a:t>
-            </a:r>
-          </a:p>
-          <a:p>
-            <a:pPr algn="l">
-              <a:lnSpc>
-                <a:spcPct val="118000"/>
-              </a:lnSpc>
-              <a:spcAft>
-                <a:spcPts val="200"/>
-              </a:spcAft>
-            </a:pPr>
-            <a:r>
-              <a:rPr sz="1300" b="0">
-                <a:solidFill>
-                  <a:srgbClr val="122033"/>
-                </a:solidFill>
-                <a:latin typeface="微软雅黑"/>
-                <a:ea typeface="微软雅黑"/>
-              </a:rPr>
-              <a:t>ESI 高被引。刊物主要是 NRL、SJS、</a:t>
-            </a:r>
-          </a:p>
           <a:p>
             <a:pPr algn="l">
               <a:lnSpc>
@@ -4905,27 +4503,7 @@
                 <a:latin typeface="微软雅黑"/>
                 <a:ea typeface="微软雅黑"/>
               </a:rPr>
-              <a:t>JQT、EJOR、IEEE TR、IISE。</a:t>
-            </a:r>
-          </a:p>
-          <a:p>
-            <a:pPr algn="l">
-              <a:lnSpc>
-                <a:spcPct val="118000"/>
-              </a:lnSpc>
-              <a:spcAft>
-                <a:spcPts val="200"/>
-              </a:spcAft>
-            </a:pPr>
-            <a:r>
-              <a:rPr sz="1300" b="0">
-                <a:solidFill>
-                  <a:srgbClr val="122033"/>
-                </a:solidFill>
-                <a:latin typeface="微软雅黑"/>
-                <a:ea typeface="微软雅黑"/>
-              </a:rPr>
-              <a:t>2025 年出了一本《随机退化过程与</a:t>
+              <a:t>以第一或通讯作者发表论文六十余篇，其中 ESI 高被引论文 6 篇。刊物包括 NRL、SJS、JQT、EJOR、IEEE TR、IISE Transactions。</a:t>
             </a:r>
           </a:p>
           <a:p>
@@ -4945,27 +4523,7 @@
                 <a:latin typeface="微软雅黑"/>
                 <a:ea typeface="微软雅黑"/>
               </a:rPr>
-              <a:t>统计建模》。</a:t>
-            </a:r>
-          </a:p>
-          <a:p>
-            <a:pPr algn="l">
-              <a:lnSpc>
-                <a:spcPct val="118000"/>
-              </a:lnSpc>
-              <a:spcAft>
-                <a:spcPts val="200"/>
-              </a:spcAft>
-            </a:pPr>
-            <a:r>
-              <a:rPr sz="1300" b="0">
-                <a:solidFill>
-                  <a:srgbClr val="122033"/>
-                </a:solidFill>
-                <a:latin typeface="微软雅黑"/>
-                <a:ea typeface="微软雅黑"/>
-              </a:rPr>
-              <a:t>主持国自然青年基金和三项面上，</a:t>
+              <a:t>2025 年出版专著《随机退化过程与统计建模》。</a:t>
             </a:r>
           </a:p>
           <a:p>
@@ -4985,29 +4543,122 @@
                 <a:latin typeface="微软雅黑"/>
                 <a:ea typeface="微软雅黑"/>
               </a:rPr>
-              <a:t>还有省基金重点。</a:t>
-            </a:r>
-          </a:p>
-          <a:p>
-            <a:pPr algn="l">
-              <a:lnSpc>
-                <a:spcPct val="118000"/>
-              </a:lnSpc>
-              <a:spcAft>
-                <a:spcPts val="200"/>
-              </a:spcAft>
-            </a:pPr>
-            <a:r>
-              <a:rPr sz="1300" b="0">
-                <a:solidFill>
-                  <a:srgbClr val="122033"/>
-                </a:solidFill>
-                <a:latin typeface="微软雅黑"/>
-                <a:ea typeface="微软雅黑"/>
-              </a:rPr>
-              <a:t>省自然科学奖。现在是可靠性分会</a:t>
-            </a:r>
-          </a:p>
+              <a:t>主持国家自然科学基金青年项目 1 项、面上项目 3 项，以及浙江省自然科学基金重点项目等。获浙江省自然科学奖。</a:t>
+            </a:r>
+          </a:p>
+        </p:txBody>
+      </p:sp>
+      <p:sp>
+        <p:nvSpPr>
+          <p:cNvPr id="19" name="Rounded Rectangle 18"/>
+          <p:cNvSpPr/>
+          <p:nvPr/>
+        </p:nvSpPr>
+        <p:spPr>
+          <a:xfrm>
+            <a:off x="8211312" y="1956816"/>
+            <a:ext cx="3767328" cy="4480560"/>
+          </a:xfrm>
+          <a:prstGeom prst="roundRect">
+            <a:avLst>
+              <a:gd name="adj" fmla="val 5000"/>
+            </a:avLst>
+          </a:prstGeom>
+          <a:solidFill>
+            <a:srgbClr val="FFFFFF"/>
+          </a:solidFill>
+          <a:ln w="6350">
+            <a:solidFill>
+              <a:srgbClr val="D0DCE6"/>
+            </a:solidFill>
+          </a:ln>
+          <a:effectLst/>
+        </p:spPr>
+        <p:style>
+          <a:lnRef idx="1">
+            <a:schemeClr val="accent1"/>
+          </a:lnRef>
+          <a:fillRef idx="3">
+            <a:schemeClr val="accent1"/>
+          </a:fillRef>
+          <a:effectRef idx="2">
+            <a:schemeClr val="accent1"/>
+          </a:effectRef>
+          <a:fontRef idx="minor">
+            <a:schemeClr val="lt1"/>
+          </a:fontRef>
+        </p:style>
+        <p:txBody>
+          <a:bodyPr rtlCol="0" anchor="ctr"/>
+          <a:lstStyle/>
+          <a:p>
+            <a:pPr algn="ctr"/>
+          </a:p>
+        </p:txBody>
+      </p:sp>
+      <p:sp>
+        <p:nvSpPr>
+          <p:cNvPr id="20" name="Rectangle 19"/>
+          <p:cNvSpPr/>
+          <p:nvPr/>
+        </p:nvSpPr>
+        <p:spPr>
+          <a:xfrm>
+            <a:off x="8211312" y="1956816"/>
+            <a:ext cx="3767328" cy="54864"/>
+          </a:xfrm>
+          <a:prstGeom prst="rect">
+            <a:avLst/>
+          </a:prstGeom>
+          <a:solidFill>
+            <a:srgbClr val="0A1F3D"/>
+          </a:solidFill>
+          <a:ln>
+            <a:noFill/>
+          </a:ln>
+          <a:effectLst/>
+        </p:spPr>
+        <p:style>
+          <a:lnRef idx="1">
+            <a:schemeClr val="accent1"/>
+          </a:lnRef>
+          <a:fillRef idx="3">
+            <a:schemeClr val="accent1"/>
+          </a:fillRef>
+          <a:effectRef idx="2">
+            <a:schemeClr val="accent1"/>
+          </a:effectRef>
+          <a:fontRef idx="minor">
+            <a:schemeClr val="lt1"/>
+          </a:fontRef>
+        </p:style>
+        <p:txBody>
+          <a:bodyPr rtlCol="0" anchor="ctr"/>
+          <a:lstStyle/>
+          <a:p>
+            <a:pPr algn="ctr"/>
+          </a:p>
+        </p:txBody>
+      </p:sp>
+      <p:sp>
+        <p:nvSpPr>
+          <p:cNvPr id="21" name="TextBox 20"/>
+          <p:cNvSpPr txBox="1"/>
+          <p:nvPr/>
+        </p:nvSpPr>
+        <p:spPr>
+          <a:xfrm>
+            <a:off x="8375904" y="2103120"/>
+            <a:ext cx="3438144" cy="365760"/>
+          </a:xfrm>
+          <a:prstGeom prst="rect">
+            <a:avLst/>
+          </a:prstGeom>
+          <a:noFill/>
+        </p:spPr>
+        <p:txBody>
+          <a:bodyPr wrap="square" lIns="36576" rIns="36576" tIns="18288" bIns="18288" anchor="t"/>
+          <a:lstStyle/>
           <a:p>
             <a:pPr algn="l">
               <a:lnSpc>
@@ -5018,6 +4669,47 @@
               </a:spcAft>
             </a:pPr>
             <a:r>
+              <a:rPr sz="1600" b="1">
+                <a:solidFill>
+                  <a:srgbClr val="0A1F3D"/>
+                </a:solidFill>
+                <a:latin typeface="微软雅黑"/>
+                <a:ea typeface="微软雅黑"/>
+              </a:rPr>
+              <a:t>社会服务</a:t>
+            </a:r>
+          </a:p>
+        </p:txBody>
+      </p:sp>
+      <p:sp>
+        <p:nvSpPr>
+          <p:cNvPr id="22" name="TextBox 21"/>
+          <p:cNvSpPr txBox="1"/>
+          <p:nvPr/>
+        </p:nvSpPr>
+        <p:spPr>
+          <a:xfrm>
+            <a:off x="8375904" y="2542032"/>
+            <a:ext cx="3438144" cy="3749039"/>
+          </a:xfrm>
+          <a:prstGeom prst="rect">
+            <a:avLst/>
+          </a:prstGeom>
+          <a:noFill/>
+        </p:spPr>
+        <p:txBody>
+          <a:bodyPr wrap="square" lIns="36576" rIns="36576" tIns="18288" bIns="18288" anchor="t"/>
+          <a:lstStyle/>
+          <a:p>
+            <a:pPr algn="l">
+              <a:lnSpc>
+                <a:spcPct val="118000"/>
+              </a:lnSpc>
+              <a:spcAft>
+                <a:spcPts val="1000"/>
+              </a:spcAft>
+            </a:pPr>
+            <a:r>
               <a:rPr sz="1300" b="0">
                 <a:solidFill>
                   <a:srgbClr val="122033"/>
@@ -5025,7 +4717,47 @@
                 <a:latin typeface="微软雅黑"/>
                 <a:ea typeface="微软雅黑"/>
               </a:rPr>
-              <a:t>副理事长，STARF 副主编。</a:t>
+              <a:t>中国运筹学会可靠性分会副理事长。</a:t>
+            </a:r>
+          </a:p>
+          <a:p>
+            <a:pPr algn="l">
+              <a:lnSpc>
+                <a:spcPct val="118000"/>
+              </a:lnSpc>
+              <a:spcAft>
+                <a:spcPts val="1000"/>
+              </a:spcAft>
+            </a:pPr>
+            <a:r>
+              <a:rPr sz="1300" b="0">
+                <a:solidFill>
+                  <a:srgbClr val="122033"/>
+                </a:solidFill>
+                <a:latin typeface="微软雅黑"/>
+                <a:ea typeface="微软雅黑"/>
+              </a:rPr>
+              <a:t>中国现场统计研究会可靠性工程分会、大数据统计分会常务理事。Statistical Theory and Related Fields 副主编。</a:t>
+            </a:r>
+          </a:p>
+          <a:p>
+            <a:pPr algn="l">
+              <a:lnSpc>
+                <a:spcPct val="118000"/>
+              </a:lnSpc>
+              <a:spcAft>
+                <a:spcPts val="1000"/>
+              </a:spcAft>
+            </a:pPr>
+            <a:r>
+              <a:rPr sz="1300" b="0">
+                <a:solidFill>
+                  <a:srgbClr val="122033"/>
+                </a:solidFill>
+                <a:latin typeface="微软雅黑"/>
+                <a:ea typeface="微软雅黑"/>
+              </a:rPr>
+              <a:t>与华为等企业合作开展小子样可靠性分析、隐患预警等工作，并整理公开退化与可靠性数据集。</a:t>
             </a:r>
           </a:p>
         </p:txBody>
@@ -5355,7 +5087,7 @@
                 <a:latin typeface="微软雅黑"/>
                 <a:ea typeface="微软雅黑"/>
               </a:rPr>
-              <a:t>02  /  05</a:t>
+              <a:t>02  /  04</a:t>
             </a:r>
           </a:p>
         </p:txBody>
@@ -5368,8 +5100,8 @@
         </p:nvSpPr>
         <p:spPr>
           <a:xfrm>
-            <a:off x="457200" y="1133856"/>
-            <a:ext cx="11247120" cy="2148840"/>
+            <a:off x="457200" y="1115568"/>
+            <a:ext cx="11247120" cy="2331720"/>
           </a:xfrm>
           <a:prstGeom prst="roundRect">
             <a:avLst>
@@ -5416,8 +5148,8 @@
         </p:nvSpPr>
         <p:spPr>
           <a:xfrm>
-            <a:off x="457200" y="1133856"/>
-            <a:ext cx="64008" cy="2148840"/>
+            <a:off x="457200" y="1115568"/>
+            <a:ext cx="64008" cy="2331720"/>
           </a:xfrm>
           <a:prstGeom prst="rect">
             <a:avLst/>
@@ -5460,8 +5192,8 @@
         </p:nvSpPr>
         <p:spPr>
           <a:xfrm>
-            <a:off x="713232" y="1280160"/>
-            <a:ext cx="10789920" cy="1874519"/>
+            <a:off x="713232" y="1243584"/>
+            <a:ext cx="10789920" cy="2084831"/>
           </a:xfrm>
           <a:prstGeom prst="rect">
             <a:avLst/>
@@ -5477,7 +5209,7 @@
                 <a:spcPct val="118000"/>
               </a:lnSpc>
               <a:spcAft>
-                <a:spcPts val="800"/>
+                <a:spcPts val="700"/>
               </a:spcAft>
             </a:pPr>
             <a:r>
@@ -5488,7 +5220,7 @@
                 <a:latin typeface="微软雅黑"/>
                 <a:ea typeface="微软雅黑"/>
               </a:rPr>
-              <a:t>很多高可靠产品，试验期内几乎看不到失效。寿命数据大多是删失，能用的信息很少。</a:t>
+              <a:t>质量强国、制造强国战略对高端装备、电子元器件和航空产品的质量与可靠性提出了更高要求。</a:t>
             </a:r>
           </a:p>
           <a:p>
@@ -5497,7 +5229,7 @@
                 <a:spcPct val="118000"/>
               </a:lnSpc>
               <a:spcAft>
-                <a:spcPts val="800"/>
+                <a:spcPts val="700"/>
               </a:spcAft>
             </a:pPr>
             <a:r>
@@ -5508,7 +5240,7 @@
                 <a:latin typeface="微软雅黑"/>
                 <a:ea typeface="微软雅黑"/>
               </a:rPr>
-              <a:t>现在更常见的是把电流、裂纹、光强、转矩这些量跟着测下来。轨迹本身比失效时间细。</a:t>
+              <a:t>这类产品通常具有高可靠、长寿命的特点。有限试验期内难以获得足够失效，寿命数据以删失为主，信息有限。</a:t>
             </a:r>
           </a:p>
           <a:p>
@@ -5517,7 +5249,7 @@
                 <a:spcPct val="118000"/>
               </a:lnSpc>
               <a:spcAft>
-                <a:spcPts val="800"/>
+                <a:spcPts val="700"/>
               </a:spcAft>
             </a:pPr>
             <a:r>
@@ -5528,7 +5260,7 @@
                 <a:latin typeface="微软雅黑"/>
                 <a:ea typeface="微软雅黑"/>
               </a:rPr>
-              <a:t>问题也跟着来：样本往往不大，指标常常不止一个，个体差异明显，数据还是一批批到的。</a:t>
+              <a:t>与此同时，试验和服役过程中可以连续观测电流、裂纹、光强、转矩等性能指标。退化轨迹比失效时间包含更丰富的过程信息，已成为可靠性评估的重要依据。</a:t>
             </a:r>
           </a:p>
           <a:p>
@@ -5548,7 +5280,7 @@
                 <a:latin typeface="微软雅黑"/>
                 <a:ea typeface="微软雅黑"/>
               </a:rPr>
-              <a:t>先验稍微定偏，后验就会跟着走；每来一批新数据就重估一遍，也不方便。</a:t>
+              <a:t>围绕高质量发展和重大装备自主可控，需要在小样本条件下给出可核验的评估与预测。</a:t>
             </a:r>
           </a:p>
         </p:txBody>
@@ -5561,7 +5293,7 @@
         </p:nvSpPr>
         <p:spPr>
           <a:xfrm>
-            <a:off x="457200" y="3438144"/>
+            <a:off x="457200" y="3602736"/>
             <a:ext cx="11247120" cy="274320"/>
           </a:xfrm>
           <a:prstGeom prst="rect">
@@ -5589,7 +5321,7 @@
                 <a:latin typeface="微软雅黑"/>
                 <a:ea typeface="微软雅黑"/>
               </a:rPr>
-              <a:t>做的时候会碰到的几个具体问题</a:t>
+              <a:t>由此形成的四个问题</a:t>
             </a:r>
           </a:p>
         </p:txBody>
@@ -5602,8 +5334,8 @@
         </p:nvSpPr>
         <p:spPr>
           <a:xfrm>
-            <a:off x="457200" y="3785615"/>
-            <a:ext cx="2788920" cy="1078992"/>
+            <a:off x="457200" y="3950208"/>
+            <a:ext cx="2788920" cy="2468880"/>
           </a:xfrm>
           <a:prstGeom prst="roundRect">
             <a:avLst>
@@ -5650,8 +5382,8 @@
         </p:nvSpPr>
         <p:spPr>
           <a:xfrm>
-            <a:off x="603504" y="3877056"/>
-            <a:ext cx="2514600" cy="292608"/>
+            <a:off x="603504" y="4096512"/>
+            <a:ext cx="2514600" cy="329184"/>
           </a:xfrm>
           <a:prstGeom prst="rect">
             <a:avLst/>
@@ -5678,7 +5410,7 @@
                 <a:latin typeface="微软雅黑"/>
                 <a:ea typeface="微软雅黑"/>
               </a:rPr>
-              <a:t>样本小</a:t>
+              <a:t>样本量偏小</a:t>
             </a:r>
           </a:p>
         </p:txBody>
@@ -5691,8 +5423,8 @@
         </p:nvSpPr>
         <p:spPr>
           <a:xfrm>
-            <a:off x="603504" y="4187952"/>
-            <a:ext cx="2514600" cy="548640"/>
+            <a:off x="603504" y="4498848"/>
+            <a:ext cx="2514600" cy="822960"/>
           </a:xfrm>
           <a:prstGeom prst="rect">
             <a:avLst/>
@@ -5719,7 +5451,7 @@
                 <a:latin typeface="微软雅黑"/>
                 <a:ea typeface="微软雅黑"/>
               </a:rPr>
-              <a:t>失效少，先验不好定</a:t>
+              <a:t>失效稀少，先验设定对后验影响大</a:t>
             </a:r>
           </a:p>
         </p:txBody>
@@ -5732,8 +5464,8 @@
         </p:nvSpPr>
         <p:spPr>
           <a:xfrm>
-            <a:off x="3364992" y="3785615"/>
-            <a:ext cx="2788920" cy="1078992"/>
+            <a:off x="3364992" y="3950208"/>
+            <a:ext cx="2788920" cy="2468880"/>
           </a:xfrm>
           <a:prstGeom prst="roundRect">
             <a:avLst>
@@ -5780,8 +5512,8 @@
         </p:nvSpPr>
         <p:spPr>
           <a:xfrm>
-            <a:off x="3511296" y="3877056"/>
-            <a:ext cx="2514600" cy="292608"/>
+            <a:off x="3511296" y="4096512"/>
+            <a:ext cx="2514600" cy="329184"/>
           </a:xfrm>
           <a:prstGeom prst="rect">
             <a:avLst/>
@@ -5808,7 +5540,7 @@
                 <a:latin typeface="微软雅黑"/>
                 <a:ea typeface="微软雅黑"/>
               </a:rPr>
-              <a:t>指标多</a:t>
+              <a:t>指标多元相依</a:t>
             </a:r>
           </a:p>
         </p:txBody>
@@ -5821,8 +5553,8 @@
         </p:nvSpPr>
         <p:spPr>
           <a:xfrm>
-            <a:off x="3511296" y="4187952"/>
-            <a:ext cx="2514600" cy="548640"/>
+            <a:off x="3511296" y="4498848"/>
+            <a:ext cx="2514600" cy="822960"/>
           </a:xfrm>
           <a:prstGeom prst="rect">
             <a:avLst/>
@@ -5849,7 +5581,7 @@
                 <a:latin typeface="微软雅黑"/>
                 <a:ea typeface="微软雅黑"/>
               </a:rPr>
-              <a:t>几个量一起退化，还可能相关</a:t>
+              <a:t>多个性能量同时退化，尾部常相关</a:t>
             </a:r>
           </a:p>
         </p:txBody>
@@ -5862,8 +5594,8 @@
         </p:nvSpPr>
         <p:spPr>
           <a:xfrm>
-            <a:off x="6272784" y="3785615"/>
-            <a:ext cx="2788920" cy="1078992"/>
+            <a:off x="6272784" y="3950208"/>
+            <a:ext cx="2788920" cy="2468880"/>
           </a:xfrm>
           <a:prstGeom prst="roundRect">
             <a:avLst>
@@ -5910,8 +5642,8 @@
         </p:nvSpPr>
         <p:spPr>
           <a:xfrm>
-            <a:off x="6419088" y="3877056"/>
-            <a:ext cx="2514600" cy="292608"/>
+            <a:off x="6419088" y="4096512"/>
+            <a:ext cx="2514600" cy="329184"/>
           </a:xfrm>
           <a:prstGeom prst="rect">
             <a:avLst/>
@@ -5938,7 +5670,7 @@
                 <a:latin typeface="微软雅黑"/>
                 <a:ea typeface="微软雅黑"/>
               </a:rPr>
-              <a:t>个体差得大</a:t>
+              <a:t>个体异质性</a:t>
             </a:r>
           </a:p>
         </p:txBody>
@@ -5951,8 +5683,8 @@
         </p:nvSpPr>
         <p:spPr>
           <a:xfrm>
-            <a:off x="6419088" y="4187952"/>
-            <a:ext cx="2514600" cy="548640"/>
+            <a:off x="6419088" y="4498848"/>
+            <a:ext cx="2514600" cy="822960"/>
           </a:xfrm>
           <a:prstGeom prst="rect">
             <a:avLst/>
@@ -5979,7 +5711,7 @@
                 <a:latin typeface="微软雅黑"/>
                 <a:ea typeface="微软雅黑"/>
               </a:rPr>
-              <a:t>有随机效应，也有两阶段、两种尺度</a:t>
+              <a:t>随机效应、两阶段变化和双尺度</a:t>
             </a:r>
           </a:p>
         </p:txBody>
@@ -5992,8 +5724,8 @@
         </p:nvSpPr>
         <p:spPr>
           <a:xfrm>
-            <a:off x="9180576" y="3785615"/>
-            <a:ext cx="2788920" cy="1078992"/>
+            <a:off x="9180576" y="3950208"/>
+            <a:ext cx="2788920" cy="2468880"/>
           </a:xfrm>
           <a:prstGeom prst="roundRect">
             <a:avLst>
@@ -6040,8 +5772,8 @@
         </p:nvSpPr>
         <p:spPr>
           <a:xfrm>
-            <a:off x="9326880" y="3877056"/>
-            <a:ext cx="2514600" cy="292608"/>
+            <a:off x="9326880" y="4096512"/>
+            <a:ext cx="2514600" cy="329184"/>
           </a:xfrm>
           <a:prstGeom prst="rect">
             <a:avLst/>
@@ -6068,7 +5800,7 @@
                 <a:latin typeface="微软雅黑"/>
                 <a:ea typeface="微软雅黑"/>
               </a:rPr>
-              <a:t>数据陆续来</a:t>
+              <a:t>监测持续到达</a:t>
             </a:r>
           </a:p>
         </p:txBody>
@@ -6081,8 +5813,8 @@
         </p:nvSpPr>
         <p:spPr>
           <a:xfrm>
-            <a:off x="9326880" y="4187952"/>
-            <a:ext cx="2514600" cy="548640"/>
+            <a:off x="9326880" y="4498848"/>
+            <a:ext cx="2514600" cy="822960"/>
           </a:xfrm>
           <a:prstGeom prst="rect">
             <a:avLst/>
@@ -6109,163 +5841,7 @@
                 <a:latin typeface="微软雅黑"/>
                 <a:ea typeface="微软雅黑"/>
               </a:rPr>
-              <a:t>不太适合每次重跑全样本</a:t>
-            </a:r>
-          </a:p>
-        </p:txBody>
-      </p:sp>
-      <p:sp>
-        <p:nvSpPr>
-          <p:cNvPr id="25" name="Rounded Rectangle 24"/>
-          <p:cNvSpPr/>
-          <p:nvPr/>
-        </p:nvSpPr>
-        <p:spPr>
-          <a:xfrm>
-            <a:off x="457200" y="5029200"/>
-            <a:ext cx="11247120" cy="1408176"/>
-          </a:xfrm>
-          <a:prstGeom prst="roundRect">
-            <a:avLst>
-              <a:gd name="adj" fmla="val 4000"/>
-            </a:avLst>
-          </a:prstGeom>
-          <a:ln>
-            <a:noFill/>
-          </a:ln>
-          <a:effectLst/>
-          <a:gradFill>
-            <a:gsLst>
-              <a:gs pos="0">
-                <a:srgbClr val="0A1F3D"/>
-              </a:gs>
-              <a:gs pos="100000">
-                <a:srgbClr val="1E4E7A"/>
-              </a:gs>
-            </a:gsLst>
-            <a:lin ang="0" scaled="0"/>
-          </a:gradFill>
-        </p:spPr>
-        <p:style>
-          <a:lnRef idx="1">
-            <a:schemeClr val="accent1"/>
-          </a:lnRef>
-          <a:fillRef idx="3">
-            <a:schemeClr val="accent1"/>
-          </a:fillRef>
-          <a:effectRef idx="2">
-            <a:schemeClr val="accent1"/>
-          </a:effectRef>
-          <a:fontRef idx="minor">
-            <a:schemeClr val="lt1"/>
-          </a:fontRef>
-        </p:style>
-        <p:txBody>
-          <a:bodyPr rtlCol="0" anchor="ctr"/>
-          <a:lstStyle/>
-          <a:p>
-            <a:pPr algn="ctr"/>
-          </a:p>
-        </p:txBody>
-      </p:sp>
-      <p:sp>
-        <p:nvSpPr>
-          <p:cNvPr id="26" name="TextBox 25"/>
-          <p:cNvSpPr txBox="1"/>
-          <p:nvPr/>
-        </p:nvSpPr>
-        <p:spPr>
-          <a:xfrm>
-            <a:off x="658368" y="5138928"/>
-            <a:ext cx="10881360" cy="237744"/>
-          </a:xfrm>
-          <a:prstGeom prst="rect">
-            <a:avLst/>
-          </a:prstGeom>
-          <a:noFill/>
-        </p:spPr>
-        <p:txBody>
-          <a:bodyPr wrap="square" lIns="36576" rIns="36576" tIns="18288" bIns="18288" anchor="t"/>
-          <a:lstStyle/>
-          <a:p>
-            <a:pPr algn="l">
-              <a:lnSpc>
-                <a:spcPct val="118000"/>
-              </a:lnSpc>
-              <a:spcAft>
-                <a:spcPts val="0"/>
-              </a:spcAft>
-            </a:pPr>
-            <a:r>
-              <a:rPr sz="1200" b="0">
-                <a:solidFill>
-                  <a:srgbClr val="3A7CA5"/>
-                </a:solidFill>
-                <a:latin typeface="微软雅黑"/>
-                <a:ea typeface="微软雅黑"/>
-              </a:rPr>
-              <a:t>我们现在主要做的</a:t>
-            </a:r>
-          </a:p>
-        </p:txBody>
-      </p:sp>
-      <p:sp>
-        <p:nvSpPr>
-          <p:cNvPr id="27" name="TextBox 26"/>
-          <p:cNvSpPr txBox="1"/>
-          <p:nvPr/>
-        </p:nvSpPr>
-        <p:spPr>
-          <a:xfrm>
-            <a:off x="658368" y="5413248"/>
-            <a:ext cx="10881360" cy="868680"/>
-          </a:xfrm>
-          <a:prstGeom prst="rect">
-            <a:avLst/>
-          </a:prstGeom>
-          <a:noFill/>
-        </p:spPr>
-        <p:txBody>
-          <a:bodyPr wrap="square" lIns="36576" rIns="36576" tIns="18288" bIns="18288" anchor="t"/>
-          <a:lstStyle/>
-          <a:p>
-            <a:pPr algn="l">
-              <a:lnSpc>
-                <a:spcPct val="118000"/>
-              </a:lnSpc>
-              <a:spcAft>
-                <a:spcPts val="600"/>
-              </a:spcAft>
-            </a:pPr>
-            <a:r>
-              <a:rPr sz="1500" b="0">
-                <a:solidFill>
-                  <a:srgbClr val="FFFFFF"/>
-                </a:solidFill>
-                <a:latin typeface="微软雅黑"/>
-                <a:ea typeface="微软雅黑"/>
-              </a:rPr>
-              <a:t>把退化过程写清楚，再用贝叶斯方法做可靠性评估和剩余寿命预测。</a:t>
-            </a:r>
-          </a:p>
-          <a:p>
-            <a:pPr algn="l">
-              <a:lnSpc>
-                <a:spcPct val="118000"/>
-              </a:lnSpc>
-              <a:spcAft>
-                <a:spcPts val="0"/>
-              </a:spcAft>
-            </a:pPr>
-            <a:r>
-              <a:rPr sz="1400" b="0">
-                <a:solidFill>
-                  <a:srgbClr val="C5D6E6"/>
-                </a:solidFill>
-                <a:latin typeface="微软雅黑"/>
-                <a:ea typeface="微软雅黑"/>
-              </a:rPr>
-              <a:t>具体包括过程建模、在线更新、小样本下的客观先验，以及加速试验和现场数据怎么放在一起。</a:t>
+              <a:t>数据以流的形式进入，需及时更新</a:t>
             </a:r>
           </a:p>
         </p:txBody>
@@ -6384,7 +5960,7 @@
                 <a:latin typeface="微软雅黑"/>
                 <a:ea typeface="微软雅黑"/>
               </a:rPr>
-              <a:t>过程</a:t>
+              <a:t>工作</a:t>
             </a:r>
           </a:p>
         </p:txBody>
@@ -6425,7 +6001,7 @@
                 <a:latin typeface="微软雅黑"/>
                 <a:ea typeface="微软雅黑"/>
               </a:rPr>
-              <a:t>退化过程上的几项工作</a:t>
+              <a:t>主要研究工作</a:t>
             </a:r>
           </a:p>
         </p:txBody>
@@ -6595,7 +6171,7 @@
                 <a:latin typeface="微软雅黑"/>
                 <a:ea typeface="微软雅黑"/>
               </a:rPr>
-              <a:t>03  /  05</a:t>
+              <a:t>03  /  04</a:t>
             </a:r>
           </a:p>
         </p:txBody>
@@ -6608,8 +6184,8 @@
         </p:nvSpPr>
         <p:spPr>
           <a:xfrm>
-            <a:off x="502920" y="1097280"/>
-            <a:ext cx="11155680" cy="457200"/>
+            <a:off x="457200" y="1078992"/>
+            <a:ext cx="11247120" cy="329184"/>
           </a:xfrm>
           <a:prstGeom prst="rect">
             <a:avLst/>
@@ -6636,7 +6212,7 @@
                 <a:latin typeface="微软雅黑"/>
                 <a:ea typeface="微软雅黑"/>
               </a:rPr>
-              <a:t>还是 Wiener、逆高斯、Gamma 这几类。后来多半是在这上面处理指标相关、两阶段、两种时间尺度，以及尾部偏厚的情形。</a:t>
+              <a:t>针对上述四个问题，相应工作如下。</a:t>
             </a:r>
           </a:p>
         </p:txBody>
@@ -6649,8 +6225,8 @@
         </p:nvSpPr>
         <p:spPr>
           <a:xfrm>
-            <a:off x="457200" y="1645920"/>
-            <a:ext cx="5669280" cy="1444752"/>
+            <a:off x="457200" y="1481328"/>
+            <a:ext cx="5669280" cy="1828800"/>
           </a:xfrm>
           <a:prstGeom prst="roundRect">
             <a:avLst>
@@ -6697,8 +6273,8 @@
         </p:nvSpPr>
         <p:spPr>
           <a:xfrm>
-            <a:off x="457200" y="1645920"/>
-            <a:ext cx="64008" cy="1444752"/>
+            <a:off x="457200" y="1481328"/>
+            <a:ext cx="64008" cy="1828800"/>
           </a:xfrm>
           <a:prstGeom prst="rect">
             <a:avLst/>
@@ -6741,8 +6317,8 @@
         </p:nvSpPr>
         <p:spPr>
           <a:xfrm>
-            <a:off x="713232" y="1792224"/>
-            <a:ext cx="5212080" cy="292608"/>
+            <a:off x="676656" y="1609344"/>
+            <a:ext cx="5257800" cy="237744"/>
           </a:xfrm>
           <a:prstGeom prst="rect">
             <a:avLst/>
@@ -6762,14 +6338,14 @@
               </a:spcAft>
             </a:pPr>
             <a:r>
-              <a:rPr sz="1600" b="1">
+              <a:rPr sz="1200" b="0">
                 <a:solidFill>
-                  <a:srgbClr val="0A1F3D"/>
+                  <a:srgbClr val="3A7CA5"/>
                 </a:solidFill>
                 <a:latin typeface="微软雅黑"/>
                 <a:ea typeface="微软雅黑"/>
               </a:rPr>
-              <a:t>多元 Wiener</a:t>
+              <a:t>样本量偏小</a:t>
             </a:r>
           </a:p>
         </p:txBody>
@@ -6782,8 +6358,8 @@
         </p:nvSpPr>
         <p:spPr>
           <a:xfrm>
-            <a:off x="713232" y="2121408"/>
-            <a:ext cx="5212080" cy="457200"/>
+            <a:off x="676656" y="1865376"/>
+            <a:ext cx="5257800" cy="310896"/>
           </a:xfrm>
           <a:prstGeom prst="rect">
             <a:avLst/>
@@ -6803,14 +6379,14 @@
               </a:spcAft>
             </a:pPr>
             <a:r>
-              <a:rPr sz="1300" b="0">
+              <a:rPr sz="1600" b="1">
                 <a:solidFill>
-                  <a:srgbClr val="122033"/>
+                  <a:srgbClr val="0A1F3D"/>
                 </a:solidFill>
                 <a:latin typeface="微软雅黑"/>
                 <a:ea typeface="微软雅黑"/>
               </a:rPr>
-              <a:t>二元和层次模型，退化速率和波动可以相关</a:t>
+              <a:t>客观贝叶斯与试验设计</a:t>
             </a:r>
           </a:p>
         </p:txBody>
@@ -6823,8 +6399,8 @@
         </p:nvSpPr>
         <p:spPr>
           <a:xfrm>
-            <a:off x="713232" y="2651760"/>
-            <a:ext cx="5212080" cy="256032"/>
+            <a:off x="676656" y="2249424"/>
+            <a:ext cx="5257800" cy="896112"/>
           </a:xfrm>
           <a:prstGeom prst="rect">
             <a:avLst/>
@@ -6844,14 +6420,14 @@
               </a:spcAft>
             </a:pPr>
             <a:r>
-              <a:rPr sz="1100" b="0">
+              <a:rPr sz="1300" b="0">
                 <a:solidFill>
-                  <a:srgbClr val="3A7CA5"/>
+                  <a:srgbClr val="122033"/>
                 </a:solidFill>
                 <a:latin typeface="微软雅黑"/>
                 <a:ea typeface="微软雅黑"/>
               </a:rPr>
-              <a:t>IEEE TR，2018、2026</a:t>
+              <a:t>建立参考先验并讨论后验正常性；研究加速寿命、加速退化及小样本评估，包括永磁制动器等对象。</a:t>
             </a:r>
           </a:p>
         </p:txBody>
@@ -6864,8 +6440,8 @@
         </p:nvSpPr>
         <p:spPr>
           <a:xfrm>
-            <a:off x="6309360" y="1645920"/>
-            <a:ext cx="5669280" cy="1444752"/>
+            <a:off x="6309360" y="1481328"/>
+            <a:ext cx="5669280" cy="1828800"/>
           </a:xfrm>
           <a:prstGeom prst="roundRect">
             <a:avLst>
@@ -6912,8 +6488,8 @@
         </p:nvSpPr>
         <p:spPr>
           <a:xfrm>
-            <a:off x="6309360" y="1645920"/>
-            <a:ext cx="64008" cy="1444752"/>
+            <a:off x="6309360" y="1481328"/>
+            <a:ext cx="64008" cy="1828800"/>
           </a:xfrm>
           <a:prstGeom prst="rect">
             <a:avLst/>
@@ -6956,8 +6532,8 @@
         </p:nvSpPr>
         <p:spPr>
           <a:xfrm>
-            <a:off x="6565392" y="1792224"/>
-            <a:ext cx="5212080" cy="292608"/>
+            <a:off x="6528816" y="1609344"/>
+            <a:ext cx="5257800" cy="237744"/>
           </a:xfrm>
           <a:prstGeom prst="rect">
             <a:avLst/>
@@ -6977,14 +6553,14 @@
               </a:spcAft>
             </a:pPr>
             <a:r>
-              <a:rPr sz="1600" b="1">
+              <a:rPr sz="1200" b="0">
                 <a:solidFill>
-                  <a:srgbClr val="0A1F3D"/>
+                  <a:srgbClr val="3A7CA5"/>
                 </a:solidFill>
                 <a:latin typeface="微软雅黑"/>
                 <a:ea typeface="微软雅黑"/>
               </a:rPr>
-              <a:t>多元 Student-t</a:t>
+              <a:t>指标多元相依</a:t>
             </a:r>
           </a:p>
         </p:txBody>
@@ -6997,8 +6573,8 @@
         </p:nvSpPr>
         <p:spPr>
           <a:xfrm>
-            <a:off x="6565392" y="2121408"/>
-            <a:ext cx="5212080" cy="457200"/>
+            <a:off x="6528816" y="1865376"/>
+            <a:ext cx="5257800" cy="310896"/>
           </a:xfrm>
           <a:prstGeom prst="rect">
             <a:avLst/>
@@ -7018,14 +6594,14 @@
               </a:spcAft>
             </a:pPr>
             <a:r>
-              <a:rPr sz="1300" b="0">
+              <a:rPr sz="1600" b="1">
                 <a:solidFill>
-                  <a:srgbClr val="122033"/>
+                  <a:srgbClr val="0A1F3D"/>
                 </a:solidFill>
                 <a:latin typeface="微软雅黑"/>
                 <a:ea typeface="微软雅黑"/>
               </a:rPr>
-              <a:t>用来拟合尾部比较重的多指标退化</a:t>
+              <a:t>多元退化过程</a:t>
             </a:r>
           </a:p>
         </p:txBody>
@@ -7038,8 +6614,8 @@
         </p:nvSpPr>
         <p:spPr>
           <a:xfrm>
-            <a:off x="6565392" y="2651760"/>
-            <a:ext cx="5212080" cy="256032"/>
+            <a:off x="6528816" y="2249424"/>
+            <a:ext cx="5257800" cy="896112"/>
           </a:xfrm>
           <a:prstGeom prst="rect">
             <a:avLst/>
@@ -7059,14 +6635,14 @@
               </a:spcAft>
             </a:pPr>
             <a:r>
-              <a:rPr sz="1100" b="0">
+              <a:rPr sz="1300" b="0">
                 <a:solidFill>
-                  <a:srgbClr val="3A7CA5"/>
+                  <a:srgbClr val="122033"/>
                 </a:solidFill>
                 <a:latin typeface="微软雅黑"/>
                 <a:ea typeface="微软雅黑"/>
               </a:rPr>
-              <a:t>IISE Transactions，2025</a:t>
+              <a:t>建立多元 Wiener 过程与多元 Student-t 过程，刻画退化速率、波动及尾部的相依结构。</a:t>
             </a:r>
           </a:p>
         </p:txBody>
@@ -7079,8 +6655,8 @@
         </p:nvSpPr>
         <p:spPr>
           <a:xfrm>
-            <a:off x="457200" y="3218688"/>
-            <a:ext cx="5669280" cy="1444752"/>
+            <a:off x="457200" y="3447288"/>
+            <a:ext cx="5669280" cy="1828800"/>
           </a:xfrm>
           <a:prstGeom prst="roundRect">
             <a:avLst>
@@ -7127,8 +6703,8 @@
         </p:nvSpPr>
         <p:spPr>
           <a:xfrm>
-            <a:off x="457200" y="3218688"/>
-            <a:ext cx="64008" cy="1444752"/>
+            <a:off x="457200" y="3447288"/>
+            <a:ext cx="64008" cy="1828800"/>
           </a:xfrm>
           <a:prstGeom prst="rect">
             <a:avLst/>
@@ -7171,8 +6747,8 @@
         </p:nvSpPr>
         <p:spPr>
           <a:xfrm>
-            <a:off x="713232" y="3364992"/>
-            <a:ext cx="5212080" cy="292608"/>
+            <a:off x="676656" y="3575304"/>
+            <a:ext cx="5257800" cy="237744"/>
           </a:xfrm>
           <a:prstGeom prst="rect">
             <a:avLst/>
@@ -7192,14 +6768,14 @@
               </a:spcAft>
             </a:pPr>
             <a:r>
-              <a:rPr sz="1600" b="1">
+              <a:rPr sz="1200" b="0">
                 <a:solidFill>
-                  <a:srgbClr val="0A1F3D"/>
+                  <a:srgbClr val="3A7CA5"/>
                 </a:solidFill>
                 <a:latin typeface="微软雅黑"/>
                 <a:ea typeface="微软雅黑"/>
               </a:rPr>
-              <a:t>两阶段逆高斯</a:t>
+              <a:t>个体异质性</a:t>
             </a:r>
           </a:p>
         </p:txBody>
@@ -7212,8 +6788,8 @@
         </p:nvSpPr>
         <p:spPr>
           <a:xfrm>
-            <a:off x="713232" y="3694176"/>
-            <a:ext cx="5212080" cy="457200"/>
+            <a:off x="676656" y="3831336"/>
+            <a:ext cx="5257800" cy="310896"/>
           </a:xfrm>
           <a:prstGeom prst="rect">
             <a:avLst/>
@@ -7233,14 +6809,14 @@
               </a:spcAft>
             </a:pPr>
             <a:r>
-              <a:rPr sz="1300" b="0">
+              <a:rPr sz="1600" b="1">
                 <a:solidFill>
-                  <a:srgbClr val="122033"/>
+                  <a:srgbClr val="0A1F3D"/>
                 </a:solidFill>
                 <a:latin typeface="微软雅黑"/>
                 <a:ea typeface="微软雅黑"/>
               </a:rPr>
-              <a:t>重参数化以后做变点和剩余寿命</a:t>
+              <a:t>随机效应与变点模型</a:t>
             </a:r>
           </a:p>
         </p:txBody>
@@ -7253,8 +6829,8 @@
         </p:nvSpPr>
         <p:spPr>
           <a:xfrm>
-            <a:off x="713232" y="4224528"/>
-            <a:ext cx="5212080" cy="256032"/>
+            <a:off x="676656" y="4215384"/>
+            <a:ext cx="5257800" cy="896112"/>
           </a:xfrm>
           <a:prstGeom prst="rect">
             <a:avLst/>
@@ -7274,14 +6850,14 @@
               </a:spcAft>
             </a:pPr>
             <a:r>
-              <a:rPr sz="1100" b="0">
+              <a:rPr sz="1300" b="0">
                 <a:solidFill>
-                  <a:srgbClr val="3A7CA5"/>
+                  <a:srgbClr val="122033"/>
                 </a:solidFill>
                 <a:latin typeface="微软雅黑"/>
                 <a:ea typeface="微软雅黑"/>
               </a:rPr>
-              <a:t>EJOR，2024</a:t>
+              <a:t>在逆高斯框架下处理两阶段变化和双尺度，并引入随机效应。</a:t>
             </a:r>
           </a:p>
         </p:txBody>
@@ -7294,8 +6870,8 @@
         </p:nvSpPr>
         <p:spPr>
           <a:xfrm>
-            <a:off x="6309360" y="3218688"/>
-            <a:ext cx="5669280" cy="1444752"/>
+            <a:off x="6309360" y="3447288"/>
+            <a:ext cx="5669280" cy="1828800"/>
           </a:xfrm>
           <a:prstGeom prst="roundRect">
             <a:avLst>
@@ -7342,8 +6918,8 @@
         </p:nvSpPr>
         <p:spPr>
           <a:xfrm>
-            <a:off x="6309360" y="3218688"/>
-            <a:ext cx="64008" cy="1444752"/>
+            <a:off x="6309360" y="3447288"/>
+            <a:ext cx="64008" cy="1828800"/>
           </a:xfrm>
           <a:prstGeom prst="rect">
             <a:avLst/>
@@ -7386,8 +6962,8 @@
         </p:nvSpPr>
         <p:spPr>
           <a:xfrm>
-            <a:off x="6565392" y="3364992"/>
-            <a:ext cx="5212080" cy="292608"/>
+            <a:off x="6528816" y="3575304"/>
+            <a:ext cx="5257800" cy="237744"/>
           </a:xfrm>
           <a:prstGeom prst="rect">
             <a:avLst/>
@@ -7407,14 +6983,14 @@
               </a:spcAft>
             </a:pPr>
             <a:r>
-              <a:rPr sz="1600" b="1">
+              <a:rPr sz="1200" b="0">
                 <a:solidFill>
-                  <a:srgbClr val="0A1F3D"/>
+                  <a:srgbClr val="3A7CA5"/>
                 </a:solidFill>
                 <a:latin typeface="微软雅黑"/>
                 <a:ea typeface="微软雅黑"/>
               </a:rPr>
-              <a:t>双尺度逆高斯</a:t>
+              <a:t>监测持续到达</a:t>
             </a:r>
           </a:p>
         </p:txBody>
@@ -7427,8 +7003,8 @@
         </p:nvSpPr>
         <p:spPr>
           <a:xfrm>
-            <a:off x="6565392" y="3694176"/>
-            <a:ext cx="5212080" cy="457200"/>
+            <a:off x="6528816" y="3831336"/>
+            <a:ext cx="5257800" cy="310896"/>
           </a:xfrm>
           <a:prstGeom prst="rect">
             <a:avLst/>
@@ -7448,14 +7024,14 @@
               </a:spcAft>
             </a:pPr>
             <a:r>
-              <a:rPr sz="1300" b="0">
+              <a:rPr sz="1600" b="1">
                 <a:solidFill>
-                  <a:srgbClr val="122033"/>
+                  <a:srgbClr val="0A1F3D"/>
                 </a:solidFill>
                 <a:latin typeface="微软雅黑"/>
                 <a:ea typeface="微软雅黑"/>
               </a:rPr>
-              <a:t>带随机效应，两种时间尺度可以放在一起</a:t>
+              <a:t>在线贝叶斯推断</a:t>
             </a:r>
           </a:p>
         </p:txBody>
@@ -7468,8 +7044,8 @@
         </p:nvSpPr>
         <p:spPr>
           <a:xfrm>
-            <a:off x="6565392" y="4224528"/>
-            <a:ext cx="5212080" cy="256032"/>
+            <a:off x="6528816" y="4215384"/>
+            <a:ext cx="5257800" cy="896112"/>
           </a:xfrm>
           <a:prstGeom prst="rect">
             <a:avLst/>
@@ -7489,14 +7065,14 @@
               </a:spcAft>
             </a:pPr>
             <a:r>
-              <a:rPr sz="1100" b="0">
+              <a:rPr sz="1300" b="0">
                 <a:solidFill>
-                  <a:srgbClr val="3A7CA5"/>
+                  <a:srgbClr val="122033"/>
                 </a:solidFill>
                 <a:latin typeface="微软雅黑"/>
                 <a:ea typeface="微软雅黑"/>
               </a:rPr>
-              <a:t>IISE Transactions，Featured Article</a:t>
+              <a:t>利用共轭或近似共轭结构作递推更新，给出剩余寿命预测，并用于维修决策。</a:t>
             </a:r>
           </a:p>
         </p:txBody>
@@ -7509,8 +7085,8 @@
         </p:nvSpPr>
         <p:spPr>
           <a:xfrm>
-            <a:off x="457200" y="4901184"/>
-            <a:ext cx="11247120" cy="1517904"/>
+            <a:off x="457200" y="5504688"/>
+            <a:ext cx="11247120" cy="932688"/>
           </a:xfrm>
           <a:prstGeom prst="roundRect">
             <a:avLst>
@@ -7563,8 +7139,8 @@
         </p:nvSpPr>
         <p:spPr>
           <a:xfrm>
-            <a:off x="676656" y="5029200"/>
-            <a:ext cx="10835640" cy="219456"/>
+            <a:off x="658368" y="5632704"/>
+            <a:ext cx="10881360" cy="694944"/>
           </a:xfrm>
           <a:prstGeom prst="rect">
             <a:avLst/>
@@ -7574,6 +7150,26 @@
         <p:txBody>
           <a:bodyPr wrap="square" lIns="36576" rIns="36576" tIns="18288" bIns="18288" anchor="t"/>
           <a:lstStyle/>
+          <a:p>
+            <a:pPr algn="l">
+              <a:lnSpc>
+                <a:spcPct val="118000"/>
+              </a:lnSpc>
+              <a:spcAft>
+                <a:spcPts val="400"/>
+              </a:spcAft>
+            </a:pPr>
+            <a:r>
+              <a:rPr sz="1300" b="0">
+                <a:solidFill>
+                  <a:srgbClr val="FFFFFF"/>
+                </a:solidFill>
+                <a:latin typeface="微软雅黑"/>
+                <a:ea typeface="微软雅黑"/>
+              </a:rPr>
+              <a:t>有关工作发表于 NRL、SJS、JQT、EJOR、IEEE TR、IISE Transactions 等。2025 年出版《随机退化过程与统计建模》。</a:t>
+            </a:r>
+          </a:p>
           <a:p>
             <a:pPr algn="l">
               <a:lnSpc>
@@ -7584,75 +7180,14 @@
               </a:spcAft>
             </a:pPr>
             <a:r>
-              <a:rPr sz="1200" b="0">
-                <a:solidFill>
-                  <a:srgbClr val="3A7CA5"/>
-                </a:solidFill>
-                <a:latin typeface="微软雅黑"/>
-                <a:ea typeface="微软雅黑"/>
-              </a:rPr>
-              <a:t>书和在做的项目</a:t>
-            </a:r>
-          </a:p>
-        </p:txBody>
-      </p:sp>
-      <p:sp>
-        <p:nvSpPr>
-          <p:cNvPr id="32" name="TextBox 31"/>
-          <p:cNvSpPr txBox="1"/>
-          <p:nvPr/>
-        </p:nvSpPr>
-        <p:spPr>
-          <a:xfrm>
-            <a:off x="676656" y="5285232"/>
-            <a:ext cx="10835640" cy="914400"/>
-          </a:xfrm>
-          <a:prstGeom prst="rect">
-            <a:avLst/>
-          </a:prstGeom>
-          <a:noFill/>
-        </p:spPr>
-        <p:txBody>
-          <a:bodyPr wrap="square" lIns="36576" rIns="36576" tIns="18288" bIns="18288" anchor="t"/>
-          <a:lstStyle/>
-          <a:p>
-            <a:pPr algn="l">
-              <a:lnSpc>
-                <a:spcPct val="118000"/>
-              </a:lnSpc>
-              <a:spcAft>
-                <a:spcPts val="400"/>
-              </a:spcAft>
-            </a:pPr>
-            <a:r>
-              <a:rPr sz="1400" b="0">
-                <a:solidFill>
-                  <a:srgbClr val="FFFFFF"/>
-                </a:solidFill>
-                <a:latin typeface="微软雅黑"/>
-                <a:ea typeface="微软雅黑"/>
-              </a:rPr>
-              <a:t>去年出了一本《随机退化过程与统计建模》，和汤银才、庄亮亮一起写的。</a:t>
-            </a:r>
-          </a:p>
-          <a:p>
-            <a:pPr algn="l">
-              <a:lnSpc>
-                <a:spcPct val="118000"/>
-              </a:lnSpc>
-              <a:spcAft>
-                <a:spcPts val="0"/>
-              </a:spcAft>
-            </a:pPr>
-            <a:r>
-              <a:rPr sz="1400" b="0">
+              <a:rPr sz="1300" b="0">
                 <a:solidFill>
                   <a:srgbClr val="C5D6E6"/>
                 </a:solidFill>
                 <a:latin typeface="微软雅黑"/>
                 <a:ea typeface="微软雅黑"/>
               </a:rPr>
-              <a:t>手上的面上项目是多维偏态厚尾退化，以及相应的贝叶斯试验设计。</a:t>
+              <a:t>在研国家自然科学基金面上项目关注多维偏态厚尾退化及其贝叶斯最优设计。</a:t>
             </a:r>
           </a:p>
         </p:txBody>
@@ -7771,7 +7306,7 @@
                 <a:latin typeface="微软雅黑"/>
                 <a:ea typeface="微软雅黑"/>
               </a:rPr>
-              <a:t>推断</a:t>
+              <a:t>展望</a:t>
             </a:r>
           </a:p>
         </p:txBody>
@@ -7812,7 +7347,7 @@
                 <a:latin typeface="微软雅黑"/>
                 <a:ea typeface="微软雅黑"/>
               </a:rPr>
-              <a:t>在线推断和剩余寿命</a:t>
+              <a:t>后续工作</a:t>
             </a:r>
           </a:p>
         </p:txBody>
@@ -7982,7 +7517,7 @@
                 <a:latin typeface="微软雅黑"/>
                 <a:ea typeface="微软雅黑"/>
               </a:rPr>
-              <a:t>04  /  05</a:t>
+              <a:t>04  /  04</a:t>
             </a:r>
           </a:p>
         </p:txBody>
@@ -7995,8 +7530,8 @@
         </p:nvSpPr>
         <p:spPr>
           <a:xfrm>
-            <a:off x="502920" y="1097280"/>
-            <a:ext cx="11155680" cy="438912"/>
+            <a:off x="457200" y="1078992"/>
+            <a:ext cx="11247120" cy="365760"/>
           </a:xfrm>
           <a:prstGeom prst="rect">
             <a:avLst/>
@@ -8023,7 +7558,7 @@
                 <a:latin typeface="微软雅黑"/>
                 <a:ea typeface="微软雅黑"/>
               </a:rPr>
-              <a:t>退化监测一般是陆续来的。后验如果能递推，就不必每来一批数据重新估一遍。Gamma 和逆高斯在合适的参数化下可以走共轭。</a:t>
+              <a:t>拟结合数据流、多中心数据、联邦学习和人工智能系统可靠性等方向继续开展工作。</a:t>
             </a:r>
           </a:p>
         </p:txBody>
@@ -8036,8 +7571,8 @@
         </p:nvSpPr>
         <p:spPr>
           <a:xfrm>
-            <a:off x="457200" y="1645920"/>
-            <a:ext cx="2788920" cy="1353312"/>
+            <a:off x="457200" y="1536192"/>
+            <a:ext cx="5669280" cy="1792224"/>
           </a:xfrm>
           <a:prstGeom prst="roundRect">
             <a:avLst>
@@ -8078,14 +7613,58 @@
       </p:sp>
       <p:sp>
         <p:nvSpPr>
-          <p:cNvPr id="11" name="TextBox 10"/>
+          <p:cNvPr id="11" name="Rectangle 10"/>
+          <p:cNvSpPr/>
+          <p:nvPr/>
+        </p:nvSpPr>
+        <p:spPr>
+          <a:xfrm>
+            <a:off x="457200" y="1536192"/>
+            <a:ext cx="64008" cy="1792224"/>
+          </a:xfrm>
+          <a:prstGeom prst="rect">
+            <a:avLst/>
+          </a:prstGeom>
+          <a:solidFill>
+            <a:srgbClr val="3A7CA5"/>
+          </a:solidFill>
+          <a:ln>
+            <a:noFill/>
+          </a:ln>
+          <a:effectLst/>
+        </p:spPr>
+        <p:style>
+          <a:lnRef idx="1">
+            <a:schemeClr val="accent1"/>
+          </a:lnRef>
+          <a:fillRef idx="3">
+            <a:schemeClr val="accent1"/>
+          </a:fillRef>
+          <a:effectRef idx="2">
+            <a:schemeClr val="accent1"/>
+          </a:effectRef>
+          <a:fontRef idx="minor">
+            <a:schemeClr val="lt1"/>
+          </a:fontRef>
+        </p:style>
+        <p:txBody>
+          <a:bodyPr rtlCol="0" anchor="ctr"/>
+          <a:lstStyle/>
+          <a:p>
+            <a:pPr algn="ctr"/>
+          </a:p>
+        </p:txBody>
+      </p:sp>
+      <p:sp>
+        <p:nvSpPr>
+          <p:cNvPr id="12" name="TextBox 11"/>
           <p:cNvSpPr txBox="1"/>
           <p:nvPr/>
         </p:nvSpPr>
         <p:spPr>
           <a:xfrm>
-            <a:off x="603504" y="1773936"/>
-            <a:ext cx="2514600" cy="310896"/>
+            <a:off x="676656" y="1682496"/>
+            <a:ext cx="5257800" cy="329184"/>
           </a:xfrm>
           <a:prstGeom prst="rect">
             <a:avLst/>
@@ -8112,21 +7691,21 @@
                 <a:latin typeface="微软雅黑"/>
                 <a:ea typeface="微软雅黑"/>
               </a:rPr>
-              <a:t>共轭</a:t>
-            </a:r>
-          </a:p>
-        </p:txBody>
-      </p:sp>
-      <p:sp>
-        <p:nvSpPr>
-          <p:cNvPr id="12" name="TextBox 11"/>
+              <a:t>数据流</a:t>
+            </a:r>
+          </a:p>
+        </p:txBody>
+      </p:sp>
+      <p:sp>
+        <p:nvSpPr>
+          <p:cNvPr id="13" name="TextBox 12"/>
           <p:cNvSpPr txBox="1"/>
           <p:nvPr/>
         </p:nvSpPr>
         <p:spPr>
           <a:xfrm>
-            <a:off x="603504" y="2139696"/>
-            <a:ext cx="2514600" cy="694944"/>
+            <a:off x="676656" y="2066544"/>
+            <a:ext cx="5257800" cy="1097280"/>
           </a:xfrm>
           <a:prstGeom prst="rect">
             <a:avLst/>
@@ -8148,282 +7727,26 @@
             <a:r>
               <a:rPr sz="1300" b="0">
                 <a:solidFill>
-                  <a:srgbClr val="5B6B7C"/>
+                  <a:srgbClr val="122033"/>
                 </a:solidFill>
                 <a:latin typeface="微软雅黑"/>
                 <a:ea typeface="微软雅黑"/>
               </a:rPr>
-              <a:t>先验选得好，后验还能写成同类</a:t>
-            </a:r>
-          </a:p>
-        </p:txBody>
-      </p:sp>
-      <p:sp>
-        <p:nvSpPr>
-          <p:cNvPr id="13" name="Rounded Rectangle 12"/>
+              <a:t>监测数据持续到达时，研究在线更新后的区间校准与覆盖率，使剩余寿命预测在流式场景下仍可核验。</a:t>
+            </a:r>
+          </a:p>
+        </p:txBody>
+      </p:sp>
+      <p:sp>
+        <p:nvSpPr>
+          <p:cNvPr id="14" name="Rounded Rectangle 13"/>
           <p:cNvSpPr/>
           <p:nvPr/>
         </p:nvSpPr>
         <p:spPr>
           <a:xfrm>
-            <a:off x="3364992" y="1645920"/>
-            <a:ext cx="2788920" cy="1353312"/>
-          </a:xfrm>
-          <a:prstGeom prst="roundRect">
-            <a:avLst>
-              <a:gd name="adj" fmla="val 5000"/>
-            </a:avLst>
-          </a:prstGeom>
-          <a:solidFill>
-            <a:srgbClr val="0A1F3D"/>
-          </a:solidFill>
-          <a:ln>
-            <a:noFill/>
-          </a:ln>
-          <a:effectLst/>
-        </p:spPr>
-        <p:style>
-          <a:lnRef idx="1">
-            <a:schemeClr val="accent1"/>
-          </a:lnRef>
-          <a:fillRef idx="3">
-            <a:schemeClr val="accent1"/>
-          </a:fillRef>
-          <a:effectRef idx="2">
-            <a:schemeClr val="accent1"/>
-          </a:effectRef>
-          <a:fontRef idx="minor">
-            <a:schemeClr val="lt1"/>
-          </a:fontRef>
-        </p:style>
-        <p:txBody>
-          <a:bodyPr rtlCol="0" anchor="ctr"/>
-          <a:lstStyle/>
-          <a:p>
-            <a:pPr algn="ctr"/>
-          </a:p>
-        </p:txBody>
-      </p:sp>
-      <p:sp>
-        <p:nvSpPr>
-          <p:cNvPr id="14" name="TextBox 13"/>
-          <p:cNvSpPr txBox="1"/>
-          <p:nvPr/>
-        </p:nvSpPr>
-        <p:spPr>
-          <a:xfrm>
-            <a:off x="3511296" y="1773936"/>
-            <a:ext cx="2514600" cy="310896"/>
-          </a:xfrm>
-          <a:prstGeom prst="rect">
-            <a:avLst/>
-          </a:prstGeom>
-          <a:noFill/>
-        </p:spPr>
-        <p:txBody>
-          <a:bodyPr wrap="square" lIns="36576" rIns="36576" tIns="18288" bIns="18288" anchor="t"/>
-          <a:lstStyle/>
-          <a:p>
-            <a:pPr algn="l">
-              <a:lnSpc>
-                <a:spcPct val="118000"/>
-              </a:lnSpc>
-              <a:spcAft>
-                <a:spcPts val="0"/>
-              </a:spcAft>
-            </a:pPr>
-            <a:r>
-              <a:rPr sz="1600" b="1">
-                <a:solidFill>
-                  <a:srgbClr val="FFFFFF"/>
-                </a:solidFill>
-                <a:latin typeface="微软雅黑"/>
-                <a:ea typeface="微软雅黑"/>
-              </a:rPr>
-              <a:t>递推</a:t>
-            </a:r>
-          </a:p>
-        </p:txBody>
-      </p:sp>
-      <p:sp>
-        <p:nvSpPr>
-          <p:cNvPr id="15" name="TextBox 14"/>
-          <p:cNvSpPr txBox="1"/>
-          <p:nvPr/>
-        </p:nvSpPr>
-        <p:spPr>
-          <a:xfrm>
-            <a:off x="3511296" y="2139696"/>
-            <a:ext cx="2514600" cy="694944"/>
-          </a:xfrm>
-          <a:prstGeom prst="rect">
-            <a:avLst/>
-          </a:prstGeom>
-          <a:noFill/>
-        </p:spPr>
-        <p:txBody>
-          <a:bodyPr wrap="square" lIns="36576" rIns="36576" tIns="18288" bIns="18288" anchor="t"/>
-          <a:lstStyle/>
-          <a:p>
-            <a:pPr algn="l">
-              <a:lnSpc>
-                <a:spcPct val="118000"/>
-              </a:lnSpc>
-              <a:spcAft>
-                <a:spcPts val="0"/>
-              </a:spcAft>
-            </a:pPr>
-            <a:r>
-              <a:rPr sz="1300" b="0">
-                <a:solidFill>
-                  <a:srgbClr val="C5D6E6"/>
-                </a:solidFill>
-                <a:latin typeface="微软雅黑"/>
-                <a:ea typeface="微软雅黑"/>
-              </a:rPr>
-              <a:t>新数据进来，更新几个超参数</a:t>
-            </a:r>
-          </a:p>
-        </p:txBody>
-      </p:sp>
-      <p:sp>
-        <p:nvSpPr>
-          <p:cNvPr id="16" name="Rounded Rectangle 15"/>
-          <p:cNvSpPr/>
-          <p:nvPr/>
-        </p:nvSpPr>
-        <p:spPr>
-          <a:xfrm>
-            <a:off x="6272784" y="1645920"/>
-            <a:ext cx="2788920" cy="1353312"/>
-          </a:xfrm>
-          <a:prstGeom prst="roundRect">
-            <a:avLst>
-              <a:gd name="adj" fmla="val 5000"/>
-            </a:avLst>
-          </a:prstGeom>
-          <a:solidFill>
-            <a:srgbClr val="0A1F3D"/>
-          </a:solidFill>
-          <a:ln>
-            <a:noFill/>
-          </a:ln>
-          <a:effectLst/>
-        </p:spPr>
-        <p:style>
-          <a:lnRef idx="1">
-            <a:schemeClr val="accent1"/>
-          </a:lnRef>
-          <a:fillRef idx="3">
-            <a:schemeClr val="accent1"/>
-          </a:fillRef>
-          <a:effectRef idx="2">
-            <a:schemeClr val="accent1"/>
-          </a:effectRef>
-          <a:fontRef idx="minor">
-            <a:schemeClr val="lt1"/>
-          </a:fontRef>
-        </p:style>
-        <p:txBody>
-          <a:bodyPr rtlCol="0" anchor="ctr"/>
-          <a:lstStyle/>
-          <a:p>
-            <a:pPr algn="ctr"/>
-          </a:p>
-        </p:txBody>
-      </p:sp>
-      <p:sp>
-        <p:nvSpPr>
-          <p:cNvPr id="17" name="TextBox 16"/>
-          <p:cNvSpPr txBox="1"/>
-          <p:nvPr/>
-        </p:nvSpPr>
-        <p:spPr>
-          <a:xfrm>
-            <a:off x="6419088" y="1773936"/>
-            <a:ext cx="2514600" cy="310896"/>
-          </a:xfrm>
-          <a:prstGeom prst="rect">
-            <a:avLst/>
-          </a:prstGeom>
-          <a:noFill/>
-        </p:spPr>
-        <p:txBody>
-          <a:bodyPr wrap="square" lIns="36576" rIns="36576" tIns="18288" bIns="18288" anchor="t"/>
-          <a:lstStyle/>
-          <a:p>
-            <a:pPr algn="l">
-              <a:lnSpc>
-                <a:spcPct val="118000"/>
-              </a:lnSpc>
-              <a:spcAft>
-                <a:spcPts val="0"/>
-              </a:spcAft>
-            </a:pPr>
-            <a:r>
-              <a:rPr sz="1600" b="1">
-                <a:solidFill>
-                  <a:srgbClr val="FFFFFF"/>
-                </a:solidFill>
-                <a:latin typeface="微软雅黑"/>
-                <a:ea typeface="微软雅黑"/>
-              </a:rPr>
-              <a:t>剩余寿命</a:t>
-            </a:r>
-          </a:p>
-        </p:txBody>
-      </p:sp>
-      <p:sp>
-        <p:nvSpPr>
-          <p:cNvPr id="18" name="TextBox 17"/>
-          <p:cNvSpPr txBox="1"/>
-          <p:nvPr/>
-        </p:nvSpPr>
-        <p:spPr>
-          <a:xfrm>
-            <a:off x="6419088" y="2139696"/>
-            <a:ext cx="2514600" cy="694944"/>
-          </a:xfrm>
-          <a:prstGeom prst="rect">
-            <a:avLst/>
-          </a:prstGeom>
-          <a:noFill/>
-        </p:spPr>
-        <p:txBody>
-          <a:bodyPr wrap="square" lIns="36576" rIns="36576" tIns="18288" bIns="18288" anchor="t"/>
-          <a:lstStyle/>
-          <a:p>
-            <a:pPr algn="l">
-              <a:lnSpc>
-                <a:spcPct val="118000"/>
-              </a:lnSpc>
-              <a:spcAft>
-                <a:spcPts val="0"/>
-              </a:spcAft>
-            </a:pPr>
-            <a:r>
-              <a:rPr sz="1300" b="0">
-                <a:solidFill>
-                  <a:srgbClr val="C5D6E6"/>
-                </a:solidFill>
-                <a:latin typeface="微软雅黑"/>
-                <a:ea typeface="微软雅黑"/>
-              </a:rPr>
-              <a:t>用当前后验直接算，不必重估</a:t>
-            </a:r>
-          </a:p>
-        </p:txBody>
-      </p:sp>
-      <p:sp>
-        <p:nvSpPr>
-          <p:cNvPr id="19" name="Rounded Rectangle 18"/>
-          <p:cNvSpPr/>
-          <p:nvPr/>
-        </p:nvSpPr>
-        <p:spPr>
-          <a:xfrm>
-            <a:off x="9180576" y="1645920"/>
-            <a:ext cx="2788920" cy="1353312"/>
+            <a:off x="6309360" y="1536192"/>
+            <a:ext cx="5669280" cy="1792224"/>
           </a:xfrm>
           <a:prstGeom prst="roundRect">
             <a:avLst>
@@ -8464,14 +7787,58 @@
       </p:sp>
       <p:sp>
         <p:nvSpPr>
-          <p:cNvPr id="20" name="TextBox 19"/>
+          <p:cNvPr id="15" name="Rectangle 14"/>
+          <p:cNvSpPr/>
+          <p:nvPr/>
+        </p:nvSpPr>
+        <p:spPr>
+          <a:xfrm>
+            <a:off x="6309360" y="1536192"/>
+            <a:ext cx="64008" cy="1792224"/>
+          </a:xfrm>
+          <a:prstGeom prst="rect">
+            <a:avLst/>
+          </a:prstGeom>
+          <a:solidFill>
+            <a:srgbClr val="3A7CA5"/>
+          </a:solidFill>
+          <a:ln>
+            <a:noFill/>
+          </a:ln>
+          <a:effectLst/>
+        </p:spPr>
+        <p:style>
+          <a:lnRef idx="1">
+            <a:schemeClr val="accent1"/>
+          </a:lnRef>
+          <a:fillRef idx="3">
+            <a:schemeClr val="accent1"/>
+          </a:fillRef>
+          <a:effectRef idx="2">
+            <a:schemeClr val="accent1"/>
+          </a:effectRef>
+          <a:fontRef idx="minor">
+            <a:schemeClr val="lt1"/>
+          </a:fontRef>
+        </p:style>
+        <p:txBody>
+          <a:bodyPr rtlCol="0" anchor="ctr"/>
+          <a:lstStyle/>
+          <a:p>
+            <a:pPr algn="ctr"/>
+          </a:p>
+        </p:txBody>
+      </p:sp>
+      <p:sp>
+        <p:nvSpPr>
+          <p:cNvPr id="16" name="TextBox 15"/>
           <p:cNvSpPr txBox="1"/>
           <p:nvPr/>
         </p:nvSpPr>
         <p:spPr>
           <a:xfrm>
-            <a:off x="9326880" y="1773936"/>
-            <a:ext cx="2514600" cy="310896"/>
+            <a:off x="6528816" y="1682496"/>
+            <a:ext cx="5257800" cy="329184"/>
           </a:xfrm>
           <a:prstGeom prst="rect">
             <a:avLst/>
@@ -8498,21 +7865,21 @@
                 <a:latin typeface="微软雅黑"/>
                 <a:ea typeface="微软雅黑"/>
               </a:rPr>
-              <a:t>异常点</a:t>
-            </a:r>
-          </a:p>
-        </p:txBody>
-      </p:sp>
-      <p:sp>
-        <p:nvSpPr>
-          <p:cNvPr id="21" name="TextBox 20"/>
+              <a:t>多中心数据</a:t>
+            </a:r>
+          </a:p>
+        </p:txBody>
+      </p:sp>
+      <p:sp>
+        <p:nvSpPr>
+          <p:cNvPr id="17" name="TextBox 16"/>
           <p:cNvSpPr txBox="1"/>
           <p:nvPr/>
         </p:nvSpPr>
         <p:spPr>
           <a:xfrm>
-            <a:off x="9326880" y="2139696"/>
-            <a:ext cx="2514600" cy="694944"/>
+            <a:off x="6528816" y="2066544"/>
+            <a:ext cx="5257800" cy="1097280"/>
           </a:xfrm>
           <a:prstGeom prst="rect">
             <a:avLst/>
@@ -8534,26 +7901,26 @@
             <a:r>
               <a:rPr sz="1300" b="0">
                 <a:solidFill>
-                  <a:srgbClr val="5B6B7C"/>
+                  <a:srgbClr val="122033"/>
                 </a:solidFill>
                 <a:latin typeface="微软雅黑"/>
                 <a:ea typeface="微软雅黑"/>
               </a:rPr>
-              <a:t>个别离谱的观测，不要把整条轨迹带偏</a:t>
-            </a:r>
-          </a:p>
-        </p:txBody>
-      </p:sp>
-      <p:sp>
-        <p:nvSpPr>
-          <p:cNvPr id="22" name="Rounded Rectangle 21"/>
+              <a:t>不同试验室、批次和服役现场的数据往往不可直接合并。拟研究中心间异质性，并讨论信息综合的方法。</a:t>
+            </a:r>
+          </a:p>
+        </p:txBody>
+      </p:sp>
+      <p:sp>
+        <p:nvSpPr>
+          <p:cNvPr id="18" name="Rounded Rectangle 17"/>
           <p:cNvSpPr/>
           <p:nvPr/>
         </p:nvSpPr>
         <p:spPr>
           <a:xfrm>
-            <a:off x="457200" y="3383280"/>
-            <a:ext cx="5669280" cy="1316736"/>
+            <a:off x="457200" y="3456432"/>
+            <a:ext cx="5669280" cy="1792224"/>
           </a:xfrm>
           <a:prstGeom prst="roundRect">
             <a:avLst>
@@ -8594,14 +7961,58 @@
       </p:sp>
       <p:sp>
         <p:nvSpPr>
-          <p:cNvPr id="23" name="TextBox 22"/>
+          <p:cNvPr id="19" name="Rectangle 18"/>
+          <p:cNvSpPr/>
+          <p:nvPr/>
+        </p:nvSpPr>
+        <p:spPr>
+          <a:xfrm>
+            <a:off x="457200" y="3456432"/>
+            <a:ext cx="64008" cy="1792224"/>
+          </a:xfrm>
+          <a:prstGeom prst="rect">
+            <a:avLst/>
+          </a:prstGeom>
+          <a:solidFill>
+            <a:srgbClr val="123A63"/>
+          </a:solidFill>
+          <a:ln>
+            <a:noFill/>
+          </a:ln>
+          <a:effectLst/>
+        </p:spPr>
+        <p:style>
+          <a:lnRef idx="1">
+            <a:schemeClr val="accent1"/>
+          </a:lnRef>
+          <a:fillRef idx="3">
+            <a:schemeClr val="accent1"/>
+          </a:fillRef>
+          <a:effectRef idx="2">
+            <a:schemeClr val="accent1"/>
+          </a:effectRef>
+          <a:fontRef idx="minor">
+            <a:schemeClr val="lt1"/>
+          </a:fontRef>
+        </p:style>
+        <p:txBody>
+          <a:bodyPr rtlCol="0" anchor="ctr"/>
+          <a:lstStyle/>
+          <a:p>
+            <a:pPr algn="ctr"/>
+          </a:p>
+        </p:txBody>
+      </p:sp>
+      <p:sp>
+        <p:nvSpPr>
+          <p:cNvPr id="20" name="TextBox 19"/>
           <p:cNvSpPr txBox="1"/>
           <p:nvPr/>
         </p:nvSpPr>
         <p:spPr>
           <a:xfrm>
-            <a:off x="658368" y="3511296"/>
-            <a:ext cx="5303520" cy="274320"/>
+            <a:off x="676656" y="3602736"/>
+            <a:ext cx="5257800" cy="329184"/>
           </a:xfrm>
           <a:prstGeom prst="rect">
             <a:avLst/>
@@ -8621,28 +8032,28 @@
               </a:spcAft>
             </a:pPr>
             <a:r>
-              <a:rPr sz="1500" b="1">
+              <a:rPr sz="1600" b="1">
                 <a:solidFill>
                   <a:srgbClr val="0A1F3D"/>
                 </a:solidFill>
                 <a:latin typeface="微软雅黑"/>
                 <a:ea typeface="微软雅黑"/>
               </a:rPr>
-              <a:t>Gamma 过程</a:t>
-            </a:r>
-          </a:p>
-        </p:txBody>
-      </p:sp>
-      <p:sp>
-        <p:nvSpPr>
-          <p:cNvPr id="24" name="TextBox 23"/>
+              <a:t>联邦学习</a:t>
+            </a:r>
+          </a:p>
+        </p:txBody>
+      </p:sp>
+      <p:sp>
+        <p:nvSpPr>
+          <p:cNvPr id="21" name="TextBox 20"/>
           <p:cNvSpPr txBox="1"/>
           <p:nvPr/>
         </p:nvSpPr>
         <p:spPr>
           <a:xfrm>
-            <a:off x="658368" y="3822192"/>
-            <a:ext cx="5303520" cy="365760"/>
+            <a:off x="676656" y="3986784"/>
+            <a:ext cx="5257800" cy="1097280"/>
           </a:xfrm>
           <a:prstGeom prst="rect">
             <a:avLst/>
@@ -8669,62 +8080,21 @@
                 <a:latin typeface="微软雅黑"/>
                 <a:ea typeface="微软雅黑"/>
               </a:rPr>
-              <a:t>共轭先验下的递归预测</a:t>
-            </a:r>
-          </a:p>
-        </p:txBody>
-      </p:sp>
-      <p:sp>
-        <p:nvSpPr>
-          <p:cNvPr id="25" name="TextBox 24"/>
-          <p:cNvSpPr txBox="1"/>
-          <p:nvPr/>
-        </p:nvSpPr>
-        <p:spPr>
-          <a:xfrm>
-            <a:off x="658368" y="4261104"/>
-            <a:ext cx="5303520" cy="256032"/>
-          </a:xfrm>
-          <a:prstGeom prst="rect">
-            <a:avLst/>
-          </a:prstGeom>
-          <a:noFill/>
-        </p:spPr>
-        <p:txBody>
-          <a:bodyPr wrap="square" lIns="36576" rIns="36576" tIns="18288" bIns="18288" anchor="t"/>
-          <a:lstStyle/>
-          <a:p>
-            <a:pPr algn="l">
-              <a:lnSpc>
-                <a:spcPct val="118000"/>
-              </a:lnSpc>
-              <a:spcAft>
-                <a:spcPts val="0"/>
-              </a:spcAft>
-            </a:pPr>
-            <a:r>
-              <a:rPr sz="1100" b="0">
-                <a:solidFill>
-                  <a:srgbClr val="3A7CA5"/>
-                </a:solidFill>
-                <a:latin typeface="微软雅黑"/>
-                <a:ea typeface="微软雅黑"/>
-              </a:rPr>
-              <a:t>Scandinavian Journal of Statistics，2026</a:t>
-            </a:r>
-          </a:p>
-        </p:txBody>
-      </p:sp>
-      <p:sp>
-        <p:nvSpPr>
-          <p:cNvPr id="26" name="Rounded Rectangle 25"/>
+              <a:t>在数据不出域的约束下开展剩余寿命预测。已有航空发动机方面的尝试，拟进一步与过程模型和贝叶斯更新结合。</a:t>
+            </a:r>
+          </a:p>
+        </p:txBody>
+      </p:sp>
+      <p:sp>
+        <p:nvSpPr>
+          <p:cNvPr id="22" name="Rounded Rectangle 21"/>
           <p:cNvSpPr/>
           <p:nvPr/>
         </p:nvSpPr>
         <p:spPr>
           <a:xfrm>
-            <a:off x="6309360" y="3383280"/>
-            <a:ext cx="5669280" cy="1316736"/>
+            <a:off x="6309360" y="3456432"/>
+            <a:ext cx="5669280" cy="1792224"/>
           </a:xfrm>
           <a:prstGeom prst="roundRect">
             <a:avLst>
@@ -8765,14 +8135,58 @@
       </p:sp>
       <p:sp>
         <p:nvSpPr>
-          <p:cNvPr id="27" name="TextBox 26"/>
+          <p:cNvPr id="23" name="Rectangle 22"/>
+          <p:cNvSpPr/>
+          <p:nvPr/>
+        </p:nvSpPr>
+        <p:spPr>
+          <a:xfrm>
+            <a:off x="6309360" y="3456432"/>
+            <a:ext cx="64008" cy="1792224"/>
+          </a:xfrm>
+          <a:prstGeom prst="rect">
+            <a:avLst/>
+          </a:prstGeom>
+          <a:solidFill>
+            <a:srgbClr val="123A63"/>
+          </a:solidFill>
+          <a:ln>
+            <a:noFill/>
+          </a:ln>
+          <a:effectLst/>
+        </p:spPr>
+        <p:style>
+          <a:lnRef idx="1">
+            <a:schemeClr val="accent1"/>
+          </a:lnRef>
+          <a:fillRef idx="3">
+            <a:schemeClr val="accent1"/>
+          </a:fillRef>
+          <a:effectRef idx="2">
+            <a:schemeClr val="accent1"/>
+          </a:effectRef>
+          <a:fontRef idx="minor">
+            <a:schemeClr val="lt1"/>
+          </a:fontRef>
+        </p:style>
+        <p:txBody>
+          <a:bodyPr rtlCol="0" anchor="ctr"/>
+          <a:lstStyle/>
+          <a:p>
+            <a:pPr algn="ctr"/>
+          </a:p>
+        </p:txBody>
+      </p:sp>
+      <p:sp>
+        <p:nvSpPr>
+          <p:cNvPr id="24" name="TextBox 23"/>
           <p:cNvSpPr txBox="1"/>
           <p:nvPr/>
         </p:nvSpPr>
         <p:spPr>
           <a:xfrm>
-            <a:off x="6510528" y="3511296"/>
-            <a:ext cx="5303520" cy="274320"/>
+            <a:off x="6528816" y="3602736"/>
+            <a:ext cx="5257800" cy="329184"/>
           </a:xfrm>
           <a:prstGeom prst="rect">
             <a:avLst/>
@@ -8792,28 +8206,28 @@
               </a:spcAft>
             </a:pPr>
             <a:r>
-              <a:rPr sz="1500" b="1">
+              <a:rPr sz="1600" b="1">
                 <a:solidFill>
                   <a:srgbClr val="0A1F3D"/>
                 </a:solidFill>
                 <a:latin typeface="微软雅黑"/>
                 <a:ea typeface="微软雅黑"/>
               </a:rPr>
-              <a:t>逆高斯过程</a:t>
-            </a:r>
-          </a:p>
-        </p:txBody>
-      </p:sp>
-      <p:sp>
-        <p:nvSpPr>
-          <p:cNvPr id="28" name="TextBox 27"/>
+              <a:t>人工智能系统可靠性</a:t>
+            </a:r>
+          </a:p>
+        </p:txBody>
+      </p:sp>
+      <p:sp>
+        <p:nvSpPr>
+          <p:cNvPr id="25" name="TextBox 24"/>
           <p:cNvSpPr txBox="1"/>
           <p:nvPr/>
         </p:nvSpPr>
         <p:spPr>
           <a:xfrm>
-            <a:off x="6510528" y="3822192"/>
-            <a:ext cx="5303520" cy="365760"/>
+            <a:off x="6528816" y="3986784"/>
+            <a:ext cx="5257800" cy="1097280"/>
           </a:xfrm>
           <a:prstGeom prst="rect">
             <a:avLst/>
@@ -8840,433 +8254,26 @@
                 <a:latin typeface="微软雅黑"/>
                 <a:ea typeface="微软雅黑"/>
               </a:rPr>
-              <a:t>在线估计和剩余寿命</a:t>
-            </a:r>
-          </a:p>
-        </p:txBody>
-      </p:sp>
-      <p:sp>
-        <p:nvSpPr>
-          <p:cNvPr id="29" name="TextBox 28"/>
-          <p:cNvSpPr txBox="1"/>
-          <p:nvPr/>
-        </p:nvSpPr>
-        <p:spPr>
-          <a:xfrm>
-            <a:off x="6510528" y="4261104"/>
-            <a:ext cx="5303520" cy="256032"/>
-          </a:xfrm>
-          <a:prstGeom prst="rect">
-            <a:avLst/>
-          </a:prstGeom>
-          <a:noFill/>
-        </p:spPr>
-        <p:txBody>
-          <a:bodyPr wrap="square" lIns="36576" rIns="36576" tIns="18288" bIns="18288" anchor="t"/>
-          <a:lstStyle/>
-          <a:p>
-            <a:pPr algn="l">
-              <a:lnSpc>
-                <a:spcPct val="118000"/>
-              </a:lnSpc>
-              <a:spcAft>
-                <a:spcPts val="0"/>
-              </a:spcAft>
-            </a:pPr>
-            <a:r>
-              <a:rPr sz="1100" b="0">
-                <a:solidFill>
-                  <a:srgbClr val="3A7CA5"/>
-                </a:solidFill>
-                <a:latin typeface="微软雅黑"/>
-                <a:ea typeface="微软雅黑"/>
-              </a:rPr>
-              <a:t>Naval Research Logistics，2025</a:t>
-            </a:r>
-          </a:p>
-        </p:txBody>
-      </p:sp>
-      <p:sp>
-        <p:nvSpPr>
-          <p:cNvPr id="30" name="Rounded Rectangle 29"/>
+              <a:t>一方面把统计建模与深度学习结合，用于预后与健康管理；另一方面讨论智能模型与智能装备自身的可靠性评估。</a:t>
+            </a:r>
+          </a:p>
+        </p:txBody>
+      </p:sp>
+      <p:sp>
+        <p:nvSpPr>
+          <p:cNvPr id="26" name="Rounded Rectangle 25"/>
           <p:cNvSpPr/>
           <p:nvPr/>
         </p:nvSpPr>
         <p:spPr>
           <a:xfrm>
-            <a:off x="457200" y="4828032"/>
-            <a:ext cx="5669280" cy="1316736"/>
+            <a:off x="457200" y="5504688"/>
+            <a:ext cx="11247120" cy="932688"/>
           </a:xfrm>
           <a:prstGeom prst="roundRect">
             <a:avLst>
-              <a:gd name="adj" fmla="val 5000"/>
+              <a:gd name="adj" fmla="val 4000"/>
             </a:avLst>
-          </a:prstGeom>
-          <a:solidFill>
-            <a:srgbClr val="FFFFFF"/>
-          </a:solidFill>
-          <a:ln w="6350">
-            <a:solidFill>
-              <a:srgbClr val="D0DCE6"/>
-            </a:solidFill>
-          </a:ln>
-          <a:effectLst/>
-        </p:spPr>
-        <p:style>
-          <a:lnRef idx="1">
-            <a:schemeClr val="accent1"/>
-          </a:lnRef>
-          <a:fillRef idx="3">
-            <a:schemeClr val="accent1"/>
-          </a:fillRef>
-          <a:effectRef idx="2">
-            <a:schemeClr val="accent1"/>
-          </a:effectRef>
-          <a:fontRef idx="minor">
-            <a:schemeClr val="lt1"/>
-          </a:fontRef>
-        </p:style>
-        <p:txBody>
-          <a:bodyPr rtlCol="0" anchor="ctr"/>
-          <a:lstStyle/>
-          <a:p>
-            <a:pPr algn="ctr"/>
-          </a:p>
-        </p:txBody>
-      </p:sp>
-      <p:sp>
-        <p:nvSpPr>
-          <p:cNvPr id="31" name="TextBox 30"/>
-          <p:cNvSpPr txBox="1"/>
-          <p:nvPr/>
-        </p:nvSpPr>
-        <p:spPr>
-          <a:xfrm>
-            <a:off x="658368" y="4956048"/>
-            <a:ext cx="5303520" cy="274320"/>
-          </a:xfrm>
-          <a:prstGeom prst="rect">
-            <a:avLst/>
-          </a:prstGeom>
-          <a:noFill/>
-        </p:spPr>
-        <p:txBody>
-          <a:bodyPr wrap="square" lIns="36576" rIns="36576" tIns="18288" bIns="18288" anchor="t"/>
-          <a:lstStyle/>
-          <a:p>
-            <a:pPr algn="l">
-              <a:lnSpc>
-                <a:spcPct val="118000"/>
-              </a:lnSpc>
-              <a:spcAft>
-                <a:spcPts val="0"/>
-              </a:spcAft>
-            </a:pPr>
-            <a:r>
-              <a:rPr sz="1500" b="1">
-                <a:solidFill>
-                  <a:srgbClr val="0A1F3D"/>
-                </a:solidFill>
-                <a:latin typeface="微软雅黑"/>
-                <a:ea typeface="微软雅黑"/>
-              </a:rPr>
-              <a:t>维修决策</a:t>
-            </a:r>
-          </a:p>
-        </p:txBody>
-      </p:sp>
-      <p:sp>
-        <p:nvSpPr>
-          <p:cNvPr id="32" name="TextBox 31"/>
-          <p:cNvSpPr txBox="1"/>
-          <p:nvPr/>
-        </p:nvSpPr>
-        <p:spPr>
-          <a:xfrm>
-            <a:off x="658368" y="5266944"/>
-            <a:ext cx="5303520" cy="365760"/>
-          </a:xfrm>
-          <a:prstGeom prst="rect">
-            <a:avLst/>
-          </a:prstGeom>
-          <a:noFill/>
-        </p:spPr>
-        <p:txBody>
-          <a:bodyPr wrap="square" lIns="36576" rIns="36576" tIns="18288" bIns="18288" anchor="t"/>
-          <a:lstStyle/>
-          <a:p>
-            <a:pPr algn="l">
-              <a:lnSpc>
-                <a:spcPct val="118000"/>
-              </a:lnSpc>
-              <a:spcAft>
-                <a:spcPts val="0"/>
-              </a:spcAft>
-            </a:pPr>
-            <a:r>
-              <a:rPr sz="1300" b="0">
-                <a:solidFill>
-                  <a:srgbClr val="122033"/>
-                </a:solidFill>
-                <a:latin typeface="微软雅黑"/>
-                <a:ea typeface="微软雅黑"/>
-              </a:rPr>
-              <a:t>把剩余寿命用到维修安排上</a:t>
-            </a:r>
-          </a:p>
-        </p:txBody>
-      </p:sp>
-      <p:sp>
-        <p:nvSpPr>
-          <p:cNvPr id="33" name="TextBox 32"/>
-          <p:cNvSpPr txBox="1"/>
-          <p:nvPr/>
-        </p:nvSpPr>
-        <p:spPr>
-          <a:xfrm>
-            <a:off x="658368" y="5705856"/>
-            <a:ext cx="5303520" cy="256032"/>
-          </a:xfrm>
-          <a:prstGeom prst="rect">
-            <a:avLst/>
-          </a:prstGeom>
-          <a:noFill/>
-        </p:spPr>
-        <p:txBody>
-          <a:bodyPr wrap="square" lIns="36576" rIns="36576" tIns="18288" bIns="18288" anchor="t"/>
-          <a:lstStyle/>
-          <a:p>
-            <a:pPr algn="l">
-              <a:lnSpc>
-                <a:spcPct val="118000"/>
-              </a:lnSpc>
-              <a:spcAft>
-                <a:spcPts val="0"/>
-              </a:spcAft>
-            </a:pPr>
-            <a:r>
-              <a:rPr sz="1100" b="0">
-                <a:solidFill>
-                  <a:srgbClr val="3A7CA5"/>
-                </a:solidFill>
-                <a:latin typeface="微软雅黑"/>
-                <a:ea typeface="微软雅黑"/>
-              </a:rPr>
-              <a:t>RESS，2023</a:t>
-            </a:r>
-          </a:p>
-        </p:txBody>
-      </p:sp>
-      <p:sp>
-        <p:nvSpPr>
-          <p:cNvPr id="34" name="Rounded Rectangle 33"/>
-          <p:cNvSpPr/>
-          <p:nvPr/>
-        </p:nvSpPr>
-        <p:spPr>
-          <a:xfrm>
-            <a:off x="6309360" y="4828032"/>
-            <a:ext cx="5669280" cy="1316736"/>
-          </a:xfrm>
-          <a:prstGeom prst="roundRect">
-            <a:avLst>
-              <a:gd name="adj" fmla="val 5000"/>
-            </a:avLst>
-          </a:prstGeom>
-          <a:solidFill>
-            <a:srgbClr val="FFFFFF"/>
-          </a:solidFill>
-          <a:ln w="6350">
-            <a:solidFill>
-              <a:srgbClr val="D0DCE6"/>
-            </a:solidFill>
-          </a:ln>
-          <a:effectLst/>
-        </p:spPr>
-        <p:style>
-          <a:lnRef idx="1">
-            <a:schemeClr val="accent1"/>
-          </a:lnRef>
-          <a:fillRef idx="3">
-            <a:schemeClr val="accent1"/>
-          </a:fillRef>
-          <a:effectRef idx="2">
-            <a:schemeClr val="accent1"/>
-          </a:effectRef>
-          <a:fontRef idx="minor">
-            <a:schemeClr val="lt1"/>
-          </a:fontRef>
-        </p:style>
-        <p:txBody>
-          <a:bodyPr rtlCol="0" anchor="ctr"/>
-          <a:lstStyle/>
-          <a:p>
-            <a:pPr algn="ctr"/>
-          </a:p>
-        </p:txBody>
-      </p:sp>
-      <p:sp>
-        <p:nvSpPr>
-          <p:cNvPr id="35" name="TextBox 34"/>
-          <p:cNvSpPr txBox="1"/>
-          <p:nvPr/>
-        </p:nvSpPr>
-        <p:spPr>
-          <a:xfrm>
-            <a:off x="6510528" y="4956048"/>
-            <a:ext cx="5303520" cy="274320"/>
-          </a:xfrm>
-          <a:prstGeom prst="rect">
-            <a:avLst/>
-          </a:prstGeom>
-          <a:noFill/>
-        </p:spPr>
-        <p:txBody>
-          <a:bodyPr wrap="square" lIns="36576" rIns="36576" tIns="18288" bIns="18288" anchor="t"/>
-          <a:lstStyle/>
-          <a:p>
-            <a:pPr algn="l">
-              <a:lnSpc>
-                <a:spcPct val="118000"/>
-              </a:lnSpc>
-              <a:spcAft>
-                <a:spcPts val="0"/>
-              </a:spcAft>
-            </a:pPr>
-            <a:r>
-              <a:rPr sz="1500" b="1">
-                <a:solidFill>
-                  <a:srgbClr val="0A1F3D"/>
-                </a:solidFill>
-                <a:latin typeface="微软雅黑"/>
-                <a:ea typeface="微软雅黑"/>
-              </a:rPr>
-              <a:t>航空发动机</a:t>
-            </a:r>
-          </a:p>
-        </p:txBody>
-      </p:sp>
-      <p:sp>
-        <p:nvSpPr>
-          <p:cNvPr id="36" name="TextBox 35"/>
-          <p:cNvSpPr txBox="1"/>
-          <p:nvPr/>
-        </p:nvSpPr>
-        <p:spPr>
-          <a:xfrm>
-            <a:off x="6510528" y="5266944"/>
-            <a:ext cx="5303520" cy="365760"/>
-          </a:xfrm>
-          <a:prstGeom prst="rect">
-            <a:avLst/>
-          </a:prstGeom>
-          <a:noFill/>
-        </p:spPr>
-        <p:txBody>
-          <a:bodyPr wrap="square" lIns="36576" rIns="36576" tIns="18288" bIns="18288" anchor="t"/>
-          <a:lstStyle/>
-          <a:p>
-            <a:pPr algn="l">
-              <a:lnSpc>
-                <a:spcPct val="118000"/>
-              </a:lnSpc>
-              <a:spcAft>
-                <a:spcPts val="0"/>
-              </a:spcAft>
-            </a:pPr>
-            <a:r>
-              <a:rPr sz="1300" b="0">
-                <a:solidFill>
-                  <a:srgbClr val="122033"/>
-                </a:solidFill>
-                <a:latin typeface="微软雅黑"/>
-                <a:ea typeface="微软雅黑"/>
-              </a:rPr>
-              <a:t>数据不出域的联邦学习</a:t>
-            </a:r>
-          </a:p>
-        </p:txBody>
-      </p:sp>
-      <p:sp>
-        <p:nvSpPr>
-          <p:cNvPr id="37" name="TextBox 36"/>
-          <p:cNvSpPr txBox="1"/>
-          <p:nvPr/>
-        </p:nvSpPr>
-        <p:spPr>
-          <a:xfrm>
-            <a:off x="6510528" y="5705856"/>
-            <a:ext cx="5303520" cy="256032"/>
-          </a:xfrm>
-          <a:prstGeom prst="rect">
-            <a:avLst/>
-          </a:prstGeom>
-          <a:noFill/>
-        </p:spPr>
-        <p:txBody>
-          <a:bodyPr wrap="square" lIns="36576" rIns="36576" tIns="18288" bIns="18288" anchor="t"/>
-          <a:lstStyle/>
-          <a:p>
-            <a:pPr algn="l">
-              <a:lnSpc>
-                <a:spcPct val="118000"/>
-              </a:lnSpc>
-              <a:spcAft>
-                <a:spcPts val="0"/>
-              </a:spcAft>
-            </a:pPr>
-            <a:r>
-              <a:rPr sz="1100" b="0">
-                <a:solidFill>
-                  <a:srgbClr val="3A7CA5"/>
-                </a:solidFill>
-                <a:latin typeface="微软雅黑"/>
-                <a:ea typeface="微软雅黑"/>
-              </a:rPr>
-              <a:t>Applied Soft Computing，2025</a:t>
-            </a:r>
-          </a:p>
-        </p:txBody>
-      </p:sp>
-    </p:spTree>
-  </p:cSld>
-  <p:clrMapOvr>
-    <a:masterClrMapping/>
-  </p:clrMapOvr>
-</p:sld>
-</file>
-
-<file path=ppt/slides/slide5.xml><?xml version="1.0" encoding="utf-8"?>
-<p:sld xmlns:a="http://schemas.openxmlformats.org/drawingml/2006/main" xmlns:p="http://schemas.openxmlformats.org/presentationml/2006/main" xmlns:r="http://schemas.openxmlformats.org/officeDocument/2006/relationships">
-  <p:cSld>
-    <p:bg>
-      <p:bgPr>
-        <a:solidFill>
-          <a:srgbClr val="F4F7FB"/>
-        </a:solidFill>
-        <a:effectLst/>
-      </p:bgPr>
-    </p:bg>
-    <p:spTree>
-      <p:nvGrpSpPr>
-        <p:cNvPr id="1" name=""/>
-        <p:cNvGrpSpPr/>
-        <p:nvPr/>
-      </p:nvGrpSpPr>
-      <p:grpSpPr/>
-      <p:sp>
-        <p:nvSpPr>
-          <p:cNvPr id="2" name="Rectangle 1"/>
-          <p:cNvSpPr/>
-          <p:nvPr/>
-        </p:nvSpPr>
-        <p:spPr>
-          <a:xfrm>
-            <a:off x="0" y="0"/>
-            <a:ext cx="12191695" cy="73152"/>
-          </a:xfrm>
-          <a:prstGeom prst="rect">
-            <a:avLst/>
           </a:prstGeom>
           <a:ln>
             <a:noFill/>
@@ -9308,14 +8315,14 @@
       </p:sp>
       <p:sp>
         <p:nvSpPr>
-          <p:cNvPr id="3" name="TextBox 2"/>
+          <p:cNvPr id="27" name="TextBox 26"/>
           <p:cNvSpPr txBox="1"/>
           <p:nvPr/>
         </p:nvSpPr>
         <p:spPr>
           <a:xfrm>
-            <a:off x="502920" y="237744"/>
-            <a:ext cx="11155680" cy="237744"/>
+            <a:off x="658368" y="5650992"/>
+            <a:ext cx="7680960" cy="658368"/>
           </a:xfrm>
           <a:prstGeom prst="rect">
             <a:avLst/>
@@ -9323,7 +8330,7 @@
           <a:noFill/>
         </p:spPr>
         <p:txBody>
-          <a:bodyPr wrap="square" lIns="36576" rIns="36576" tIns="18288" bIns="18288" anchor="t"/>
+          <a:bodyPr wrap="square" lIns="36576" rIns="36576" tIns="18288" bIns="18288" anchor="ctr"/>
           <a:lstStyle/>
           <a:p>
             <a:pPr algn="l">
@@ -9335,28 +8342,28 @@
               </a:spcAft>
             </a:pPr>
             <a:r>
-              <a:rPr sz="1200" b="0">
+              <a:rPr sz="1400" b="0">
                 <a:solidFill>
-                  <a:srgbClr val="3A7CA5"/>
+                  <a:srgbClr val="FFFFFF"/>
                 </a:solidFill>
                 <a:latin typeface="微软雅黑"/>
                 <a:ea typeface="微软雅黑"/>
               </a:rPr>
-              <a:t>其他</a:t>
-            </a:r>
-          </a:p>
-        </p:txBody>
-      </p:sp>
-      <p:sp>
-        <p:nvSpPr>
-          <p:cNvPr id="4" name="TextBox 3"/>
+              <a:t>以上汇报请各位批评指正。</a:t>
+            </a:r>
+          </a:p>
+        </p:txBody>
+      </p:sp>
+      <p:sp>
+        <p:nvSpPr>
+          <p:cNvPr id="28" name="TextBox 27"/>
           <p:cNvSpPr txBox="1"/>
           <p:nvPr/>
         </p:nvSpPr>
         <p:spPr>
           <a:xfrm>
-            <a:off x="502920" y="475488"/>
-            <a:ext cx="11155680" cy="402336"/>
+            <a:off x="8321040" y="5632704"/>
+            <a:ext cx="3200400" cy="694944"/>
           </a:xfrm>
           <a:prstGeom prst="rect">
             <a:avLst/>
@@ -9364,8 +8371,28 @@
           <a:noFill/>
         </p:spPr>
         <p:txBody>
-          <a:bodyPr wrap="square" lIns="36576" rIns="36576" tIns="18288" bIns="18288" anchor="t"/>
-          <a:lstStyle/>
+          <a:bodyPr wrap="square" lIns="36576" rIns="36576" tIns="18288" bIns="18288" anchor="ctr"/>
+          <a:lstStyle/>
+          <a:p>
+            <a:pPr algn="l">
+              <a:lnSpc>
+                <a:spcPct val="118000"/>
+              </a:lnSpc>
+              <a:spcAft>
+                <a:spcPts val="200"/>
+              </a:spcAft>
+            </a:pPr>
+            <a:r>
+              <a:rPr sz="1200" b="0">
+                <a:solidFill>
+                  <a:srgbClr val="FFFFFF"/>
+                </a:solidFill>
+                <a:latin typeface="微软雅黑"/>
+                <a:ea typeface="微软雅黑"/>
+              </a:rPr>
+              <a:t>xuancha@mail.zjgsu.edu.cn</a:t>
+            </a:r>
+          </a:p>
           <a:p>
             <a:pPr algn="l">
               <a:lnSpc>
@@ -9376,1055 +8403,7 @@
               </a:spcAft>
             </a:pPr>
             <a:r>
-              <a:rPr sz="2400" b="1">
-                <a:solidFill>
-                  <a:srgbClr val="0A1F3D"/>
-                </a:solidFill>
-                <a:latin typeface="微软雅黑"/>
-                <a:ea typeface="微软雅黑"/>
-              </a:rPr>
-              <a:t>小样本、应用，还有没做完的</a:t>
-            </a:r>
-          </a:p>
-        </p:txBody>
-      </p:sp>
-      <p:sp>
-        <p:nvSpPr>
-          <p:cNvPr id="5" name="Rectangle 4"/>
-          <p:cNvSpPr/>
-          <p:nvPr/>
-        </p:nvSpPr>
-        <p:spPr>
-          <a:xfrm>
-            <a:off x="502920" y="932688"/>
-            <a:ext cx="384048" cy="36576"/>
-          </a:xfrm>
-          <a:prstGeom prst="rect">
-            <a:avLst/>
-          </a:prstGeom>
-          <a:solidFill>
-            <a:srgbClr val="3A7CA5"/>
-          </a:solidFill>
-          <a:ln>
-            <a:noFill/>
-          </a:ln>
-          <a:effectLst/>
-        </p:spPr>
-        <p:style>
-          <a:lnRef idx="1">
-            <a:schemeClr val="accent1"/>
-          </a:lnRef>
-          <a:fillRef idx="3">
-            <a:schemeClr val="accent1"/>
-          </a:fillRef>
-          <a:effectRef idx="2">
-            <a:schemeClr val="accent1"/>
-          </a:effectRef>
-          <a:fontRef idx="minor">
-            <a:schemeClr val="lt1"/>
-          </a:fontRef>
-        </p:style>
-        <p:txBody>
-          <a:bodyPr rtlCol="0" anchor="ctr"/>
-          <a:lstStyle/>
-          <a:p>
-            <a:pPr algn="ctr"/>
-          </a:p>
-        </p:txBody>
-      </p:sp>
-      <p:sp>
-        <p:nvSpPr>
-          <p:cNvPr id="6" name="Rectangle 5"/>
-          <p:cNvSpPr/>
-          <p:nvPr/>
-        </p:nvSpPr>
-        <p:spPr>
-          <a:xfrm>
-            <a:off x="0" y="6638544"/>
-            <a:ext cx="12191695" cy="219456"/>
-          </a:xfrm>
-          <a:prstGeom prst="rect">
-            <a:avLst/>
-          </a:prstGeom>
-          <a:solidFill>
-            <a:srgbClr val="0A1F3D"/>
-          </a:solidFill>
-          <a:ln>
-            <a:noFill/>
-          </a:ln>
-          <a:effectLst/>
-        </p:spPr>
-        <p:style>
-          <a:lnRef idx="1">
-            <a:schemeClr val="accent1"/>
-          </a:lnRef>
-          <a:fillRef idx="3">
-            <a:schemeClr val="accent1"/>
-          </a:fillRef>
-          <a:effectRef idx="2">
-            <a:schemeClr val="accent1"/>
-          </a:effectRef>
-          <a:fontRef idx="minor">
-            <a:schemeClr val="lt1"/>
-          </a:fontRef>
-        </p:style>
-        <p:txBody>
-          <a:bodyPr rtlCol="0" anchor="ctr"/>
-          <a:lstStyle/>
-          <a:p>
-            <a:pPr algn="ctr"/>
-          </a:p>
-        </p:txBody>
-      </p:sp>
-      <p:sp>
-        <p:nvSpPr>
-          <p:cNvPr id="7" name="TextBox 6"/>
-          <p:cNvSpPr txBox="1"/>
-          <p:nvPr/>
-        </p:nvSpPr>
-        <p:spPr>
-          <a:xfrm>
-            <a:off x="457200" y="6638544"/>
-            <a:ext cx="9326880" cy="219456"/>
-          </a:xfrm>
-          <a:prstGeom prst="rect">
-            <a:avLst/>
-          </a:prstGeom>
-          <a:noFill/>
-        </p:spPr>
-        <p:txBody>
-          <a:bodyPr wrap="square" lIns="36576" rIns="36576" tIns="18288" bIns="18288" anchor="ctr"/>
-          <a:lstStyle/>
-          <a:p>
-            <a:pPr algn="l">
-              <a:lnSpc>
-                <a:spcPct val="118000"/>
-              </a:lnSpc>
-              <a:spcAft>
-                <a:spcPts val="0"/>
-              </a:spcAft>
-            </a:pPr>
-            <a:r>
-              <a:rPr sz="1000" b="0">
-                <a:solidFill>
-                  <a:srgbClr val="B8CDDE"/>
-                </a:solidFill>
-                <a:latin typeface="微软雅黑"/>
-                <a:ea typeface="微软雅黑"/>
-              </a:rPr>
-              <a:t>徐安察    浙江工商大学统计与数据科学学院</a:t>
-            </a:r>
-          </a:p>
-        </p:txBody>
-      </p:sp>
-      <p:sp>
-        <p:nvSpPr>
-          <p:cNvPr id="8" name="TextBox 7"/>
-          <p:cNvSpPr txBox="1"/>
-          <p:nvPr/>
-        </p:nvSpPr>
-        <p:spPr>
-          <a:xfrm>
-            <a:off x="10515600" y="6638544"/>
-            <a:ext cx="1280160" cy="219456"/>
-          </a:xfrm>
-          <a:prstGeom prst="rect">
-            <a:avLst/>
-          </a:prstGeom>
-          <a:noFill/>
-        </p:spPr>
-        <p:txBody>
-          <a:bodyPr wrap="square" lIns="36576" rIns="36576" tIns="18288" bIns="18288" anchor="ctr"/>
-          <a:lstStyle/>
-          <a:p>
-            <a:pPr algn="r">
-              <a:lnSpc>
-                <a:spcPct val="118000"/>
-              </a:lnSpc>
-              <a:spcAft>
-                <a:spcPts val="0"/>
-              </a:spcAft>
-            </a:pPr>
-            <a:r>
-              <a:rPr sz="1000" b="0">
-                <a:solidFill>
-                  <a:srgbClr val="C5D6E6"/>
-                </a:solidFill>
-                <a:latin typeface="微软雅黑"/>
-                <a:ea typeface="微软雅黑"/>
-              </a:rPr>
-              <a:t>05  /  05</a:t>
-            </a:r>
-          </a:p>
-        </p:txBody>
-      </p:sp>
-      <p:sp>
-        <p:nvSpPr>
-          <p:cNvPr id="9" name="Rounded Rectangle 8"/>
-          <p:cNvSpPr/>
-          <p:nvPr/>
-        </p:nvSpPr>
-        <p:spPr>
-          <a:xfrm>
-            <a:off x="457200" y="1133856"/>
-            <a:ext cx="3675887" cy="3657600"/>
-          </a:xfrm>
-          <a:prstGeom prst="roundRect">
-            <a:avLst>
-              <a:gd name="adj" fmla="val 5000"/>
-            </a:avLst>
-          </a:prstGeom>
-          <a:solidFill>
-            <a:srgbClr val="FFFFFF"/>
-          </a:solidFill>
-          <a:ln w="6350">
-            <a:solidFill>
-              <a:srgbClr val="D0DCE6"/>
-            </a:solidFill>
-          </a:ln>
-          <a:effectLst/>
-        </p:spPr>
-        <p:style>
-          <a:lnRef idx="1">
-            <a:schemeClr val="accent1"/>
-          </a:lnRef>
-          <a:fillRef idx="3">
-            <a:schemeClr val="accent1"/>
-          </a:fillRef>
-          <a:effectRef idx="2">
-            <a:schemeClr val="accent1"/>
-          </a:effectRef>
-          <a:fontRef idx="minor">
-            <a:schemeClr val="lt1"/>
-          </a:fontRef>
-        </p:style>
-        <p:txBody>
-          <a:bodyPr rtlCol="0" anchor="ctr"/>
-          <a:lstStyle/>
-          <a:p>
-            <a:pPr algn="ctr"/>
-          </a:p>
-        </p:txBody>
-      </p:sp>
-      <p:sp>
-        <p:nvSpPr>
-          <p:cNvPr id="10" name="Rectangle 9"/>
-          <p:cNvSpPr/>
-          <p:nvPr/>
-        </p:nvSpPr>
-        <p:spPr>
-          <a:xfrm>
-            <a:off x="457200" y="1133856"/>
-            <a:ext cx="3675887" cy="54864"/>
-          </a:xfrm>
-          <a:prstGeom prst="rect">
-            <a:avLst/>
-          </a:prstGeom>
-          <a:solidFill>
-            <a:srgbClr val="3A7CA5"/>
-          </a:solidFill>
-          <a:ln>
-            <a:noFill/>
-          </a:ln>
-          <a:effectLst/>
-        </p:spPr>
-        <p:style>
-          <a:lnRef idx="1">
-            <a:schemeClr val="accent1"/>
-          </a:lnRef>
-          <a:fillRef idx="3">
-            <a:schemeClr val="accent1"/>
-          </a:fillRef>
-          <a:effectRef idx="2">
-            <a:schemeClr val="accent1"/>
-          </a:effectRef>
-          <a:fontRef idx="minor">
-            <a:schemeClr val="lt1"/>
-          </a:fontRef>
-        </p:style>
-        <p:txBody>
-          <a:bodyPr rtlCol="0" anchor="ctr"/>
-          <a:lstStyle/>
-          <a:p>
-            <a:pPr algn="ctr"/>
-          </a:p>
-        </p:txBody>
-      </p:sp>
-      <p:sp>
-        <p:nvSpPr>
-          <p:cNvPr id="11" name="TextBox 10"/>
-          <p:cNvSpPr txBox="1"/>
-          <p:nvPr/>
-        </p:nvSpPr>
-        <p:spPr>
-          <a:xfrm>
-            <a:off x="640080" y="1335024"/>
-            <a:ext cx="3310128" cy="457200"/>
-          </a:xfrm>
-          <a:prstGeom prst="rect">
-            <a:avLst/>
-          </a:prstGeom>
-          <a:noFill/>
-        </p:spPr>
-        <p:txBody>
-          <a:bodyPr wrap="square" lIns="36576" rIns="36576" tIns="18288" bIns="18288" anchor="t"/>
-          <a:lstStyle/>
-          <a:p>
-            <a:pPr algn="l">
-              <a:lnSpc>
-                <a:spcPct val="118000"/>
-              </a:lnSpc>
-              <a:spcAft>
-                <a:spcPts val="0"/>
-              </a:spcAft>
-            </a:pPr>
-            <a:r>
-              <a:rPr sz="1500" b="1">
-                <a:solidFill>
-                  <a:srgbClr val="0A1F3D"/>
-                </a:solidFill>
-                <a:latin typeface="微软雅黑"/>
-                <a:ea typeface="微软雅黑"/>
-              </a:rPr>
-              <a:t>小样本</a:t>
-            </a:r>
-          </a:p>
-        </p:txBody>
-      </p:sp>
-      <p:sp>
-        <p:nvSpPr>
-          <p:cNvPr id="12" name="TextBox 11"/>
-          <p:cNvSpPr txBox="1"/>
-          <p:nvPr/>
-        </p:nvSpPr>
-        <p:spPr>
-          <a:xfrm>
-            <a:off x="640080" y="1883664"/>
-            <a:ext cx="3310128" cy="2697480"/>
-          </a:xfrm>
-          <a:prstGeom prst="rect">
-            <a:avLst/>
-          </a:prstGeom>
-          <a:noFill/>
-        </p:spPr>
-        <p:txBody>
-          <a:bodyPr wrap="square" lIns="36576" rIns="36576" tIns="18288" bIns="18288" anchor="t"/>
-          <a:lstStyle/>
-          <a:p>
-            <a:pPr algn="l">
-              <a:lnSpc>
-                <a:spcPct val="118000"/>
-              </a:lnSpc>
-              <a:spcAft>
-                <a:spcPts val="800"/>
-              </a:spcAft>
-            </a:pPr>
-            <a:r>
-              <a:rPr sz="1300" b="0">
-                <a:solidFill>
-                  <a:srgbClr val="122033"/>
-                </a:solidFill>
-                <a:latin typeface="微软雅黑"/>
-                <a:ea typeface="微软雅黑"/>
-              </a:rPr>
-              <a:t>·  博士阶段开始做参考先验和后验正常性</a:t>
-            </a:r>
-          </a:p>
-          <a:p>
-            <a:pPr algn="l">
-              <a:lnSpc>
-                <a:spcPct val="118000"/>
-              </a:lnSpc>
-              <a:spcAft>
-                <a:spcPts val="800"/>
-              </a:spcAft>
-            </a:pPr>
-            <a:r>
-              <a:rPr sz="1300" b="0">
-                <a:solidFill>
-                  <a:srgbClr val="122033"/>
-                </a:solidFill>
-                <a:latin typeface="微软雅黑"/>
-                <a:ea typeface="微软雅黑"/>
-              </a:rPr>
-              <a:t>·  后来做到屏蔽数据、竞争失效</a:t>
-            </a:r>
-          </a:p>
-          <a:p>
-            <a:pPr algn="l">
-              <a:lnSpc>
-                <a:spcPct val="118000"/>
-              </a:lnSpc>
-              <a:spcAft>
-                <a:spcPts val="800"/>
-              </a:spcAft>
-            </a:pPr>
-            <a:r>
-              <a:rPr sz="1300" b="0">
-                <a:solidFill>
-                  <a:srgbClr val="122033"/>
-                </a:solidFill>
-                <a:latin typeface="微软雅黑"/>
-                <a:ea typeface="微软雅黑"/>
-              </a:rPr>
-              <a:t>·  也做加速寿命和加速退化</a:t>
-            </a:r>
-          </a:p>
-          <a:p>
-            <a:pPr algn="l">
-              <a:lnSpc>
-                <a:spcPct val="118000"/>
-              </a:lnSpc>
-              <a:spcAft>
-                <a:spcPts val="800"/>
-              </a:spcAft>
-            </a:pPr>
-            <a:r>
-              <a:rPr sz="1300" b="0">
-                <a:solidFill>
-                  <a:srgbClr val="122033"/>
-                </a:solidFill>
-                <a:latin typeface="微软雅黑"/>
-                <a:ea typeface="微软雅黑"/>
-              </a:rPr>
-              <a:t>·  主要写在 IEEE TR、CSDA、JSPI</a:t>
-            </a:r>
-          </a:p>
-        </p:txBody>
-      </p:sp>
-      <p:sp>
-        <p:nvSpPr>
-          <p:cNvPr id="13" name="Rounded Rectangle 12"/>
-          <p:cNvSpPr/>
-          <p:nvPr/>
-        </p:nvSpPr>
-        <p:spPr>
-          <a:xfrm>
-            <a:off x="4297680" y="1133856"/>
-            <a:ext cx="3675887" cy="3657600"/>
-          </a:xfrm>
-          <a:prstGeom prst="roundRect">
-            <a:avLst>
-              <a:gd name="adj" fmla="val 5000"/>
-            </a:avLst>
-          </a:prstGeom>
-          <a:solidFill>
-            <a:srgbClr val="FFFFFF"/>
-          </a:solidFill>
-          <a:ln w="6350">
-            <a:solidFill>
-              <a:srgbClr val="D0DCE6"/>
-            </a:solidFill>
-          </a:ln>
-          <a:effectLst/>
-        </p:spPr>
-        <p:style>
-          <a:lnRef idx="1">
-            <a:schemeClr val="accent1"/>
-          </a:lnRef>
-          <a:fillRef idx="3">
-            <a:schemeClr val="accent1"/>
-          </a:fillRef>
-          <a:effectRef idx="2">
-            <a:schemeClr val="accent1"/>
-          </a:effectRef>
-          <a:fontRef idx="minor">
-            <a:schemeClr val="lt1"/>
-          </a:fontRef>
-        </p:style>
-        <p:txBody>
-          <a:bodyPr rtlCol="0" anchor="ctr"/>
-          <a:lstStyle/>
-          <a:p>
-            <a:pPr algn="ctr"/>
-          </a:p>
-        </p:txBody>
-      </p:sp>
-      <p:sp>
-        <p:nvSpPr>
-          <p:cNvPr id="14" name="Rectangle 13"/>
-          <p:cNvSpPr/>
-          <p:nvPr/>
-        </p:nvSpPr>
-        <p:spPr>
-          <a:xfrm>
-            <a:off x="4297680" y="1133856"/>
-            <a:ext cx="3675887" cy="54864"/>
-          </a:xfrm>
-          <a:prstGeom prst="rect">
-            <a:avLst/>
-          </a:prstGeom>
-          <a:solidFill>
-            <a:srgbClr val="123A63"/>
-          </a:solidFill>
-          <a:ln>
-            <a:noFill/>
-          </a:ln>
-          <a:effectLst/>
-        </p:spPr>
-        <p:style>
-          <a:lnRef idx="1">
-            <a:schemeClr val="accent1"/>
-          </a:lnRef>
-          <a:fillRef idx="3">
-            <a:schemeClr val="accent1"/>
-          </a:fillRef>
-          <a:effectRef idx="2">
-            <a:schemeClr val="accent1"/>
-          </a:effectRef>
-          <a:fontRef idx="minor">
-            <a:schemeClr val="lt1"/>
-          </a:fontRef>
-        </p:style>
-        <p:txBody>
-          <a:bodyPr rtlCol="0" anchor="ctr"/>
-          <a:lstStyle/>
-          <a:p>
-            <a:pPr algn="ctr"/>
-          </a:p>
-        </p:txBody>
-      </p:sp>
-      <p:sp>
-        <p:nvSpPr>
-          <p:cNvPr id="15" name="TextBox 14"/>
-          <p:cNvSpPr txBox="1"/>
-          <p:nvPr/>
-        </p:nvSpPr>
-        <p:spPr>
-          <a:xfrm>
-            <a:off x="4480560" y="1335024"/>
-            <a:ext cx="3310128" cy="457200"/>
-          </a:xfrm>
-          <a:prstGeom prst="rect">
-            <a:avLst/>
-          </a:prstGeom>
-          <a:noFill/>
-        </p:spPr>
-        <p:txBody>
-          <a:bodyPr wrap="square" lIns="36576" rIns="36576" tIns="18288" bIns="18288" anchor="t"/>
-          <a:lstStyle/>
-          <a:p>
-            <a:pPr algn="l">
-              <a:lnSpc>
-                <a:spcPct val="118000"/>
-              </a:lnSpc>
-              <a:spcAft>
-                <a:spcPts val="0"/>
-              </a:spcAft>
-            </a:pPr>
-            <a:r>
-              <a:rPr sz="1500" b="1">
-                <a:solidFill>
-                  <a:srgbClr val="0A1F3D"/>
-                </a:solidFill>
-                <a:latin typeface="微软雅黑"/>
-                <a:ea typeface="微软雅黑"/>
-              </a:rPr>
-              <a:t>应用</a:t>
-            </a:r>
-          </a:p>
-        </p:txBody>
-      </p:sp>
-      <p:sp>
-        <p:nvSpPr>
-          <p:cNvPr id="16" name="TextBox 15"/>
-          <p:cNvSpPr txBox="1"/>
-          <p:nvPr/>
-        </p:nvSpPr>
-        <p:spPr>
-          <a:xfrm>
-            <a:off x="4480560" y="1883664"/>
-            <a:ext cx="3310128" cy="2697480"/>
-          </a:xfrm>
-          <a:prstGeom prst="rect">
-            <a:avLst/>
-          </a:prstGeom>
-          <a:noFill/>
-        </p:spPr>
-        <p:txBody>
-          <a:bodyPr wrap="square" lIns="36576" rIns="36576" tIns="18288" bIns="18288" anchor="t"/>
-          <a:lstStyle/>
-          <a:p>
-            <a:pPr algn="l">
-              <a:lnSpc>
-                <a:spcPct val="118000"/>
-              </a:lnSpc>
-              <a:spcAft>
-                <a:spcPts val="800"/>
-              </a:spcAft>
-            </a:pPr>
-            <a:r>
-              <a:rPr sz="1300" b="0">
-                <a:solidFill>
-                  <a:srgbClr val="122033"/>
-                </a:solidFill>
-                <a:latin typeface="微软雅黑"/>
-                <a:ea typeface="微软雅黑"/>
-              </a:rPr>
-              <a:t>·  永磁制动器的小样本评估</a:t>
-            </a:r>
-          </a:p>
-          <a:p>
-            <a:pPr algn="l">
-              <a:lnSpc>
-                <a:spcPct val="118000"/>
-              </a:lnSpc>
-              <a:spcAft>
-                <a:spcPts val="800"/>
-              </a:spcAft>
-            </a:pPr>
-            <a:r>
-              <a:rPr sz="1300" b="0">
-                <a:solidFill>
-                  <a:srgbClr val="122033"/>
-                </a:solidFill>
-                <a:latin typeface="微软雅黑"/>
-                <a:ea typeface="微软雅黑"/>
-              </a:rPr>
-              <a:t>·  和华为做过 Weibull 算法、隐患预警</a:t>
-            </a:r>
-          </a:p>
-          <a:p>
-            <a:pPr algn="l">
-              <a:lnSpc>
-                <a:spcPct val="118000"/>
-              </a:lnSpc>
-              <a:spcAft>
-                <a:spcPts val="800"/>
-              </a:spcAft>
-            </a:pPr>
-            <a:r>
-              <a:rPr sz="1300" b="0">
-                <a:solidFill>
-                  <a:srgbClr val="122033"/>
-                </a:solidFill>
-                <a:latin typeface="微软雅黑"/>
-                <a:ea typeface="微软雅黑"/>
-              </a:rPr>
-              <a:t>·  动态环境下的系统可靠性</a:t>
-            </a:r>
-          </a:p>
-          <a:p>
-            <a:pPr algn="l">
-              <a:lnSpc>
-                <a:spcPct val="118000"/>
-              </a:lnSpc>
-              <a:spcAft>
-                <a:spcPts val="800"/>
-              </a:spcAft>
-            </a:pPr>
-            <a:r>
-              <a:rPr sz="1300" b="0">
-                <a:solidFill>
-                  <a:srgbClr val="122033"/>
-                </a:solidFill>
-                <a:latin typeface="微软雅黑"/>
-                <a:ea typeface="微软雅黑"/>
-              </a:rPr>
-              <a:t>·  加速试验和现场数据怎么一起用</a:t>
-            </a:r>
-          </a:p>
-        </p:txBody>
-      </p:sp>
-      <p:sp>
-        <p:nvSpPr>
-          <p:cNvPr id="17" name="Rounded Rectangle 16"/>
-          <p:cNvSpPr/>
-          <p:nvPr/>
-        </p:nvSpPr>
-        <p:spPr>
-          <a:xfrm>
-            <a:off x="8138160" y="1133856"/>
-            <a:ext cx="3675887" cy="3657600"/>
-          </a:xfrm>
-          <a:prstGeom prst="roundRect">
-            <a:avLst>
-              <a:gd name="adj" fmla="val 5000"/>
-            </a:avLst>
-          </a:prstGeom>
-          <a:solidFill>
-            <a:srgbClr val="FFFFFF"/>
-          </a:solidFill>
-          <a:ln w="6350">
-            <a:solidFill>
-              <a:srgbClr val="D0DCE6"/>
-            </a:solidFill>
-          </a:ln>
-          <a:effectLst/>
-        </p:spPr>
-        <p:style>
-          <a:lnRef idx="1">
-            <a:schemeClr val="accent1"/>
-          </a:lnRef>
-          <a:fillRef idx="3">
-            <a:schemeClr val="accent1"/>
-          </a:fillRef>
-          <a:effectRef idx="2">
-            <a:schemeClr val="accent1"/>
-          </a:effectRef>
-          <a:fontRef idx="minor">
-            <a:schemeClr val="lt1"/>
-          </a:fontRef>
-        </p:style>
-        <p:txBody>
-          <a:bodyPr rtlCol="0" anchor="ctr"/>
-          <a:lstStyle/>
-          <a:p>
-            <a:pPr algn="ctr"/>
-          </a:p>
-        </p:txBody>
-      </p:sp>
-      <p:sp>
-        <p:nvSpPr>
-          <p:cNvPr id="18" name="Rectangle 17"/>
-          <p:cNvSpPr/>
-          <p:nvPr/>
-        </p:nvSpPr>
-        <p:spPr>
-          <a:xfrm>
-            <a:off x="8138160" y="1133856"/>
-            <a:ext cx="3675887" cy="54864"/>
-          </a:xfrm>
-          <a:prstGeom prst="rect">
-            <a:avLst/>
-          </a:prstGeom>
-          <a:solidFill>
-            <a:srgbClr val="0A1F3D"/>
-          </a:solidFill>
-          <a:ln>
-            <a:noFill/>
-          </a:ln>
-          <a:effectLst/>
-        </p:spPr>
-        <p:style>
-          <a:lnRef idx="1">
-            <a:schemeClr val="accent1"/>
-          </a:lnRef>
-          <a:fillRef idx="3">
-            <a:schemeClr val="accent1"/>
-          </a:fillRef>
-          <a:effectRef idx="2">
-            <a:schemeClr val="accent1"/>
-          </a:effectRef>
-          <a:fontRef idx="minor">
-            <a:schemeClr val="lt1"/>
-          </a:fontRef>
-        </p:style>
-        <p:txBody>
-          <a:bodyPr rtlCol="0" anchor="ctr"/>
-          <a:lstStyle/>
-          <a:p>
-            <a:pPr algn="ctr"/>
-          </a:p>
-        </p:txBody>
-      </p:sp>
-      <p:sp>
-        <p:nvSpPr>
-          <p:cNvPr id="19" name="TextBox 18"/>
-          <p:cNvSpPr txBox="1"/>
-          <p:nvPr/>
-        </p:nvSpPr>
-        <p:spPr>
-          <a:xfrm>
-            <a:off x="8321040" y="1335024"/>
-            <a:ext cx="3310128" cy="457200"/>
-          </a:xfrm>
-          <a:prstGeom prst="rect">
-            <a:avLst/>
-          </a:prstGeom>
-          <a:noFill/>
-        </p:spPr>
-        <p:txBody>
-          <a:bodyPr wrap="square" lIns="36576" rIns="36576" tIns="18288" bIns="18288" anchor="t"/>
-          <a:lstStyle/>
-          <a:p>
-            <a:pPr algn="l">
-              <a:lnSpc>
-                <a:spcPct val="118000"/>
-              </a:lnSpc>
-              <a:spcAft>
-                <a:spcPts val="0"/>
-              </a:spcAft>
-            </a:pPr>
-            <a:r>
-              <a:rPr sz="1500" b="1">
-                <a:solidFill>
-                  <a:srgbClr val="0A1F3D"/>
-                </a:solidFill>
-                <a:latin typeface="微软雅黑"/>
-                <a:ea typeface="微软雅黑"/>
-              </a:rPr>
-              <a:t>后面还想搞清楚的</a:t>
-            </a:r>
-          </a:p>
-        </p:txBody>
-      </p:sp>
-      <p:sp>
-        <p:nvSpPr>
-          <p:cNvPr id="20" name="TextBox 19"/>
-          <p:cNvSpPr txBox="1"/>
-          <p:nvPr/>
-        </p:nvSpPr>
-        <p:spPr>
-          <a:xfrm>
-            <a:off x="8321040" y="1883664"/>
-            <a:ext cx="3310128" cy="2697480"/>
-          </a:xfrm>
-          <a:prstGeom prst="rect">
-            <a:avLst/>
-          </a:prstGeom>
-          <a:noFill/>
-        </p:spPr>
-        <p:txBody>
-          <a:bodyPr wrap="square" lIns="36576" rIns="36576" tIns="18288" bIns="18288" anchor="t"/>
-          <a:lstStyle/>
-          <a:p>
-            <a:pPr algn="l">
-              <a:lnSpc>
-                <a:spcPct val="118000"/>
-              </a:lnSpc>
-              <a:spcAft>
-                <a:spcPts val="800"/>
-              </a:spcAft>
-            </a:pPr>
-            <a:r>
-              <a:rPr sz="1300" b="0">
-                <a:solidFill>
-                  <a:srgbClr val="122033"/>
-                </a:solidFill>
-                <a:latin typeface="微软雅黑"/>
-                <a:ea typeface="微软雅黑"/>
-              </a:rPr>
-              <a:t>·  多维偏态厚尾，参数怎么定才稳</a:t>
-            </a:r>
-          </a:p>
-          <a:p>
-            <a:pPr algn="l">
-              <a:lnSpc>
-                <a:spcPct val="118000"/>
-              </a:lnSpc>
-              <a:spcAft>
-                <a:spcPts val="800"/>
-              </a:spcAft>
-            </a:pPr>
-            <a:r>
-              <a:rPr sz="1300" b="0">
-                <a:solidFill>
-                  <a:srgbClr val="122033"/>
-                </a:solidFill>
-                <a:latin typeface="微软雅黑"/>
-                <a:ea typeface="微软雅黑"/>
-              </a:rPr>
-              <a:t>·  在线更新之后，区间还准不准</a:t>
-            </a:r>
-          </a:p>
-          <a:p>
-            <a:pPr algn="l">
-              <a:lnSpc>
-                <a:spcPct val="118000"/>
-              </a:lnSpc>
-              <a:spcAft>
-                <a:spcPts val="800"/>
-              </a:spcAft>
-            </a:pPr>
-            <a:r>
-              <a:rPr sz="1300" b="0">
-                <a:solidFill>
-                  <a:srgbClr val="122033"/>
-                </a:solidFill>
-                <a:latin typeface="微软雅黑"/>
-                <a:ea typeface="微软雅黑"/>
-              </a:rPr>
-              <a:t>·  试验往现场外推，偏差从哪来</a:t>
-            </a:r>
-          </a:p>
-          <a:p>
-            <a:pPr algn="l">
-              <a:lnSpc>
-                <a:spcPct val="118000"/>
-              </a:lnSpc>
-              <a:spcAft>
-                <a:spcPts val="800"/>
-              </a:spcAft>
-            </a:pPr>
-            <a:r>
-              <a:rPr sz="1300" b="0">
-                <a:solidFill>
-                  <a:srgbClr val="122033"/>
-                </a:solidFill>
-                <a:latin typeface="微软雅黑"/>
-                <a:ea typeface="微软雅黑"/>
-              </a:rPr>
-              <a:t>·  试验设计怎么同时照顾评估和预测</a:t>
-            </a:r>
-          </a:p>
-        </p:txBody>
-      </p:sp>
-      <p:sp>
-        <p:nvSpPr>
-          <p:cNvPr id="21" name="Rounded Rectangle 20"/>
-          <p:cNvSpPr/>
-          <p:nvPr/>
-        </p:nvSpPr>
-        <p:spPr>
-          <a:xfrm>
-            <a:off x="457200" y="4956048"/>
-            <a:ext cx="11247120" cy="1481328"/>
-          </a:xfrm>
-          <a:prstGeom prst="roundRect">
-            <a:avLst>
-              <a:gd name="adj" fmla="val 4000"/>
-            </a:avLst>
-          </a:prstGeom>
-          <a:ln>
-            <a:noFill/>
-          </a:ln>
-          <a:effectLst/>
-          <a:gradFill>
-            <a:gsLst>
-              <a:gs pos="0">
-                <a:srgbClr val="0A1F3D"/>
-              </a:gs>
-              <a:gs pos="100000">
-                <a:srgbClr val="1E4E7A"/>
-              </a:gs>
-            </a:gsLst>
-            <a:lin ang="0" scaled="0"/>
-          </a:gradFill>
-        </p:spPr>
-        <p:style>
-          <a:lnRef idx="1">
-            <a:schemeClr val="accent1"/>
-          </a:lnRef>
-          <a:fillRef idx="3">
-            <a:schemeClr val="accent1"/>
-          </a:fillRef>
-          <a:effectRef idx="2">
-            <a:schemeClr val="accent1"/>
-          </a:effectRef>
-          <a:fontRef idx="minor">
-            <a:schemeClr val="lt1"/>
-          </a:fontRef>
-        </p:style>
-        <p:txBody>
-          <a:bodyPr rtlCol="0" anchor="ctr"/>
-          <a:lstStyle/>
-          <a:p>
-            <a:pPr algn="ctr"/>
-          </a:p>
-        </p:txBody>
-      </p:sp>
-      <p:sp>
-        <p:nvSpPr>
-          <p:cNvPr id="22" name="TextBox 21"/>
-          <p:cNvSpPr txBox="1"/>
-          <p:nvPr/>
-        </p:nvSpPr>
-        <p:spPr>
-          <a:xfrm>
-            <a:off x="676656" y="5120640"/>
-            <a:ext cx="7680960" cy="1097280"/>
-          </a:xfrm>
-          <a:prstGeom prst="rect">
-            <a:avLst/>
-          </a:prstGeom>
-          <a:noFill/>
-        </p:spPr>
-        <p:txBody>
-          <a:bodyPr wrap="square" lIns="36576" rIns="36576" tIns="18288" bIns="18288" anchor="t"/>
-          <a:lstStyle/>
-          <a:p>
-            <a:pPr algn="l">
-              <a:lnSpc>
-                <a:spcPct val="118000"/>
-              </a:lnSpc>
-              <a:spcAft>
-                <a:spcPts val="600"/>
-              </a:spcAft>
-            </a:pPr>
-            <a:r>
-              <a:rPr sz="1500" b="0">
-                <a:solidFill>
-                  <a:srgbClr val="FFFFFF"/>
-                </a:solidFill>
-                <a:latin typeface="微软雅黑"/>
-                <a:ea typeface="微软雅黑"/>
-              </a:rPr>
-              <a:t>后面这几件事还没有想清楚，希望听听各位的意见。</a:t>
-            </a:r>
-          </a:p>
-          <a:p>
-            <a:pPr algn="l">
-              <a:lnSpc>
-                <a:spcPct val="118000"/>
-              </a:lnSpc>
-              <a:spcAft>
-                <a:spcPts val="0"/>
-              </a:spcAft>
-            </a:pPr>
-            <a:r>
-              <a:rPr sz="1400" b="0">
-                <a:solidFill>
-                  <a:srgbClr val="C5D6E6"/>
-                </a:solidFill>
-                <a:latin typeface="微软雅黑"/>
-                <a:ea typeface="微软雅黑"/>
-              </a:rPr>
-              <a:t>谢谢。</a:t>
-            </a:r>
-          </a:p>
-        </p:txBody>
-      </p:sp>
-      <p:sp>
-        <p:nvSpPr>
-          <p:cNvPr id="23" name="TextBox 22"/>
-          <p:cNvSpPr txBox="1"/>
-          <p:nvPr/>
-        </p:nvSpPr>
-        <p:spPr>
-          <a:xfrm>
-            <a:off x="8503920" y="5175504"/>
-            <a:ext cx="2971800" cy="1051560"/>
-          </a:xfrm>
-          <a:prstGeom prst="rect">
-            <a:avLst/>
-          </a:prstGeom>
-          <a:noFill/>
-        </p:spPr>
-        <p:txBody>
-          <a:bodyPr wrap="square" lIns="36576" rIns="36576" tIns="18288" bIns="18288" anchor="t"/>
-          <a:lstStyle/>
-          <a:p>
-            <a:pPr algn="l">
-              <a:lnSpc>
-                <a:spcPct val="118000"/>
-              </a:lnSpc>
-              <a:spcAft>
-                <a:spcPts val="400"/>
-              </a:spcAft>
-            </a:pPr>
-            <a:r>
-              <a:rPr sz="1300" b="0">
-                <a:solidFill>
-                  <a:srgbClr val="FFFFFF"/>
-                </a:solidFill>
-                <a:latin typeface="微软雅黑"/>
-                <a:ea typeface="微软雅黑"/>
-              </a:rPr>
-              <a:t>xuancha@mail.zjgsu.edu.cn</a:t>
-            </a:r>
-          </a:p>
-          <a:p>
-            <a:pPr algn="l">
-              <a:lnSpc>
-                <a:spcPct val="118000"/>
-              </a:lnSpc>
-              <a:spcAft>
-                <a:spcPts val="0"/>
-              </a:spcAft>
-            </a:pPr>
-            <a:r>
-              <a:rPr sz="1300" b="0">
+              <a:rPr sz="1200" b="0">
                 <a:solidFill>
                   <a:srgbClr val="C5D6E6"/>
                 </a:solidFill>

</xml_diff>